<commit_message>
added shell customization to cmdline_tips
</commit_message>
<xml_diff>
--- a/cmd-line-101/cmdline_tips_draft.pptx
+++ b/cmd-line-101/cmdline_tips_draft.pptx
@@ -18,6 +18,11 @@
     <p:sldId id="263" r:id="rId12"/>
     <p:sldId id="264" r:id="rId13"/>
     <p:sldId id="265" r:id="rId14"/>
+    <p:sldId id="270" r:id="rId15"/>
+    <p:sldId id="269" r:id="rId16"/>
+    <p:sldId id="271" r:id="rId17"/>
+    <p:sldId id="272" r:id="rId18"/>
+    <p:sldId id="273" r:id="rId19"/>
   </p:sldIdLst>
   <p:sldSz cx="12192000" cy="6858000"/>
   <p:notesSz cx="6858000" cy="9144000"/>
@@ -116,6 +121,11 @@
       </a:defRPr>
     </a:lvl9pPr>
   </p:defaultTextStyle>
+  <p:extLst>
+    <p:ext uri="{EFAFB233-063F-42B5-8137-9DF3F51BA10A}">
+      <p15:sldGuideLst xmlns:p15="http://schemas.microsoft.com/office/powerpoint/2012/main"/>
+    </p:ext>
+  </p:extLst>
 </p:presentation>
 </file>
 
@@ -266,7 +276,7 @@
           <a:p>
             <a:fld id="{A686B4F0-C34F-B24F-B974-1303EBE688C1}" type="datetimeFigureOut">
               <a:rPr lang="en-US" smtClean="0"/>
-              <a:t>1/30/26</a:t>
+              <a:t>2/2/26</a:t>
             </a:fld>
             <a:endParaRPr lang="en-US"/>
           </a:p>
@@ -464,7 +474,7 @@
           <a:p>
             <a:fld id="{A686B4F0-C34F-B24F-B974-1303EBE688C1}" type="datetimeFigureOut">
               <a:rPr lang="en-US" smtClean="0"/>
-              <a:t>1/30/26</a:t>
+              <a:t>2/2/26</a:t>
             </a:fld>
             <a:endParaRPr lang="en-US"/>
           </a:p>
@@ -672,7 +682,7 @@
           <a:p>
             <a:fld id="{A686B4F0-C34F-B24F-B974-1303EBE688C1}" type="datetimeFigureOut">
               <a:rPr lang="en-US" smtClean="0"/>
-              <a:t>1/30/26</a:t>
+              <a:t>2/2/26</a:t>
             </a:fld>
             <a:endParaRPr lang="en-US"/>
           </a:p>
@@ -870,7 +880,7 @@
           <a:p>
             <a:fld id="{A686B4F0-C34F-B24F-B974-1303EBE688C1}" type="datetimeFigureOut">
               <a:rPr lang="en-US" smtClean="0"/>
-              <a:t>1/30/26</a:t>
+              <a:t>2/2/26</a:t>
             </a:fld>
             <a:endParaRPr lang="en-US"/>
           </a:p>
@@ -1145,7 +1155,7 @@
           <a:p>
             <a:fld id="{A686B4F0-C34F-B24F-B974-1303EBE688C1}" type="datetimeFigureOut">
               <a:rPr lang="en-US" smtClean="0"/>
-              <a:t>1/30/26</a:t>
+              <a:t>2/2/26</a:t>
             </a:fld>
             <a:endParaRPr lang="en-US"/>
           </a:p>
@@ -1410,7 +1420,7 @@
           <a:p>
             <a:fld id="{A686B4F0-C34F-B24F-B974-1303EBE688C1}" type="datetimeFigureOut">
               <a:rPr lang="en-US" smtClean="0"/>
-              <a:t>1/30/26</a:t>
+              <a:t>2/2/26</a:t>
             </a:fld>
             <a:endParaRPr lang="en-US"/>
           </a:p>
@@ -1822,7 +1832,7 @@
           <a:p>
             <a:fld id="{A686B4F0-C34F-B24F-B974-1303EBE688C1}" type="datetimeFigureOut">
               <a:rPr lang="en-US" smtClean="0"/>
-              <a:t>1/30/26</a:t>
+              <a:t>2/2/26</a:t>
             </a:fld>
             <a:endParaRPr lang="en-US"/>
           </a:p>
@@ -1963,7 +1973,7 @@
           <a:p>
             <a:fld id="{A686B4F0-C34F-B24F-B974-1303EBE688C1}" type="datetimeFigureOut">
               <a:rPr lang="en-US" smtClean="0"/>
-              <a:t>1/30/26</a:t>
+              <a:t>2/2/26</a:t>
             </a:fld>
             <a:endParaRPr lang="en-US"/>
           </a:p>
@@ -2076,7 +2086,7 @@
           <a:p>
             <a:fld id="{A686B4F0-C34F-B24F-B974-1303EBE688C1}" type="datetimeFigureOut">
               <a:rPr lang="en-US" smtClean="0"/>
-              <a:t>1/30/26</a:t>
+              <a:t>2/2/26</a:t>
             </a:fld>
             <a:endParaRPr lang="en-US"/>
           </a:p>
@@ -2387,7 +2397,7 @@
           <a:p>
             <a:fld id="{A686B4F0-C34F-B24F-B974-1303EBE688C1}" type="datetimeFigureOut">
               <a:rPr lang="en-US" smtClean="0"/>
-              <a:t>1/30/26</a:t>
+              <a:t>2/2/26</a:t>
             </a:fld>
             <a:endParaRPr lang="en-US"/>
           </a:p>
@@ -2675,7 +2685,7 @@
           <a:p>
             <a:fld id="{A686B4F0-C34F-B24F-B974-1303EBE688C1}" type="datetimeFigureOut">
               <a:rPr lang="en-US" smtClean="0"/>
-              <a:t>1/30/26</a:t>
+              <a:t>2/2/26</a:t>
             </a:fld>
             <a:endParaRPr lang="en-US"/>
           </a:p>
@@ -2916,7 +2926,7 @@
           <a:p>
             <a:fld id="{A686B4F0-C34F-B24F-B974-1303EBE688C1}" type="datetimeFigureOut">
               <a:rPr lang="en-US" smtClean="0"/>
-              <a:t>1/30/26</a:t>
+              <a:t>2/2/26</a:t>
             </a:fld>
             <a:endParaRPr lang="en-US"/>
           </a:p>
@@ -3851,12 +3861,1271 @@
               <a:t>`</a:t>
             </a:r>
           </a:p>
+          <a:p>
+            <a:pPr lvl="1"/>
+            <a:r>
+              <a:rPr lang="en-US" dirty="0"/>
+              <a:t>Both are startup config files, usually in your home `~` directory</a:t>
+            </a:r>
+          </a:p>
+          <a:p>
+            <a:r>
+              <a:rPr lang="en-US" dirty="0"/>
+              <a:t>`.</a:t>
+            </a:r>
+            <a:r>
+              <a:rPr lang="en-US" dirty="0" err="1"/>
+              <a:t>bash_profile</a:t>
+            </a:r>
+            <a:r>
+              <a:rPr lang="en-US" dirty="0"/>
+              <a:t>` is run only once, upon login</a:t>
+            </a:r>
+          </a:p>
+          <a:p>
+            <a:pPr lvl="1"/>
+            <a:r>
+              <a:rPr lang="en-US" dirty="0"/>
+              <a:t>Sources the `.</a:t>
+            </a:r>
+            <a:r>
+              <a:rPr lang="en-US" dirty="0" err="1"/>
+              <a:t>bashrc</a:t>
+            </a:r>
+            <a:r>
+              <a:rPr lang="en-US" dirty="0"/>
+              <a:t>` file (won’t do so otherwise!)</a:t>
+            </a:r>
+          </a:p>
+          <a:p>
+            <a:pPr lvl="1"/>
+            <a:r>
+              <a:rPr lang="en-US" i="1" dirty="0"/>
+              <a:t>Generally, this is all you want in here</a:t>
+            </a:r>
+          </a:p>
+          <a:p>
+            <a:r>
+              <a:rPr lang="en-US" dirty="0"/>
+              <a:t>`.</a:t>
+            </a:r>
+            <a:r>
+              <a:rPr lang="en-US" dirty="0" err="1"/>
+              <a:t>bashrc`is</a:t>
+            </a:r>
+            <a:r>
+              <a:rPr lang="en-US" dirty="0"/>
+              <a:t> read anytime a shell is opened (assuming it has been sourced)</a:t>
+            </a:r>
+          </a:p>
+          <a:p>
+            <a:pPr lvl="1"/>
+            <a:r>
+              <a:rPr lang="en-US" dirty="0"/>
+              <a:t>E.g. if you connect to an interactive node after logging in using `</a:t>
+            </a:r>
+            <a:r>
+              <a:rPr lang="en-US" dirty="0" err="1"/>
+              <a:t>salloc</a:t>
+            </a:r>
+            <a:r>
+              <a:rPr lang="en-US" dirty="0"/>
+              <a:t>`</a:t>
+            </a:r>
+          </a:p>
+          <a:p>
+            <a:pPr lvl="1"/>
+            <a:r>
+              <a:rPr lang="en-US" i="1" dirty="0"/>
+              <a:t>TL;DR when using Cannon, put your customizations in here</a:t>
+            </a:r>
+          </a:p>
         </p:txBody>
       </p:sp>
     </p:spTree>
     <p:extLst>
       <p:ext uri="{BB962C8B-B14F-4D97-AF65-F5344CB8AC3E}">
         <p14:creationId xmlns:p14="http://schemas.microsoft.com/office/powerpoint/2010/main" val="1131102732"/>
+      </p:ext>
+    </p:extLst>
+  </p:cSld>
+  <p:clrMapOvr>
+    <a:masterClrMapping/>
+  </p:clrMapOvr>
+</p:sld>
+</file>
+
+<file path=ppt/slides/slide14.xml><?xml version="1.0" encoding="utf-8"?>
+<p:sld xmlns:a="http://schemas.openxmlformats.org/drawingml/2006/main" xmlns:r="http://schemas.openxmlformats.org/officeDocument/2006/relationships" xmlns:p="http://schemas.openxmlformats.org/presentationml/2006/main">
+  <p:cSld>
+    <p:spTree>
+      <p:nvGrpSpPr>
+        <p:cNvPr id="1" name="">
+          <a:extLst>
+            <a:ext uri="{FF2B5EF4-FFF2-40B4-BE49-F238E27FC236}">
+              <a16:creationId xmlns:a16="http://schemas.microsoft.com/office/drawing/2014/main" id="{3DB7EF5E-D0DA-B7BE-8547-7868AFB24833}"/>
+            </a:ext>
+          </a:extLst>
+        </p:cNvPr>
+        <p:cNvGrpSpPr/>
+        <p:nvPr/>
+      </p:nvGrpSpPr>
+      <p:grpSpPr>
+        <a:xfrm>
+          <a:off x="0" y="0"/>
+          <a:ext cx="0" cy="0"/>
+          <a:chOff x="0" y="0"/>
+          <a:chExt cx="0" cy="0"/>
+        </a:xfrm>
+      </p:grpSpPr>
+      <p:sp>
+        <p:nvSpPr>
+          <p:cNvPr id="2" name="Title 1">
+            <a:extLst>
+              <a:ext uri="{FF2B5EF4-FFF2-40B4-BE49-F238E27FC236}">
+                <a16:creationId xmlns:a16="http://schemas.microsoft.com/office/drawing/2014/main" id="{EC652586-096C-0A07-A743-DF789D9A4145}"/>
+              </a:ext>
+            </a:extLst>
+          </p:cNvPr>
+          <p:cNvSpPr>
+            <a:spLocks noGrp="1"/>
+          </p:cNvSpPr>
+          <p:nvPr>
+            <p:ph type="title"/>
+          </p:nvPr>
+        </p:nvSpPr>
+        <p:spPr/>
+        <p:txBody>
+          <a:bodyPr/>
+          <a:lstStyle/>
+          <a:p>
+            <a:r>
+              <a:rPr lang="en-US" dirty="0"/>
+              <a:t>Customizing your bash shell</a:t>
+            </a:r>
+          </a:p>
+        </p:txBody>
+      </p:sp>
+      <p:sp>
+        <p:nvSpPr>
+          <p:cNvPr id="3" name="Content Placeholder 2">
+            <a:extLst>
+              <a:ext uri="{FF2B5EF4-FFF2-40B4-BE49-F238E27FC236}">
+                <a16:creationId xmlns:a16="http://schemas.microsoft.com/office/drawing/2014/main" id="{4943C8EA-BA6F-A752-DE23-7D27B817E02A}"/>
+              </a:ext>
+            </a:extLst>
+          </p:cNvPr>
+          <p:cNvSpPr>
+            <a:spLocks noGrp="1"/>
+          </p:cNvSpPr>
+          <p:nvPr>
+            <p:ph idx="1"/>
+          </p:nvPr>
+        </p:nvSpPr>
+        <p:spPr/>
+        <p:txBody>
+          <a:bodyPr/>
+          <a:lstStyle/>
+          <a:p>
+            <a:r>
+              <a:rPr lang="en-US" dirty="0"/>
+              <a:t>Let’s have a look at what a `.</a:t>
+            </a:r>
+            <a:r>
+              <a:rPr lang="en-US" dirty="0" err="1"/>
+              <a:t>bashrc</a:t>
+            </a:r>
+            <a:r>
+              <a:rPr lang="en-US" dirty="0"/>
+              <a:t>` profile looks like on Cannon</a:t>
+            </a:r>
+          </a:p>
+          <a:p>
+            <a:pPr lvl="1"/>
+            <a:r>
+              <a:rPr lang="en-US" dirty="0"/>
+              <a:t>Will be run whenever you log in, by any jobs you submit or create a new shell</a:t>
+            </a:r>
+          </a:p>
+          <a:p>
+            <a:pPr lvl="1"/>
+            <a:r>
+              <a:rPr lang="en-US" dirty="0"/>
+              <a:t>The ‘global definitions’ section sources cluster-wide definitions, allows jobs to run properly</a:t>
+            </a:r>
+          </a:p>
+          <a:p>
+            <a:pPr lvl="2"/>
+            <a:r>
+              <a:rPr lang="en-US" dirty="0"/>
+              <a:t>Don’t modify this part!!</a:t>
+            </a:r>
+          </a:p>
+          <a:p>
+            <a:pPr lvl="1"/>
+            <a:r>
+              <a:rPr lang="en-US" dirty="0"/>
+              <a:t>Customization goes under the ‘user specific’ section</a:t>
+            </a:r>
+          </a:p>
+          <a:p>
+            <a:pPr lvl="1"/>
+            <a:endParaRPr lang="en-US" dirty="0"/>
+          </a:p>
+        </p:txBody>
+      </p:sp>
+      <p:sp>
+        <p:nvSpPr>
+          <p:cNvPr id="4" name="TextBox 3">
+            <a:extLst>
+              <a:ext uri="{FF2B5EF4-FFF2-40B4-BE49-F238E27FC236}">
+                <a16:creationId xmlns:a16="http://schemas.microsoft.com/office/drawing/2014/main" id="{C9B3809E-0484-1E6E-0E41-2A966292693E}"/>
+              </a:ext>
+            </a:extLst>
+          </p:cNvPr>
+          <p:cNvSpPr txBox="1"/>
+          <p:nvPr/>
+        </p:nvSpPr>
+        <p:spPr>
+          <a:xfrm>
+            <a:off x="2956193" y="4629838"/>
+            <a:ext cx="6279614" cy="2031325"/>
+          </a:xfrm>
+          <a:prstGeom prst="rect">
+            <a:avLst/>
+          </a:prstGeom>
+          <a:noFill/>
+        </p:spPr>
+        <p:txBody>
+          <a:bodyPr wrap="square" rtlCol="0">
+            <a:spAutoFit/>
+          </a:bodyPr>
+          <a:lstStyle/>
+          <a:p>
+            <a:r>
+              <a:rPr lang="en-US" dirty="0"/>
+              <a:t># .</a:t>
+            </a:r>
+            <a:r>
+              <a:rPr lang="en-US" dirty="0" err="1"/>
+              <a:t>bashrc</a:t>
+            </a:r>
+            <a:endParaRPr lang="en-US" dirty="0"/>
+          </a:p>
+          <a:p>
+            <a:r>
+              <a:rPr lang="en-US" dirty="0"/>
+              <a:t># Source global definitions</a:t>
+            </a:r>
+          </a:p>
+          <a:p>
+            <a:r>
+              <a:rPr lang="en-US" dirty="0"/>
+              <a:t>if [ -f /</a:t>
+            </a:r>
+            <a:r>
+              <a:rPr lang="en-US" dirty="0" err="1"/>
+              <a:t>etc</a:t>
+            </a:r>
+            <a:r>
+              <a:rPr lang="en-US" dirty="0"/>
+              <a:t>/</a:t>
+            </a:r>
+            <a:r>
+              <a:rPr lang="en-US" dirty="0" err="1"/>
+              <a:t>bashrc</a:t>
+            </a:r>
+            <a:r>
+              <a:rPr lang="en-US" dirty="0"/>
+              <a:t> ]; then</a:t>
+            </a:r>
+          </a:p>
+          <a:p>
+            <a:r>
+              <a:rPr lang="en-US" dirty="0"/>
+              <a:t>. /</a:t>
+            </a:r>
+            <a:r>
+              <a:rPr lang="en-US" dirty="0" err="1"/>
+              <a:t>etc</a:t>
+            </a:r>
+            <a:r>
+              <a:rPr lang="en-US" dirty="0"/>
+              <a:t>/</a:t>
+            </a:r>
+            <a:r>
+              <a:rPr lang="en-US" dirty="0" err="1"/>
+              <a:t>bashrc</a:t>
+            </a:r>
+            <a:endParaRPr lang="en-US" dirty="0"/>
+          </a:p>
+          <a:p>
+            <a:r>
+              <a:rPr lang="en-US" dirty="0"/>
+              <a:t>fi</a:t>
+            </a:r>
+          </a:p>
+          <a:p>
+            <a:r>
+              <a:rPr lang="en-US" dirty="0"/>
+              <a:t># User specific aliases and functions</a:t>
+            </a:r>
+          </a:p>
+          <a:p>
+            <a:endParaRPr lang="en-US" dirty="0"/>
+          </a:p>
+        </p:txBody>
+      </p:sp>
+    </p:spTree>
+    <p:extLst>
+      <p:ext uri="{BB962C8B-B14F-4D97-AF65-F5344CB8AC3E}">
+        <p14:creationId xmlns:p14="http://schemas.microsoft.com/office/powerpoint/2010/main" val="1946170520"/>
+      </p:ext>
+    </p:extLst>
+  </p:cSld>
+  <p:clrMapOvr>
+    <a:masterClrMapping/>
+  </p:clrMapOvr>
+</p:sld>
+</file>
+
+<file path=ppt/slides/slide15.xml><?xml version="1.0" encoding="utf-8"?>
+<p:sld xmlns:a="http://schemas.openxmlformats.org/drawingml/2006/main" xmlns:r="http://schemas.openxmlformats.org/officeDocument/2006/relationships" xmlns:p="http://schemas.openxmlformats.org/presentationml/2006/main">
+  <p:cSld>
+    <p:spTree>
+      <p:nvGrpSpPr>
+        <p:cNvPr id="1" name="">
+          <a:extLst>
+            <a:ext uri="{FF2B5EF4-FFF2-40B4-BE49-F238E27FC236}">
+              <a16:creationId xmlns:a16="http://schemas.microsoft.com/office/drawing/2014/main" id="{D80C01A9-26CC-BF0E-12F5-3B46B29C8847}"/>
+            </a:ext>
+          </a:extLst>
+        </p:cNvPr>
+        <p:cNvGrpSpPr/>
+        <p:nvPr/>
+      </p:nvGrpSpPr>
+      <p:grpSpPr>
+        <a:xfrm>
+          <a:off x="0" y="0"/>
+          <a:ext cx="0" cy="0"/>
+          <a:chOff x="0" y="0"/>
+          <a:chExt cx="0" cy="0"/>
+        </a:xfrm>
+      </p:grpSpPr>
+      <p:sp>
+        <p:nvSpPr>
+          <p:cNvPr id="2" name="Title 1">
+            <a:extLst>
+              <a:ext uri="{FF2B5EF4-FFF2-40B4-BE49-F238E27FC236}">
+                <a16:creationId xmlns:a16="http://schemas.microsoft.com/office/drawing/2014/main" id="{050CFBB0-7D40-55E5-725A-9BBCABBA9698}"/>
+              </a:ext>
+            </a:extLst>
+          </p:cNvPr>
+          <p:cNvSpPr>
+            <a:spLocks noGrp="1"/>
+          </p:cNvSpPr>
+          <p:nvPr>
+            <p:ph type="title"/>
+          </p:nvPr>
+        </p:nvSpPr>
+        <p:spPr/>
+        <p:txBody>
+          <a:bodyPr/>
+          <a:lstStyle/>
+          <a:p>
+            <a:r>
+              <a:rPr lang="en-US" dirty="0"/>
+              <a:t>Customizing your bash shell</a:t>
+            </a:r>
+          </a:p>
+        </p:txBody>
+      </p:sp>
+      <p:sp>
+        <p:nvSpPr>
+          <p:cNvPr id="3" name="Content Placeholder 2">
+            <a:extLst>
+              <a:ext uri="{FF2B5EF4-FFF2-40B4-BE49-F238E27FC236}">
+                <a16:creationId xmlns:a16="http://schemas.microsoft.com/office/drawing/2014/main" id="{BFE598A9-5BFD-4D95-3B54-00CCEF9B412A}"/>
+              </a:ext>
+            </a:extLst>
+          </p:cNvPr>
+          <p:cNvSpPr>
+            <a:spLocks noGrp="1"/>
+          </p:cNvSpPr>
+          <p:nvPr>
+            <p:ph idx="1"/>
+          </p:nvPr>
+        </p:nvSpPr>
+        <p:spPr/>
+        <p:txBody>
+          <a:bodyPr/>
+          <a:lstStyle/>
+          <a:p>
+            <a:r>
+              <a:rPr lang="en-US" dirty="0"/>
+              <a:t>On the Cannon cluster, say there are several modules you commonly use</a:t>
+            </a:r>
+          </a:p>
+          <a:p>
+            <a:r>
+              <a:rPr lang="en-US" dirty="0"/>
+              <a:t>You could append `module load` statements to `.</a:t>
+            </a:r>
+            <a:r>
+              <a:rPr lang="en-US" dirty="0" err="1"/>
+              <a:t>bashrc</a:t>
+            </a:r>
+            <a:r>
+              <a:rPr lang="en-US" dirty="0"/>
+              <a:t>`:</a:t>
+            </a:r>
+          </a:p>
+        </p:txBody>
+      </p:sp>
+      <p:sp>
+        <p:nvSpPr>
+          <p:cNvPr id="4" name="TextBox 3">
+            <a:extLst>
+              <a:ext uri="{FF2B5EF4-FFF2-40B4-BE49-F238E27FC236}">
+                <a16:creationId xmlns:a16="http://schemas.microsoft.com/office/drawing/2014/main" id="{1AD2BB00-CE2A-330B-CD14-D11D3A97855D}"/>
+              </a:ext>
+            </a:extLst>
+          </p:cNvPr>
+          <p:cNvSpPr txBox="1"/>
+          <p:nvPr/>
+        </p:nvSpPr>
+        <p:spPr>
+          <a:xfrm>
+            <a:off x="1837980" y="3349128"/>
+            <a:ext cx="8516039" cy="2585323"/>
+          </a:xfrm>
+          <a:prstGeom prst="rect">
+            <a:avLst/>
+          </a:prstGeom>
+          <a:noFill/>
+        </p:spPr>
+        <p:txBody>
+          <a:bodyPr wrap="square" rtlCol="0">
+            <a:spAutoFit/>
+          </a:bodyPr>
+          <a:lstStyle/>
+          <a:p>
+            <a:r>
+              <a:rPr lang="en-US" dirty="0"/>
+              <a:t># .</a:t>
+            </a:r>
+            <a:r>
+              <a:rPr lang="en-US" dirty="0" err="1"/>
+              <a:t>bashrc</a:t>
+            </a:r>
+            <a:endParaRPr lang="en-US" dirty="0"/>
+          </a:p>
+          <a:p>
+            <a:r>
+              <a:rPr lang="en-US" dirty="0"/>
+              <a:t># Source global definitions</a:t>
+            </a:r>
+          </a:p>
+          <a:p>
+            <a:r>
+              <a:rPr lang="en-US" dirty="0"/>
+              <a:t>if [ -f /</a:t>
+            </a:r>
+            <a:r>
+              <a:rPr lang="en-US" dirty="0" err="1"/>
+              <a:t>etc</a:t>
+            </a:r>
+            <a:r>
+              <a:rPr lang="en-US" dirty="0"/>
+              <a:t>/</a:t>
+            </a:r>
+            <a:r>
+              <a:rPr lang="en-US" dirty="0" err="1"/>
+              <a:t>bashrc</a:t>
+            </a:r>
+            <a:r>
+              <a:rPr lang="en-US" dirty="0"/>
+              <a:t> ]; then</a:t>
+            </a:r>
+          </a:p>
+          <a:p>
+            <a:r>
+              <a:rPr lang="en-US" dirty="0"/>
+              <a:t>. /</a:t>
+            </a:r>
+            <a:r>
+              <a:rPr lang="en-US" dirty="0" err="1"/>
+              <a:t>etc</a:t>
+            </a:r>
+            <a:r>
+              <a:rPr lang="en-US" dirty="0"/>
+              <a:t>/</a:t>
+            </a:r>
+            <a:r>
+              <a:rPr lang="en-US" dirty="0" err="1"/>
+              <a:t>bashrc</a:t>
+            </a:r>
+            <a:endParaRPr lang="en-US" dirty="0"/>
+          </a:p>
+          <a:p>
+            <a:r>
+              <a:rPr lang="en-US" dirty="0"/>
+              <a:t>fi</a:t>
+            </a:r>
+          </a:p>
+          <a:p>
+            <a:r>
+              <a:rPr lang="en-US" dirty="0"/>
+              <a:t># User specific aliases and functions</a:t>
+            </a:r>
+          </a:p>
+          <a:p>
+            <a:r>
+              <a:rPr lang="en-US" dirty="0"/>
+              <a:t>module load </a:t>
+            </a:r>
+            <a:r>
+              <a:rPr lang="en-US" dirty="0" err="1"/>
+              <a:t>jdk</a:t>
+            </a:r>
+            <a:endParaRPr lang="en-US" dirty="0"/>
+          </a:p>
+          <a:p>
+            <a:r>
+              <a:rPr lang="en-US" dirty="0"/>
+              <a:t>module load python</a:t>
+            </a:r>
+          </a:p>
+          <a:p>
+            <a:endParaRPr lang="en-US" dirty="0"/>
+          </a:p>
+        </p:txBody>
+      </p:sp>
+    </p:spTree>
+    <p:extLst>
+      <p:ext uri="{BB962C8B-B14F-4D97-AF65-F5344CB8AC3E}">
+        <p14:creationId xmlns:p14="http://schemas.microsoft.com/office/powerpoint/2010/main" val="1861293206"/>
+      </p:ext>
+    </p:extLst>
+  </p:cSld>
+  <p:clrMapOvr>
+    <a:masterClrMapping/>
+  </p:clrMapOvr>
+</p:sld>
+</file>
+
+<file path=ppt/slides/slide16.xml><?xml version="1.0" encoding="utf-8"?>
+<p:sld xmlns:a="http://schemas.openxmlformats.org/drawingml/2006/main" xmlns:r="http://schemas.openxmlformats.org/officeDocument/2006/relationships" xmlns:p="http://schemas.openxmlformats.org/presentationml/2006/main">
+  <p:cSld>
+    <p:spTree>
+      <p:nvGrpSpPr>
+        <p:cNvPr id="1" name="">
+          <a:extLst>
+            <a:ext uri="{FF2B5EF4-FFF2-40B4-BE49-F238E27FC236}">
+              <a16:creationId xmlns:a16="http://schemas.microsoft.com/office/drawing/2014/main" id="{924B8DB0-F9BD-F545-26A6-A77857811595}"/>
+            </a:ext>
+          </a:extLst>
+        </p:cNvPr>
+        <p:cNvGrpSpPr/>
+        <p:nvPr/>
+      </p:nvGrpSpPr>
+      <p:grpSpPr>
+        <a:xfrm>
+          <a:off x="0" y="0"/>
+          <a:ext cx="0" cy="0"/>
+          <a:chOff x="0" y="0"/>
+          <a:chExt cx="0" cy="0"/>
+        </a:xfrm>
+      </p:grpSpPr>
+      <p:sp>
+        <p:nvSpPr>
+          <p:cNvPr id="2" name="Title 1">
+            <a:extLst>
+              <a:ext uri="{FF2B5EF4-FFF2-40B4-BE49-F238E27FC236}">
+                <a16:creationId xmlns:a16="http://schemas.microsoft.com/office/drawing/2014/main" id="{42AF2313-8047-7AB7-1FF7-A88DA78D659D}"/>
+              </a:ext>
+            </a:extLst>
+          </p:cNvPr>
+          <p:cNvSpPr>
+            <a:spLocks noGrp="1"/>
+          </p:cNvSpPr>
+          <p:nvPr>
+            <p:ph type="title"/>
+          </p:nvPr>
+        </p:nvSpPr>
+        <p:spPr/>
+        <p:txBody>
+          <a:bodyPr/>
+          <a:lstStyle/>
+          <a:p>
+            <a:r>
+              <a:rPr lang="en-US" dirty="0"/>
+              <a:t>Customizing your bash shell</a:t>
+            </a:r>
+          </a:p>
+        </p:txBody>
+      </p:sp>
+      <p:sp>
+        <p:nvSpPr>
+          <p:cNvPr id="3" name="Content Placeholder 2">
+            <a:extLst>
+              <a:ext uri="{FF2B5EF4-FFF2-40B4-BE49-F238E27FC236}">
+                <a16:creationId xmlns:a16="http://schemas.microsoft.com/office/drawing/2014/main" id="{2E918526-8ED1-E162-203C-0AACB5483B26}"/>
+              </a:ext>
+            </a:extLst>
+          </p:cNvPr>
+          <p:cNvSpPr>
+            <a:spLocks noGrp="1"/>
+          </p:cNvSpPr>
+          <p:nvPr>
+            <p:ph idx="1"/>
+          </p:nvPr>
+        </p:nvSpPr>
+        <p:spPr/>
+        <p:txBody>
+          <a:bodyPr/>
+          <a:lstStyle/>
+          <a:p>
+            <a:r>
+              <a:rPr lang="en-US" dirty="0"/>
+              <a:t>However, it is better practice to instead use a </a:t>
+            </a:r>
+            <a:r>
+              <a:rPr lang="en-US" i="1" dirty="0"/>
+              <a:t>shell function</a:t>
+            </a:r>
+          </a:p>
+          <a:p>
+            <a:r>
+              <a:rPr lang="en-US" dirty="0"/>
+              <a:t>In your `.</a:t>
+            </a:r>
+            <a:r>
+              <a:rPr lang="en-US" dirty="0" err="1"/>
+              <a:t>bashrc</a:t>
+            </a:r>
+            <a:r>
+              <a:rPr lang="en-US" dirty="0"/>
+              <a:t>` we can add a custom function `</a:t>
+            </a:r>
+            <a:r>
+              <a:rPr lang="en-US" dirty="0" err="1"/>
+              <a:t>mymodules</a:t>
+            </a:r>
+            <a:r>
+              <a:rPr lang="en-US" dirty="0"/>
+              <a:t>`:</a:t>
+            </a:r>
+          </a:p>
+          <a:p>
+            <a:pPr lvl="1"/>
+            <a:r>
+              <a:rPr lang="en-US" dirty="0"/>
+              <a:t>Can type `</a:t>
+            </a:r>
+            <a:r>
+              <a:rPr lang="en-US" dirty="0" err="1"/>
+              <a:t>mymodules</a:t>
+            </a:r>
+            <a:r>
+              <a:rPr lang="en-US" dirty="0"/>
+              <a:t>` to run the function and load the listed modules</a:t>
+            </a:r>
+          </a:p>
+        </p:txBody>
+      </p:sp>
+      <p:sp>
+        <p:nvSpPr>
+          <p:cNvPr id="4" name="TextBox 3">
+            <a:extLst>
+              <a:ext uri="{FF2B5EF4-FFF2-40B4-BE49-F238E27FC236}">
+                <a16:creationId xmlns:a16="http://schemas.microsoft.com/office/drawing/2014/main" id="{D787EF2D-DB4B-8E13-047F-FE9D1384D8C4}"/>
+              </a:ext>
+            </a:extLst>
+          </p:cNvPr>
+          <p:cNvSpPr txBox="1"/>
+          <p:nvPr/>
+        </p:nvSpPr>
+        <p:spPr>
+          <a:xfrm>
+            <a:off x="2610999" y="3429000"/>
+            <a:ext cx="6279614" cy="3139321"/>
+          </a:xfrm>
+          <a:prstGeom prst="rect">
+            <a:avLst/>
+          </a:prstGeom>
+          <a:noFill/>
+        </p:spPr>
+        <p:txBody>
+          <a:bodyPr wrap="square" rtlCol="0">
+            <a:spAutoFit/>
+          </a:bodyPr>
+          <a:lstStyle/>
+          <a:p>
+            <a:r>
+              <a:rPr lang="en-US" dirty="0"/>
+              <a:t># .</a:t>
+            </a:r>
+            <a:r>
+              <a:rPr lang="en-US" dirty="0" err="1"/>
+              <a:t>bashrc</a:t>
+            </a:r>
+            <a:endParaRPr lang="en-US" dirty="0"/>
+          </a:p>
+          <a:p>
+            <a:r>
+              <a:rPr lang="en-US" dirty="0"/>
+              <a:t># Source global definitions</a:t>
+            </a:r>
+          </a:p>
+          <a:p>
+            <a:r>
+              <a:rPr lang="en-US" dirty="0"/>
+              <a:t>if [ -f /</a:t>
+            </a:r>
+            <a:r>
+              <a:rPr lang="en-US" dirty="0" err="1"/>
+              <a:t>etc</a:t>
+            </a:r>
+            <a:r>
+              <a:rPr lang="en-US" dirty="0"/>
+              <a:t>/</a:t>
+            </a:r>
+            <a:r>
+              <a:rPr lang="en-US" dirty="0" err="1"/>
+              <a:t>bashrc</a:t>
+            </a:r>
+            <a:r>
+              <a:rPr lang="en-US" dirty="0"/>
+              <a:t> ]; then</a:t>
+            </a:r>
+          </a:p>
+          <a:p>
+            <a:r>
+              <a:rPr lang="en-US" dirty="0"/>
+              <a:t>. /</a:t>
+            </a:r>
+            <a:r>
+              <a:rPr lang="en-US" dirty="0" err="1"/>
+              <a:t>etc</a:t>
+            </a:r>
+            <a:r>
+              <a:rPr lang="en-US" dirty="0"/>
+              <a:t>/</a:t>
+            </a:r>
+            <a:r>
+              <a:rPr lang="en-US" dirty="0" err="1"/>
+              <a:t>bashrc</a:t>
+            </a:r>
+            <a:endParaRPr lang="en-US" dirty="0"/>
+          </a:p>
+          <a:p>
+            <a:r>
+              <a:rPr lang="en-US" dirty="0"/>
+              <a:t>fi</a:t>
+            </a:r>
+          </a:p>
+          <a:p>
+            <a:r>
+              <a:rPr lang="en-US" dirty="0"/>
+              <a:t># User specific aliases and functions</a:t>
+            </a:r>
+          </a:p>
+          <a:p>
+            <a:r>
+              <a:rPr lang="en-US" dirty="0"/>
+              <a:t>function </a:t>
+            </a:r>
+            <a:r>
+              <a:rPr lang="en-US" dirty="0" err="1"/>
+              <a:t>mymodules</a:t>
+            </a:r>
+            <a:r>
+              <a:rPr lang="en-US" dirty="0"/>
+              <a:t> {</a:t>
+            </a:r>
+            <a:br>
+              <a:rPr lang="en-US" dirty="0"/>
+            </a:br>
+            <a:r>
+              <a:rPr lang="en-US" dirty="0"/>
+              <a:t>    module load </a:t>
+            </a:r>
+            <a:r>
+              <a:rPr lang="en-US" dirty="0" err="1"/>
+              <a:t>jdk</a:t>
+            </a:r>
+            <a:br>
+              <a:rPr lang="en-US" dirty="0"/>
+            </a:br>
+            <a:r>
+              <a:rPr lang="en-US" dirty="0"/>
+              <a:t>     module load python</a:t>
+            </a:r>
+            <a:br>
+              <a:rPr lang="en-US" dirty="0"/>
+            </a:br>
+            <a:r>
+              <a:rPr lang="en-US" dirty="0"/>
+              <a:t>}</a:t>
+            </a:r>
+          </a:p>
+          <a:p>
+            <a:endParaRPr lang="en-US" dirty="0"/>
+          </a:p>
+        </p:txBody>
+      </p:sp>
+    </p:spTree>
+    <p:extLst>
+      <p:ext uri="{BB962C8B-B14F-4D97-AF65-F5344CB8AC3E}">
+        <p14:creationId xmlns:p14="http://schemas.microsoft.com/office/powerpoint/2010/main" val="463845319"/>
+      </p:ext>
+    </p:extLst>
+  </p:cSld>
+  <p:clrMapOvr>
+    <a:masterClrMapping/>
+  </p:clrMapOvr>
+</p:sld>
+</file>
+
+<file path=ppt/slides/slide17.xml><?xml version="1.0" encoding="utf-8"?>
+<p:sld xmlns:a="http://schemas.openxmlformats.org/drawingml/2006/main" xmlns:r="http://schemas.openxmlformats.org/officeDocument/2006/relationships" xmlns:p="http://schemas.openxmlformats.org/presentationml/2006/main">
+  <p:cSld>
+    <p:spTree>
+      <p:nvGrpSpPr>
+        <p:cNvPr id="1" name="">
+          <a:extLst>
+            <a:ext uri="{FF2B5EF4-FFF2-40B4-BE49-F238E27FC236}">
+              <a16:creationId xmlns:a16="http://schemas.microsoft.com/office/drawing/2014/main" id="{DCF69CC8-603A-8941-0C2D-02A5A4028BFE}"/>
+            </a:ext>
+          </a:extLst>
+        </p:cNvPr>
+        <p:cNvGrpSpPr/>
+        <p:nvPr/>
+      </p:nvGrpSpPr>
+      <p:grpSpPr>
+        <a:xfrm>
+          <a:off x="0" y="0"/>
+          <a:ext cx="0" cy="0"/>
+          <a:chOff x="0" y="0"/>
+          <a:chExt cx="0" cy="0"/>
+        </a:xfrm>
+      </p:grpSpPr>
+      <p:sp>
+        <p:nvSpPr>
+          <p:cNvPr id="2" name="Title 1">
+            <a:extLst>
+              <a:ext uri="{FF2B5EF4-FFF2-40B4-BE49-F238E27FC236}">
+                <a16:creationId xmlns:a16="http://schemas.microsoft.com/office/drawing/2014/main" id="{3C2F5687-A7AF-8590-3CD1-2EF9CEEF499F}"/>
+              </a:ext>
+            </a:extLst>
+          </p:cNvPr>
+          <p:cNvSpPr>
+            <a:spLocks noGrp="1"/>
+          </p:cNvSpPr>
+          <p:nvPr>
+            <p:ph type="title"/>
+          </p:nvPr>
+        </p:nvSpPr>
+        <p:spPr/>
+        <p:txBody>
+          <a:bodyPr/>
+          <a:lstStyle/>
+          <a:p>
+            <a:r>
+              <a:rPr lang="en-US" dirty="0"/>
+              <a:t>Customizing your bash shell</a:t>
+            </a:r>
+          </a:p>
+        </p:txBody>
+      </p:sp>
+      <p:sp>
+        <p:nvSpPr>
+          <p:cNvPr id="3" name="Content Placeholder 2">
+            <a:extLst>
+              <a:ext uri="{FF2B5EF4-FFF2-40B4-BE49-F238E27FC236}">
+                <a16:creationId xmlns:a16="http://schemas.microsoft.com/office/drawing/2014/main" id="{677CC674-9931-8EC9-B19D-1D174B252EAE}"/>
+              </a:ext>
+            </a:extLst>
+          </p:cNvPr>
+          <p:cNvSpPr>
+            <a:spLocks noGrp="1"/>
+          </p:cNvSpPr>
+          <p:nvPr>
+            <p:ph idx="1"/>
+          </p:nvPr>
+        </p:nvSpPr>
+        <p:spPr/>
+        <p:txBody>
+          <a:bodyPr/>
+          <a:lstStyle/>
+          <a:p>
+            <a:r>
+              <a:rPr lang="en-US" dirty="0"/>
+              <a:t>More customization: making your bash prompt cute!</a:t>
+            </a:r>
+          </a:p>
+          <a:p>
+            <a:pPr lvl="1"/>
+            <a:r>
+              <a:rPr lang="en-US" dirty="0"/>
+              <a:t>Changing fonts, colors, etc.</a:t>
+            </a:r>
+          </a:p>
+          <a:p>
+            <a:r>
+              <a:rPr lang="en-US" dirty="0"/>
+              <a:t>Modify the `$PS1` variable</a:t>
+            </a:r>
+          </a:p>
+          <a:p>
+            <a:pPr lvl="1"/>
+            <a:r>
+              <a:rPr lang="en-US" dirty="0"/>
+              <a:t>Unfortunately the syntax is quite cryptic…</a:t>
+            </a:r>
+          </a:p>
+          <a:p>
+            <a:pPr lvl="1"/>
+            <a:r>
+              <a:rPr lang="en-US" dirty="0"/>
+              <a:t>Easiest to just copy a template someone else made…here’s mine:</a:t>
+            </a:r>
+          </a:p>
+          <a:p>
+            <a:pPr lvl="2"/>
+            <a:r>
+              <a:rPr lang="en-US" dirty="0"/>
+              <a:t>Make username cyan, add ‘@’, make hostname green, add ‘:’, display PWD in yellow, add ‘$’ and a space</a:t>
+            </a:r>
+          </a:p>
+          <a:p>
+            <a:pPr marL="457200" lvl="1" indent="0">
+              <a:buNone/>
+            </a:pPr>
+            <a:r>
+              <a:rPr lang="en-US" dirty="0"/>
+              <a:t> </a:t>
+            </a:r>
+          </a:p>
+        </p:txBody>
+      </p:sp>
+      <p:sp>
+        <p:nvSpPr>
+          <p:cNvPr id="4" name="TextBox 3">
+            <a:extLst>
+              <a:ext uri="{FF2B5EF4-FFF2-40B4-BE49-F238E27FC236}">
+                <a16:creationId xmlns:a16="http://schemas.microsoft.com/office/drawing/2014/main" id="{D5C7A9DA-6879-9B54-A948-A0582C62BA15}"/>
+              </a:ext>
+            </a:extLst>
+          </p:cNvPr>
+          <p:cNvSpPr txBox="1"/>
+          <p:nvPr/>
+        </p:nvSpPr>
+        <p:spPr>
+          <a:xfrm>
+            <a:off x="1759043" y="5012674"/>
+            <a:ext cx="8673913" cy="646331"/>
+          </a:xfrm>
+          <a:prstGeom prst="rect">
+            <a:avLst/>
+          </a:prstGeom>
+          <a:noFill/>
+        </p:spPr>
+        <p:txBody>
+          <a:bodyPr wrap="none" rtlCol="0">
+            <a:spAutoFit/>
+          </a:bodyPr>
+          <a:lstStyle/>
+          <a:p>
+            <a:r>
+              <a:rPr lang="en-US" dirty="0"/>
+              <a:t>export PS1="\[\033[36m\]\u\[\033[m\]@\[\033[32m\]\h:\[\033[33;1m\]\w\[\033[m\]\$ "</a:t>
+            </a:r>
+          </a:p>
+          <a:p>
+            <a:endParaRPr lang="en-US" dirty="0"/>
+          </a:p>
+        </p:txBody>
+      </p:sp>
+      <p:pic>
+        <p:nvPicPr>
+          <p:cNvPr id="5" name="Picture 4">
+            <a:extLst>
+              <a:ext uri="{FF2B5EF4-FFF2-40B4-BE49-F238E27FC236}">
+                <a16:creationId xmlns:a16="http://schemas.microsoft.com/office/drawing/2014/main" id="{D4D7F7A8-7B34-C82F-9E20-8845DF02F266}"/>
+              </a:ext>
+            </a:extLst>
+          </p:cNvPr>
+          <p:cNvPicPr>
+            <a:picLocks noChangeAspect="1"/>
+          </p:cNvPicPr>
+          <p:nvPr/>
+        </p:nvPicPr>
+        <p:blipFill>
+          <a:blip r:embed="rId2"/>
+          <a:stretch>
+            <a:fillRect/>
+          </a:stretch>
+        </p:blipFill>
+        <p:spPr>
+          <a:xfrm>
+            <a:off x="1759043" y="5628709"/>
+            <a:ext cx="6007100" cy="254000"/>
+          </a:xfrm>
+          <a:prstGeom prst="rect">
+            <a:avLst/>
+          </a:prstGeom>
+        </p:spPr>
+      </p:pic>
+    </p:spTree>
+    <p:extLst>
+      <p:ext uri="{BB962C8B-B14F-4D97-AF65-F5344CB8AC3E}">
+        <p14:creationId xmlns:p14="http://schemas.microsoft.com/office/powerpoint/2010/main" val="4007938463"/>
+      </p:ext>
+    </p:extLst>
+  </p:cSld>
+  <p:clrMapOvr>
+    <a:masterClrMapping/>
+  </p:clrMapOvr>
+</p:sld>
+</file>
+
+<file path=ppt/slides/slide18.xml><?xml version="1.0" encoding="utf-8"?>
+<p:sld xmlns:a="http://schemas.openxmlformats.org/drawingml/2006/main" xmlns:r="http://schemas.openxmlformats.org/officeDocument/2006/relationships" xmlns:p="http://schemas.openxmlformats.org/presentationml/2006/main">
+  <p:cSld>
+    <p:spTree>
+      <p:nvGrpSpPr>
+        <p:cNvPr id="1" name="">
+          <a:extLst>
+            <a:ext uri="{FF2B5EF4-FFF2-40B4-BE49-F238E27FC236}">
+              <a16:creationId xmlns:a16="http://schemas.microsoft.com/office/drawing/2014/main" id="{BEF825BE-1D61-03D0-B296-487B17425778}"/>
+            </a:ext>
+          </a:extLst>
+        </p:cNvPr>
+        <p:cNvGrpSpPr/>
+        <p:nvPr/>
+      </p:nvGrpSpPr>
+      <p:grpSpPr>
+        <a:xfrm>
+          <a:off x="0" y="0"/>
+          <a:ext cx="0" cy="0"/>
+          <a:chOff x="0" y="0"/>
+          <a:chExt cx="0" cy="0"/>
+        </a:xfrm>
+      </p:grpSpPr>
+      <p:sp>
+        <p:nvSpPr>
+          <p:cNvPr id="2" name="Title 1">
+            <a:extLst>
+              <a:ext uri="{FF2B5EF4-FFF2-40B4-BE49-F238E27FC236}">
+                <a16:creationId xmlns:a16="http://schemas.microsoft.com/office/drawing/2014/main" id="{ECA934A3-8937-3637-C8D1-DA9417CB4AF7}"/>
+              </a:ext>
+            </a:extLst>
+          </p:cNvPr>
+          <p:cNvSpPr>
+            <a:spLocks noGrp="1"/>
+          </p:cNvSpPr>
+          <p:nvPr>
+            <p:ph type="title"/>
+          </p:nvPr>
+        </p:nvSpPr>
+        <p:spPr/>
+        <p:txBody>
+          <a:bodyPr/>
+          <a:lstStyle/>
+          <a:p>
+            <a:r>
+              <a:rPr lang="en-US" dirty="0"/>
+              <a:t>Customizing your bash shell</a:t>
+            </a:r>
+          </a:p>
+        </p:txBody>
+      </p:sp>
+      <p:sp>
+        <p:nvSpPr>
+          <p:cNvPr id="3" name="Content Placeholder 2">
+            <a:extLst>
+              <a:ext uri="{FF2B5EF4-FFF2-40B4-BE49-F238E27FC236}">
+                <a16:creationId xmlns:a16="http://schemas.microsoft.com/office/drawing/2014/main" id="{28077C11-2E90-C24A-63F7-7725F52963F9}"/>
+              </a:ext>
+            </a:extLst>
+          </p:cNvPr>
+          <p:cNvSpPr>
+            <a:spLocks noGrp="1"/>
+          </p:cNvSpPr>
+          <p:nvPr>
+            <p:ph idx="1"/>
+          </p:nvPr>
+        </p:nvSpPr>
+        <p:spPr/>
+        <p:txBody>
+          <a:bodyPr/>
+          <a:lstStyle/>
+          <a:p>
+            <a:r>
+              <a:rPr lang="en-US" dirty="0"/>
+              <a:t>More customization: coloring `</a:t>
+            </a:r>
+            <a:r>
+              <a:rPr lang="en-US" dirty="0" err="1"/>
+              <a:t>ls`output</a:t>
+            </a:r>
+            <a:r>
+              <a:rPr lang="en-US" dirty="0"/>
+              <a:t> based on file type</a:t>
+            </a:r>
+          </a:p>
+          <a:p>
+            <a:pPr lvl="1"/>
+            <a:r>
+              <a:rPr lang="en-US" dirty="0"/>
+              <a:t>When using GNU `</a:t>
+            </a:r>
+            <a:r>
+              <a:rPr lang="en-US" dirty="0" err="1"/>
+              <a:t>ls`</a:t>
+            </a:r>
+            <a:r>
+              <a:rPr lang="en-US" dirty="0"/>
+              <a:t> (i.e. Cannon, but can be different e.g. on MacOS!):</a:t>
+            </a:r>
+          </a:p>
+          <a:p>
+            <a:pPr lvl="2"/>
+            <a:r>
+              <a:rPr lang="en-US" dirty="0"/>
+              <a:t>Set an </a:t>
+            </a:r>
+            <a:r>
+              <a:rPr lang="en-US" i="1" dirty="0"/>
+              <a:t>alias</a:t>
+            </a:r>
+            <a:r>
+              <a:rPr lang="en-US" dirty="0"/>
+              <a:t> for `</a:t>
+            </a:r>
+            <a:r>
+              <a:rPr lang="en-US" dirty="0" err="1"/>
+              <a:t>ls`</a:t>
+            </a:r>
+            <a:r>
+              <a:rPr lang="en-US" dirty="0"/>
+              <a:t> to auto-enable color (otherwise would need to specify every time)</a:t>
+            </a:r>
+          </a:p>
+          <a:p>
+            <a:pPr lvl="2"/>
+            <a:r>
+              <a:rPr lang="en-US" dirty="0"/>
+              <a:t>Set the LS_COLORS environmental variable </a:t>
+            </a:r>
+          </a:p>
+          <a:p>
+            <a:r>
+              <a:rPr lang="en-US" dirty="0"/>
+              <a:t>Again, the syntax is awful…here is mine:</a:t>
+            </a:r>
+          </a:p>
+          <a:p>
+            <a:pPr lvl="1"/>
+            <a:r>
+              <a:rPr lang="en-US" dirty="0" err="1"/>
+              <a:t>Dirs</a:t>
+            </a:r>
+            <a:r>
+              <a:rPr lang="en-US" dirty="0"/>
+              <a:t> in cyan, </a:t>
+            </a:r>
+            <a:r>
+              <a:rPr lang="en-US" dirty="0" err="1"/>
+              <a:t>symlinks</a:t>
+            </a:r>
+            <a:r>
+              <a:rPr lang="en-US" dirty="0"/>
+              <a:t> in magenta, executables in green, regular files in white, etc.</a:t>
+            </a:r>
+          </a:p>
+        </p:txBody>
+      </p:sp>
+      <p:sp>
+        <p:nvSpPr>
+          <p:cNvPr id="5" name="TextBox 4">
+            <a:extLst>
+              <a:ext uri="{FF2B5EF4-FFF2-40B4-BE49-F238E27FC236}">
+                <a16:creationId xmlns:a16="http://schemas.microsoft.com/office/drawing/2014/main" id="{6E8AB614-9E16-E3E2-B90C-E63629B11800}"/>
+              </a:ext>
+            </a:extLst>
+          </p:cNvPr>
+          <p:cNvSpPr txBox="1"/>
+          <p:nvPr/>
+        </p:nvSpPr>
+        <p:spPr>
+          <a:xfrm>
+            <a:off x="1759043" y="5012674"/>
+            <a:ext cx="7703199" cy="923330"/>
+          </a:xfrm>
+          <a:prstGeom prst="rect">
+            <a:avLst/>
+          </a:prstGeom>
+          <a:noFill/>
+        </p:spPr>
+        <p:txBody>
+          <a:bodyPr wrap="none" rtlCol="0">
+            <a:spAutoFit/>
+          </a:bodyPr>
+          <a:lstStyle/>
+          <a:p>
+            <a:r>
+              <a:rPr lang="en-US" dirty="0"/>
+              <a:t>alias ls='ls --color=auto'</a:t>
+            </a:r>
+          </a:p>
+          <a:p>
+            <a:r>
+              <a:rPr lang="en-US" dirty="0"/>
+              <a:t>export LS_COLORS="di=36:ln=35:ex=32:fi=0:pi=33:so=35:bd=33;1:cd=33;1"</a:t>
+            </a:r>
+          </a:p>
+          <a:p>
+            <a:endParaRPr lang="en-US" dirty="0"/>
+          </a:p>
+        </p:txBody>
+      </p:sp>
+      <p:pic>
+        <p:nvPicPr>
+          <p:cNvPr id="6" name="Picture 5">
+            <a:extLst>
+              <a:ext uri="{FF2B5EF4-FFF2-40B4-BE49-F238E27FC236}">
+                <a16:creationId xmlns:a16="http://schemas.microsoft.com/office/drawing/2014/main" id="{2D4AB6DF-E557-CFDA-5F2B-ECE4610173F3}"/>
+              </a:ext>
+            </a:extLst>
+          </p:cNvPr>
+          <p:cNvPicPr>
+            <a:picLocks noChangeAspect="1"/>
+          </p:cNvPicPr>
+          <p:nvPr/>
+        </p:nvPicPr>
+        <p:blipFill>
+          <a:blip r:embed="rId2"/>
+          <a:stretch>
+            <a:fillRect/>
+          </a:stretch>
+        </p:blipFill>
+        <p:spPr>
+          <a:xfrm>
+            <a:off x="1759043" y="5781063"/>
+            <a:ext cx="2895600" cy="736600"/>
+          </a:xfrm>
+          <a:prstGeom prst="rect">
+            <a:avLst/>
+          </a:prstGeom>
+        </p:spPr>
+      </p:pic>
+    </p:spTree>
+    <p:extLst>
+      <p:ext uri="{BB962C8B-B14F-4D97-AF65-F5344CB8AC3E}">
+        <p14:creationId xmlns:p14="http://schemas.microsoft.com/office/powerpoint/2010/main" val="3914168222"/>
       </p:ext>
     </p:extLst>
   </p:cSld>

</xml_diff>

<commit_message>
added functions and aliaes
</commit_message>
<xml_diff>
--- a/cmd-line-101/cmdline_tips_draft.pptx
+++ b/cmd-line-101/cmdline_tips_draft.pptx
@@ -20,9 +20,15 @@
     <p:sldId id="265" r:id="rId14"/>
     <p:sldId id="270" r:id="rId15"/>
     <p:sldId id="269" r:id="rId16"/>
-    <p:sldId id="271" r:id="rId17"/>
-    <p:sldId id="272" r:id="rId18"/>
-    <p:sldId id="273" r:id="rId19"/>
+    <p:sldId id="274" r:id="rId17"/>
+    <p:sldId id="271" r:id="rId18"/>
+    <p:sldId id="275" r:id="rId19"/>
+    <p:sldId id="272" r:id="rId20"/>
+    <p:sldId id="273" r:id="rId21"/>
+    <p:sldId id="276" r:id="rId22"/>
+    <p:sldId id="277" r:id="rId23"/>
+    <p:sldId id="278" r:id="rId24"/>
+    <p:sldId id="279" r:id="rId25"/>
   </p:sldIdLst>
   <p:sldSz cx="12192000" cy="6858000"/>
   <p:notesSz cx="6858000" cy="9144000"/>
@@ -276,7 +282,7 @@
           <a:p>
             <a:fld id="{A686B4F0-C34F-B24F-B974-1303EBE688C1}" type="datetimeFigureOut">
               <a:rPr lang="en-US" smtClean="0"/>
-              <a:t>2/2/26</a:t>
+              <a:t>2/4/26</a:t>
             </a:fld>
             <a:endParaRPr lang="en-US"/>
           </a:p>
@@ -474,7 +480,7 @@
           <a:p>
             <a:fld id="{A686B4F0-C34F-B24F-B974-1303EBE688C1}" type="datetimeFigureOut">
               <a:rPr lang="en-US" smtClean="0"/>
-              <a:t>2/2/26</a:t>
+              <a:t>2/4/26</a:t>
             </a:fld>
             <a:endParaRPr lang="en-US"/>
           </a:p>
@@ -682,7 +688,7 @@
           <a:p>
             <a:fld id="{A686B4F0-C34F-B24F-B974-1303EBE688C1}" type="datetimeFigureOut">
               <a:rPr lang="en-US" smtClean="0"/>
-              <a:t>2/2/26</a:t>
+              <a:t>2/4/26</a:t>
             </a:fld>
             <a:endParaRPr lang="en-US"/>
           </a:p>
@@ -880,7 +886,7 @@
           <a:p>
             <a:fld id="{A686B4F0-C34F-B24F-B974-1303EBE688C1}" type="datetimeFigureOut">
               <a:rPr lang="en-US" smtClean="0"/>
-              <a:t>2/2/26</a:t>
+              <a:t>2/4/26</a:t>
             </a:fld>
             <a:endParaRPr lang="en-US"/>
           </a:p>
@@ -1155,7 +1161,7 @@
           <a:p>
             <a:fld id="{A686B4F0-C34F-B24F-B974-1303EBE688C1}" type="datetimeFigureOut">
               <a:rPr lang="en-US" smtClean="0"/>
-              <a:t>2/2/26</a:t>
+              <a:t>2/4/26</a:t>
             </a:fld>
             <a:endParaRPr lang="en-US"/>
           </a:p>
@@ -1420,7 +1426,7 @@
           <a:p>
             <a:fld id="{A686B4F0-C34F-B24F-B974-1303EBE688C1}" type="datetimeFigureOut">
               <a:rPr lang="en-US" smtClean="0"/>
-              <a:t>2/2/26</a:t>
+              <a:t>2/4/26</a:t>
             </a:fld>
             <a:endParaRPr lang="en-US"/>
           </a:p>
@@ -1832,7 +1838,7 @@
           <a:p>
             <a:fld id="{A686B4F0-C34F-B24F-B974-1303EBE688C1}" type="datetimeFigureOut">
               <a:rPr lang="en-US" smtClean="0"/>
-              <a:t>2/2/26</a:t>
+              <a:t>2/4/26</a:t>
             </a:fld>
             <a:endParaRPr lang="en-US"/>
           </a:p>
@@ -1973,7 +1979,7 @@
           <a:p>
             <a:fld id="{A686B4F0-C34F-B24F-B974-1303EBE688C1}" type="datetimeFigureOut">
               <a:rPr lang="en-US" smtClean="0"/>
-              <a:t>2/2/26</a:t>
+              <a:t>2/4/26</a:t>
             </a:fld>
             <a:endParaRPr lang="en-US"/>
           </a:p>
@@ -2086,7 +2092,7 @@
           <a:p>
             <a:fld id="{A686B4F0-C34F-B24F-B974-1303EBE688C1}" type="datetimeFigureOut">
               <a:rPr lang="en-US" smtClean="0"/>
-              <a:t>2/2/26</a:t>
+              <a:t>2/4/26</a:t>
             </a:fld>
             <a:endParaRPr lang="en-US"/>
           </a:p>
@@ -2397,7 +2403,7 @@
           <a:p>
             <a:fld id="{A686B4F0-C34F-B24F-B974-1303EBE688C1}" type="datetimeFigureOut">
               <a:rPr lang="en-US" smtClean="0"/>
-              <a:t>2/2/26</a:t>
+              <a:t>2/4/26</a:t>
             </a:fld>
             <a:endParaRPr lang="en-US"/>
           </a:p>
@@ -2685,7 +2691,7 @@
           <a:p>
             <a:fld id="{A686B4F0-C34F-B24F-B974-1303EBE688C1}" type="datetimeFigureOut">
               <a:rPr lang="en-US" smtClean="0"/>
-              <a:t>2/2/26</a:t>
+              <a:t>2/4/26</a:t>
             </a:fld>
             <a:endParaRPr lang="en-US"/>
           </a:p>
@@ -2926,7 +2932,7 @@
           <a:p>
             <a:fld id="{A686B4F0-C34F-B24F-B974-1303EBE688C1}" type="datetimeFigureOut">
               <a:rPr lang="en-US" smtClean="0"/>
-              <a:t>2/2/26</a:t>
+              <a:t>2/4/26</a:t>
             </a:fld>
             <a:endParaRPr lang="en-US"/>
           </a:p>
@@ -4422,6 +4428,201 @@
         <p:cNvPr id="1" name="">
           <a:extLst>
             <a:ext uri="{FF2B5EF4-FFF2-40B4-BE49-F238E27FC236}">
+              <a16:creationId xmlns:a16="http://schemas.microsoft.com/office/drawing/2014/main" id="{626D994C-8EDF-B390-05D3-9DA4A82E3A39}"/>
+            </a:ext>
+          </a:extLst>
+        </p:cNvPr>
+        <p:cNvGrpSpPr/>
+        <p:nvPr/>
+      </p:nvGrpSpPr>
+      <p:grpSpPr>
+        <a:xfrm>
+          <a:off x="0" y="0"/>
+          <a:ext cx="0" cy="0"/>
+          <a:chOff x="0" y="0"/>
+          <a:chExt cx="0" cy="0"/>
+        </a:xfrm>
+      </p:grpSpPr>
+      <p:sp>
+        <p:nvSpPr>
+          <p:cNvPr id="2" name="Title 1">
+            <a:extLst>
+              <a:ext uri="{FF2B5EF4-FFF2-40B4-BE49-F238E27FC236}">
+                <a16:creationId xmlns:a16="http://schemas.microsoft.com/office/drawing/2014/main" id="{2561E278-D42D-5F8F-C170-FAD20AFB9C36}"/>
+              </a:ext>
+            </a:extLst>
+          </p:cNvPr>
+          <p:cNvSpPr>
+            <a:spLocks noGrp="1"/>
+          </p:cNvSpPr>
+          <p:nvPr>
+            <p:ph type="title"/>
+          </p:nvPr>
+        </p:nvSpPr>
+        <p:spPr/>
+        <p:txBody>
+          <a:bodyPr/>
+          <a:lstStyle/>
+          <a:p>
+            <a:r>
+              <a:rPr lang="en-US" dirty="0"/>
+              <a:t>Customizing your bash shell</a:t>
+            </a:r>
+          </a:p>
+        </p:txBody>
+      </p:sp>
+      <p:sp>
+        <p:nvSpPr>
+          <p:cNvPr id="3" name="Content Placeholder 2">
+            <a:extLst>
+              <a:ext uri="{FF2B5EF4-FFF2-40B4-BE49-F238E27FC236}">
+                <a16:creationId xmlns:a16="http://schemas.microsoft.com/office/drawing/2014/main" id="{583A0784-E341-F4D6-6E6B-7F50A869B351}"/>
+              </a:ext>
+            </a:extLst>
+          </p:cNvPr>
+          <p:cNvSpPr>
+            <a:spLocks noGrp="1"/>
+          </p:cNvSpPr>
+          <p:nvPr>
+            <p:ph idx="1"/>
+          </p:nvPr>
+        </p:nvSpPr>
+        <p:spPr/>
+        <p:txBody>
+          <a:bodyPr/>
+          <a:lstStyle/>
+          <a:p>
+            <a:r>
+              <a:rPr lang="en-US" dirty="0"/>
+              <a:t>However, it is better practice to instead use a </a:t>
+            </a:r>
+            <a:r>
+              <a:rPr lang="en-US" i="1" dirty="0"/>
+              <a:t>shell function</a:t>
+            </a:r>
+            <a:endParaRPr lang="en-US" dirty="0"/>
+          </a:p>
+          <a:p>
+            <a:r>
+              <a:rPr lang="en-US" dirty="0"/>
+              <a:t>Shell functions: like other programming languages, a re-</a:t>
+            </a:r>
+            <a:r>
+              <a:rPr lang="en-US" dirty="0" err="1"/>
+              <a:t>usuable</a:t>
+            </a:r>
+            <a:r>
+              <a:rPr lang="en-US" dirty="0"/>
+              <a:t> modular “block” of code</a:t>
+            </a:r>
+          </a:p>
+          <a:p>
+            <a:pPr lvl="1"/>
+            <a:r>
+              <a:rPr lang="en-US" dirty="0"/>
+              <a:t>Given a custom name and invoked at command line like any shell program</a:t>
+            </a:r>
+          </a:p>
+          <a:p>
+            <a:pPr lvl="1"/>
+            <a:r>
+              <a:rPr lang="en-US" dirty="0"/>
+              <a:t>Executes the commands inside the function body</a:t>
+            </a:r>
+          </a:p>
+          <a:p>
+            <a:r>
+              <a:rPr lang="en-US" dirty="0"/>
+              <a:t>Note functions don’t only go in your profile, can be part of shell scripts, etc.</a:t>
+            </a:r>
+          </a:p>
+        </p:txBody>
+      </p:sp>
+      <p:sp>
+        <p:nvSpPr>
+          <p:cNvPr id="4" name="TextBox 3">
+            <a:extLst>
+              <a:ext uri="{FF2B5EF4-FFF2-40B4-BE49-F238E27FC236}">
+                <a16:creationId xmlns:a16="http://schemas.microsoft.com/office/drawing/2014/main" id="{6AF9ABA5-BC2E-93D1-F8EC-D103FF02CCC3}"/>
+              </a:ext>
+            </a:extLst>
+          </p:cNvPr>
+          <p:cNvSpPr txBox="1"/>
+          <p:nvPr/>
+        </p:nvSpPr>
+        <p:spPr>
+          <a:xfrm>
+            <a:off x="1837980" y="5365217"/>
+            <a:ext cx="8516039" cy="1754326"/>
+          </a:xfrm>
+          <a:prstGeom prst="rect">
+            <a:avLst/>
+          </a:prstGeom>
+          <a:noFill/>
+        </p:spPr>
+        <p:txBody>
+          <a:bodyPr wrap="square" rtlCol="0">
+            <a:spAutoFit/>
+          </a:bodyPr>
+          <a:lstStyle/>
+          <a:p>
+            <a:r>
+              <a:rPr lang="en-US" dirty="0"/>
+              <a:t>function </a:t>
+            </a:r>
+            <a:r>
+              <a:rPr lang="en-US" dirty="0" err="1"/>
+              <a:t>function_name</a:t>
+            </a:r>
+            <a:r>
+              <a:rPr lang="en-US" dirty="0"/>
+              <a:t> {</a:t>
+            </a:r>
+          </a:p>
+          <a:p>
+            <a:endParaRPr lang="en-US" dirty="0"/>
+          </a:p>
+          <a:p>
+            <a:r>
+              <a:rPr lang="en-US" dirty="0"/>
+              <a:t>        shell command(s)</a:t>
+            </a:r>
+          </a:p>
+          <a:p>
+            <a:endParaRPr lang="en-US" dirty="0"/>
+          </a:p>
+          <a:p>
+            <a:r>
+              <a:rPr lang="en-US" dirty="0"/>
+              <a:t>}</a:t>
+            </a:r>
+          </a:p>
+          <a:p>
+            <a:endParaRPr lang="en-US" dirty="0"/>
+          </a:p>
+        </p:txBody>
+      </p:sp>
+    </p:spTree>
+    <p:extLst>
+      <p:ext uri="{BB962C8B-B14F-4D97-AF65-F5344CB8AC3E}">
+        <p14:creationId xmlns:p14="http://schemas.microsoft.com/office/powerpoint/2010/main" val="2916775078"/>
+      </p:ext>
+    </p:extLst>
+  </p:cSld>
+  <p:clrMapOvr>
+    <a:masterClrMapping/>
+  </p:clrMapOvr>
+</p:sld>
+</file>
+
+<file path=ppt/slides/slide17.xml><?xml version="1.0" encoding="utf-8"?>
+<p:sld xmlns:a="http://schemas.openxmlformats.org/drawingml/2006/main" xmlns:r="http://schemas.openxmlformats.org/officeDocument/2006/relationships" xmlns:p="http://schemas.openxmlformats.org/presentationml/2006/main">
+  <p:cSld>
+    <p:spTree>
+      <p:nvGrpSpPr>
+        <p:cNvPr id="1" name="">
+          <a:extLst>
+            <a:ext uri="{FF2B5EF4-FFF2-40B4-BE49-F238E27FC236}">
               <a16:creationId xmlns:a16="http://schemas.microsoft.com/office/drawing/2014/main" id="{924B8DB0-F9BD-F545-26A6-A77857811595}"/>
             </a:ext>
           </a:extLst>
@@ -4488,16 +4689,6 @@
           <a:p>
             <a:r>
               <a:rPr lang="en-US" dirty="0"/>
-              <a:t>However, it is better practice to instead use a </a:t>
-            </a:r>
-            <a:r>
-              <a:rPr lang="en-US" i="1" dirty="0"/>
-              <a:t>shell function</a:t>
-            </a:r>
-          </a:p>
-          <a:p>
-            <a:r>
-              <a:rPr lang="en-US" dirty="0"/>
               <a:t>In your `.</a:t>
             </a:r>
             <a:r>
@@ -4521,7 +4712,7 @@
             <a:pPr lvl="1"/>
             <a:r>
               <a:rPr lang="en-US" dirty="0"/>
-              <a:t>Can type `</a:t>
+              <a:t>Type `</a:t>
             </a:r>
             <a:r>
               <a:rPr lang="en-US" dirty="0" err="1"/>
@@ -4548,7 +4739,7 @@
         </p:nvSpPr>
         <p:spPr>
           <a:xfrm>
-            <a:off x="2610999" y="3429000"/>
+            <a:off x="2610999" y="2988326"/>
             <a:ext cx="6279614" cy="3139321"/>
           </a:xfrm>
           <a:prstGeom prst="rect">
@@ -4688,7 +4879,199 @@
 </p:sld>
 </file>
 
-<file path=ppt/slides/slide17.xml><?xml version="1.0" encoding="utf-8"?>
+<file path=ppt/slides/slide18.xml><?xml version="1.0" encoding="utf-8"?>
+<p:sld xmlns:a="http://schemas.openxmlformats.org/drawingml/2006/main" xmlns:r="http://schemas.openxmlformats.org/officeDocument/2006/relationships" xmlns:p="http://schemas.openxmlformats.org/presentationml/2006/main">
+  <p:cSld>
+    <p:spTree>
+      <p:nvGrpSpPr>
+        <p:cNvPr id="1" name="">
+          <a:extLst>
+            <a:ext uri="{FF2B5EF4-FFF2-40B4-BE49-F238E27FC236}">
+              <a16:creationId xmlns:a16="http://schemas.microsoft.com/office/drawing/2014/main" id="{C93CB2B2-B8F8-AF9D-50F5-EE884B1A82CD}"/>
+            </a:ext>
+          </a:extLst>
+        </p:cNvPr>
+        <p:cNvGrpSpPr/>
+        <p:nvPr/>
+      </p:nvGrpSpPr>
+      <p:grpSpPr>
+        <a:xfrm>
+          <a:off x="0" y="0"/>
+          <a:ext cx="0" cy="0"/>
+          <a:chOff x="0" y="0"/>
+          <a:chExt cx="0" cy="0"/>
+        </a:xfrm>
+      </p:grpSpPr>
+      <p:sp>
+        <p:nvSpPr>
+          <p:cNvPr id="2" name="Title 1">
+            <a:extLst>
+              <a:ext uri="{FF2B5EF4-FFF2-40B4-BE49-F238E27FC236}">
+                <a16:creationId xmlns:a16="http://schemas.microsoft.com/office/drawing/2014/main" id="{C273639D-76D2-F1B3-AC6A-4B5A6C1CF8DA}"/>
+              </a:ext>
+            </a:extLst>
+          </p:cNvPr>
+          <p:cNvSpPr>
+            <a:spLocks noGrp="1"/>
+          </p:cNvSpPr>
+          <p:nvPr>
+            <p:ph type="title"/>
+          </p:nvPr>
+        </p:nvSpPr>
+        <p:spPr/>
+        <p:txBody>
+          <a:bodyPr/>
+          <a:lstStyle/>
+          <a:p>
+            <a:r>
+              <a:rPr lang="en-US" dirty="0"/>
+              <a:t>Customizing your bash shell</a:t>
+            </a:r>
+          </a:p>
+        </p:txBody>
+      </p:sp>
+      <p:sp>
+        <p:nvSpPr>
+          <p:cNvPr id="3" name="Content Placeholder 2">
+            <a:extLst>
+              <a:ext uri="{FF2B5EF4-FFF2-40B4-BE49-F238E27FC236}">
+                <a16:creationId xmlns:a16="http://schemas.microsoft.com/office/drawing/2014/main" id="{7586F261-E7C2-A419-3EA4-2285167CC7C7}"/>
+              </a:ext>
+            </a:extLst>
+          </p:cNvPr>
+          <p:cNvSpPr>
+            <a:spLocks noGrp="1"/>
+          </p:cNvSpPr>
+          <p:nvPr>
+            <p:ph idx="1"/>
+          </p:nvPr>
+        </p:nvSpPr>
+        <p:spPr/>
+        <p:txBody>
+          <a:bodyPr/>
+          <a:lstStyle/>
+          <a:p>
+            <a:r>
+              <a:rPr lang="en-US" dirty="0"/>
+              <a:t>Other useful things to put in your profile: </a:t>
+            </a:r>
+            <a:r>
+              <a:rPr lang="en-US" i="1" dirty="0"/>
+              <a:t>command</a:t>
+            </a:r>
+            <a:r>
+              <a:rPr lang="en-US" dirty="0"/>
+              <a:t> </a:t>
+            </a:r>
+            <a:r>
+              <a:rPr lang="en-US" i="1" dirty="0"/>
+              <a:t>aliases</a:t>
+            </a:r>
+          </a:p>
+          <a:p>
+            <a:pPr lvl="1"/>
+            <a:r>
+              <a:rPr lang="en-US" dirty="0"/>
+              <a:t>Similar to a function, an alias is a shortcut for a long command</a:t>
+            </a:r>
+          </a:p>
+          <a:p>
+            <a:pPr lvl="1"/>
+            <a:r>
+              <a:rPr lang="en-US" dirty="0"/>
+              <a:t>Invoke the alias like any program</a:t>
+            </a:r>
+          </a:p>
+          <a:p>
+            <a:r>
+              <a:rPr lang="en-US" dirty="0"/>
+              <a:t>E.g. whenever you use `ls`, want to include the `-l` and `-h` flags to show file details and make size human-readable</a:t>
+            </a:r>
+          </a:p>
+          <a:p>
+            <a:pPr lvl="1"/>
+            <a:r>
+              <a:rPr lang="en-US" dirty="0"/>
+              <a:t>Note here we are setting an alias for an already existing program</a:t>
+            </a:r>
+          </a:p>
+        </p:txBody>
+      </p:sp>
+      <p:sp>
+        <p:nvSpPr>
+          <p:cNvPr id="5" name="TextBox 4">
+            <a:extLst>
+              <a:ext uri="{FF2B5EF4-FFF2-40B4-BE49-F238E27FC236}">
+                <a16:creationId xmlns:a16="http://schemas.microsoft.com/office/drawing/2014/main" id="{832CA035-EADD-CFEC-A236-BEA70BC0D522}"/>
+              </a:ext>
+            </a:extLst>
+          </p:cNvPr>
+          <p:cNvSpPr txBox="1"/>
+          <p:nvPr/>
+        </p:nvSpPr>
+        <p:spPr>
+          <a:xfrm>
+            <a:off x="1837980" y="4869458"/>
+            <a:ext cx="8516039" cy="1477328"/>
+          </a:xfrm>
+          <a:prstGeom prst="rect">
+            <a:avLst/>
+          </a:prstGeom>
+          <a:noFill/>
+        </p:spPr>
+        <p:txBody>
+          <a:bodyPr wrap="square" rtlCol="0">
+            <a:spAutoFit/>
+          </a:bodyPr>
+          <a:lstStyle/>
+          <a:p>
+            <a:r>
+              <a:rPr lang="en-US" dirty="0"/>
+              <a:t>alias </a:t>
+            </a:r>
+            <a:r>
+              <a:rPr lang="en-US" dirty="0" err="1"/>
+              <a:t>name_of_alias</a:t>
+            </a:r>
+            <a:r>
+              <a:rPr lang="en-US" dirty="0"/>
+              <a:t>=‘full command to run’</a:t>
+            </a:r>
+          </a:p>
+          <a:p>
+            <a:endParaRPr lang="en-US" dirty="0"/>
+          </a:p>
+          <a:p>
+            <a:r>
+              <a:rPr lang="en-US" dirty="0"/>
+              <a:t>alias ls=‘ls -l -h’</a:t>
+            </a:r>
+          </a:p>
+          <a:p>
+            <a:r>
+              <a:rPr lang="en-US" dirty="0"/>
+              <a:t>ls</a:t>
+            </a:r>
+          </a:p>
+          <a:p>
+            <a:endParaRPr lang="en-US" dirty="0"/>
+          </a:p>
+        </p:txBody>
+      </p:sp>
+    </p:spTree>
+    <p:extLst>
+      <p:ext uri="{BB962C8B-B14F-4D97-AF65-F5344CB8AC3E}">
+        <p14:creationId xmlns:p14="http://schemas.microsoft.com/office/powerpoint/2010/main" val="3022114170"/>
+      </p:ext>
+    </p:extLst>
+  </p:cSld>
+  <p:clrMapOvr>
+    <a:masterClrMapping/>
+  </p:clrMapOvr>
+</p:sld>
+</file>
+
+<file path=ppt/slides/slide19.xml><?xml version="1.0" encoding="utf-8"?>
 <p:sld xmlns:a="http://schemas.openxmlformats.org/drawingml/2006/main" xmlns:r="http://schemas.openxmlformats.org/officeDocument/2006/relationships" xmlns:p="http://schemas.openxmlformats.org/presentationml/2006/main">
   <p:cSld>
     <p:spTree>
@@ -4891,7 +5274,146 @@
 </p:sld>
 </file>
 
-<file path=ppt/slides/slide18.xml><?xml version="1.0" encoding="utf-8"?>
+<file path=ppt/slides/slide2.xml><?xml version="1.0" encoding="utf-8"?>
+<p:sld xmlns:a="http://schemas.openxmlformats.org/drawingml/2006/main" xmlns:r="http://schemas.openxmlformats.org/officeDocument/2006/relationships" xmlns:p="http://schemas.openxmlformats.org/presentationml/2006/main">
+  <p:cSld>
+    <p:spTree>
+      <p:nvGrpSpPr>
+        <p:cNvPr id="1" name=""/>
+        <p:cNvGrpSpPr/>
+        <p:nvPr/>
+      </p:nvGrpSpPr>
+      <p:grpSpPr>
+        <a:xfrm>
+          <a:off x="0" y="0"/>
+          <a:ext cx="0" cy="0"/>
+          <a:chOff x="0" y="0"/>
+          <a:chExt cx="0" cy="0"/>
+        </a:xfrm>
+      </p:grpSpPr>
+      <p:sp>
+        <p:nvSpPr>
+          <p:cNvPr id="2" name="Title 1">
+            <a:extLst>
+              <a:ext uri="{FF2B5EF4-FFF2-40B4-BE49-F238E27FC236}">
+                <a16:creationId xmlns:a16="http://schemas.microsoft.com/office/drawing/2014/main" id="{0EE03133-4B55-6D63-00E8-2FADDAC347B6}"/>
+              </a:ext>
+            </a:extLst>
+          </p:cNvPr>
+          <p:cNvSpPr>
+            <a:spLocks noGrp="1"/>
+          </p:cNvSpPr>
+          <p:nvPr>
+            <p:ph type="title"/>
+          </p:nvPr>
+        </p:nvSpPr>
+        <p:spPr/>
+        <p:txBody>
+          <a:bodyPr/>
+          <a:lstStyle/>
+          <a:p>
+            <a:r>
+              <a:rPr lang="en-US" dirty="0"/>
+              <a:t>Environmental variables</a:t>
+            </a:r>
+          </a:p>
+        </p:txBody>
+      </p:sp>
+      <p:sp>
+        <p:nvSpPr>
+          <p:cNvPr id="3" name="Content Placeholder 2">
+            <a:extLst>
+              <a:ext uri="{FF2B5EF4-FFF2-40B4-BE49-F238E27FC236}">
+                <a16:creationId xmlns:a16="http://schemas.microsoft.com/office/drawing/2014/main" id="{633E4DD6-2D20-CB12-42C1-BE793AD1BCE9}"/>
+              </a:ext>
+            </a:extLst>
+          </p:cNvPr>
+          <p:cNvSpPr>
+            <a:spLocks noGrp="1"/>
+          </p:cNvSpPr>
+          <p:nvPr>
+            <p:ph idx="1"/>
+          </p:nvPr>
+        </p:nvSpPr>
+        <p:spPr/>
+        <p:txBody>
+          <a:bodyPr/>
+          <a:lstStyle/>
+          <a:p>
+            <a:r>
+              <a:rPr lang="en-US" dirty="0"/>
+              <a:t>When you type a command at the terminal and it executes, what is actually happening?</a:t>
+            </a:r>
+          </a:p>
+          <a:p>
+            <a:pPr lvl="1"/>
+            <a:r>
+              <a:rPr lang="en-US" dirty="0"/>
+              <a:t>E.g. `</a:t>
+            </a:r>
+            <a:r>
+              <a:rPr lang="en-US" dirty="0" err="1"/>
+              <a:t>ls`</a:t>
+            </a:r>
+            <a:endParaRPr lang="en-US" dirty="0"/>
+          </a:p>
+          <a:p>
+            <a:r>
+              <a:rPr lang="en-US" dirty="0"/>
+              <a:t>Or, when you type a command and you get a “command not found” error even </a:t>
+            </a:r>
+            <a:r>
+              <a:rPr lang="en-US" dirty="0" err="1"/>
+              <a:t>tho</a:t>
+            </a:r>
+            <a:r>
+              <a:rPr lang="en-US" dirty="0"/>
+              <a:t> you’ve installed it, why is that?</a:t>
+            </a:r>
+          </a:p>
+          <a:p>
+            <a:r>
+              <a:rPr lang="en-US" dirty="0"/>
+              <a:t>“Behind the scenes” the shell sets variables that contain important configuration data (paths to executables, </a:t>
+            </a:r>
+            <a:r>
+              <a:rPr lang="en-US" dirty="0" err="1"/>
+              <a:t>etc</a:t>
+            </a:r>
+            <a:r>
+              <a:rPr lang="en-US" dirty="0"/>
+              <a:t>)</a:t>
+            </a:r>
+          </a:p>
+          <a:p>
+            <a:r>
+              <a:rPr lang="en-US" b="1" i="1" dirty="0"/>
+              <a:t>Environmental variables </a:t>
+            </a:r>
+          </a:p>
+          <a:p>
+            <a:pPr lvl="1"/>
+            <a:r>
+              <a:rPr lang="en-US" dirty="0"/>
+              <a:t>Inherited by all child processes upon shell startup</a:t>
+            </a:r>
+          </a:p>
+        </p:txBody>
+      </p:sp>
+    </p:spTree>
+    <p:extLst>
+      <p:ext uri="{BB962C8B-B14F-4D97-AF65-F5344CB8AC3E}">
+        <p14:creationId xmlns:p14="http://schemas.microsoft.com/office/powerpoint/2010/main" val="258523420"/>
+      </p:ext>
+    </p:extLst>
+  </p:cSld>
+  <p:clrMapOvr>
+    <a:masterClrMapping/>
+  </p:clrMapOvr>
+</p:sld>
+</file>
+
+<file path=ppt/slides/slide20.xml><?xml version="1.0" encoding="utf-8"?>
 <p:sld xmlns:a="http://schemas.openxmlformats.org/drawingml/2006/main" xmlns:r="http://schemas.openxmlformats.org/officeDocument/2006/relationships" xmlns:p="http://schemas.openxmlformats.org/presentationml/2006/main">
   <p:cSld>
     <p:spTree>
@@ -5135,7 +5657,7 @@
 </p:sld>
 </file>
 
-<file path=ppt/slides/slide2.xml><?xml version="1.0" encoding="utf-8"?>
+<file path=ppt/slides/slide21.xml><?xml version="1.0" encoding="utf-8"?>
 <p:sld xmlns:a="http://schemas.openxmlformats.org/drawingml/2006/main" xmlns:r="http://schemas.openxmlformats.org/officeDocument/2006/relationships" xmlns:p="http://schemas.openxmlformats.org/presentationml/2006/main">
   <p:cSld>
     <p:spTree>
@@ -5157,7 +5679,7 @@
           <p:cNvPr id="2" name="Title 1">
             <a:extLst>
               <a:ext uri="{FF2B5EF4-FFF2-40B4-BE49-F238E27FC236}">
-                <a16:creationId xmlns:a16="http://schemas.microsoft.com/office/drawing/2014/main" id="{0EE03133-4B55-6D63-00E8-2FADDAC347B6}"/>
+                <a16:creationId xmlns:a16="http://schemas.microsoft.com/office/drawing/2014/main" id="{BC60B2B6-B62E-3F94-2B36-41E4093194A9}"/>
               </a:ext>
             </a:extLst>
           </p:cNvPr>
@@ -5175,7 +5697,7 @@
           <a:p>
             <a:r>
               <a:rPr lang="en-US" dirty="0"/>
-              <a:t>Environmental variables</a:t>
+              <a:t>Terminal multiplexers</a:t>
             </a:r>
           </a:p>
         </p:txBody>
@@ -5185,7 +5707,7 @@
           <p:cNvPr id="3" name="Content Placeholder 2">
             <a:extLst>
               <a:ext uri="{FF2B5EF4-FFF2-40B4-BE49-F238E27FC236}">
-                <a16:creationId xmlns:a16="http://schemas.microsoft.com/office/drawing/2014/main" id="{633E4DD6-2D20-CB12-42C1-BE793AD1BCE9}"/>
+                <a16:creationId xmlns:a16="http://schemas.microsoft.com/office/drawing/2014/main" id="{80B38656-629D-2F6C-A82C-9C9262465A62}"/>
               </a:ext>
             </a:extLst>
           </p:cNvPr>
@@ -5203,60 +5725,41 @@
           <a:p>
             <a:r>
               <a:rPr lang="en-US" dirty="0"/>
-              <a:t>When you type a command at the terminal and it executes, what is actually happening?</a:t>
+              <a:t>Programs that let you run multiple terminal sessions within a single window</a:t>
             </a:r>
           </a:p>
           <a:p>
             <a:pPr lvl="1"/>
             <a:r>
               <a:rPr lang="en-US" dirty="0"/>
-              <a:t>E.g. `</a:t>
-            </a:r>
-            <a:r>
-              <a:rPr lang="en-US" dirty="0" err="1"/>
-              <a:t>ls`</a:t>
-            </a:r>
-            <a:endParaRPr lang="en-US" dirty="0"/>
-          </a:p>
-          <a:p>
-            <a:r>
-              <a:rPr lang="en-US" dirty="0"/>
-              <a:t>Or, when you type a command and you get a “command not found” error even </a:t>
-            </a:r>
-            <a:r>
-              <a:rPr lang="en-US" dirty="0" err="1"/>
-              <a:t>tho</a:t>
-            </a:r>
-            <a:r>
-              <a:rPr lang="en-US" dirty="0"/>
-              <a:t> you’ve installed it, why is that?</a:t>
-            </a:r>
-          </a:p>
-          <a:p>
-            <a:r>
-              <a:rPr lang="en-US" dirty="0"/>
-              <a:t>“Behind the scenes” the shell sets variables that contain important configuration data (paths to executables, </a:t>
-            </a:r>
-            <a:r>
-              <a:rPr lang="en-US" dirty="0" err="1"/>
-              <a:t>etc</a:t>
-            </a:r>
-            <a:r>
-              <a:rPr lang="en-US" dirty="0"/>
-              <a:t>)</a:t>
-            </a:r>
-          </a:p>
-          <a:p>
-            <a:r>
-              <a:rPr lang="en-US" b="1" i="1" dirty="0"/>
-              <a:t>Environmental variables </a:t>
+              <a:t>Can ‘detach’ a session without closing in-progress programs (continue running in the background)</a:t>
             </a:r>
           </a:p>
           <a:p>
             <a:pPr lvl="1"/>
             <a:r>
               <a:rPr lang="en-US" dirty="0"/>
-              <a:t>Inherited by all child processes upon shell startup</a:t>
+              <a:t>‘Reattach’ to a session later</a:t>
+            </a:r>
+          </a:p>
+          <a:p>
+            <a:pPr lvl="1"/>
+            <a:r>
+              <a:rPr lang="en-US" dirty="0"/>
+              <a:t>Can have complex session layouts (split panes, multiple windows, etc.)</a:t>
+            </a:r>
+          </a:p>
+          <a:p>
+            <a:r>
+              <a:rPr lang="en-US" dirty="0"/>
+              <a:t>Great for running multiple programs and for saving your runs from disconnects</a:t>
+            </a:r>
+          </a:p>
+          <a:p>
+            <a:pPr lvl="1"/>
+            <a:r>
+              <a:rPr lang="en-US" dirty="0"/>
+              <a:t>And for making you feel like a proper hacker</a:t>
             </a:r>
           </a:p>
         </p:txBody>
@@ -5264,7 +5767,323 @@
     </p:spTree>
     <p:extLst>
       <p:ext uri="{BB962C8B-B14F-4D97-AF65-F5344CB8AC3E}">
-        <p14:creationId xmlns:p14="http://schemas.microsoft.com/office/powerpoint/2010/main" val="258523420"/>
+        <p14:creationId xmlns:p14="http://schemas.microsoft.com/office/powerpoint/2010/main" val="1645433589"/>
+      </p:ext>
+    </p:extLst>
+  </p:cSld>
+  <p:clrMapOvr>
+    <a:masterClrMapping/>
+  </p:clrMapOvr>
+</p:sld>
+</file>
+
+<file path=ppt/slides/slide22.xml><?xml version="1.0" encoding="utf-8"?>
+<p:sld xmlns:a="http://schemas.openxmlformats.org/drawingml/2006/main" xmlns:r="http://schemas.openxmlformats.org/officeDocument/2006/relationships" xmlns:p="http://schemas.openxmlformats.org/presentationml/2006/main">
+  <p:cSld>
+    <p:spTree>
+      <p:nvGrpSpPr>
+        <p:cNvPr id="1" name="">
+          <a:extLst>
+            <a:ext uri="{FF2B5EF4-FFF2-40B4-BE49-F238E27FC236}">
+              <a16:creationId xmlns:a16="http://schemas.microsoft.com/office/drawing/2014/main" id="{DC813F91-3699-DBE8-BC19-A765FEED254A}"/>
+            </a:ext>
+          </a:extLst>
+        </p:cNvPr>
+        <p:cNvGrpSpPr/>
+        <p:nvPr/>
+      </p:nvGrpSpPr>
+      <p:grpSpPr>
+        <a:xfrm>
+          <a:off x="0" y="0"/>
+          <a:ext cx="0" cy="0"/>
+          <a:chOff x="0" y="0"/>
+          <a:chExt cx="0" cy="0"/>
+        </a:xfrm>
+      </p:grpSpPr>
+      <p:sp>
+        <p:nvSpPr>
+          <p:cNvPr id="2" name="Title 1">
+            <a:extLst>
+              <a:ext uri="{FF2B5EF4-FFF2-40B4-BE49-F238E27FC236}">
+                <a16:creationId xmlns:a16="http://schemas.microsoft.com/office/drawing/2014/main" id="{1FBE05AF-6640-FBF9-4C9C-B4E49FAF6D8E}"/>
+              </a:ext>
+            </a:extLst>
+          </p:cNvPr>
+          <p:cNvSpPr>
+            <a:spLocks noGrp="1"/>
+          </p:cNvSpPr>
+          <p:nvPr>
+            <p:ph type="title"/>
+          </p:nvPr>
+        </p:nvSpPr>
+        <p:spPr/>
+        <p:txBody>
+          <a:bodyPr/>
+          <a:lstStyle/>
+          <a:p>
+            <a:r>
+              <a:rPr lang="en-US" dirty="0"/>
+              <a:t>Terminal multiplexers</a:t>
+            </a:r>
+          </a:p>
+        </p:txBody>
+      </p:sp>
+      <p:sp>
+        <p:nvSpPr>
+          <p:cNvPr id="3" name="Content Placeholder 2">
+            <a:extLst>
+              <a:ext uri="{FF2B5EF4-FFF2-40B4-BE49-F238E27FC236}">
+                <a16:creationId xmlns:a16="http://schemas.microsoft.com/office/drawing/2014/main" id="{D028AA84-DCED-0E1F-7327-62E43E98315E}"/>
+              </a:ext>
+            </a:extLst>
+          </p:cNvPr>
+          <p:cNvSpPr>
+            <a:spLocks noGrp="1"/>
+          </p:cNvSpPr>
+          <p:nvPr>
+            <p:ph idx="1"/>
+          </p:nvPr>
+        </p:nvSpPr>
+        <p:spPr/>
+        <p:txBody>
+          <a:bodyPr/>
+          <a:lstStyle/>
+          <a:p>
+            <a:r>
+              <a:rPr lang="en-US" dirty="0"/>
+              <a:t>Terminology</a:t>
+            </a:r>
+          </a:p>
+          <a:p>
+            <a:pPr lvl="1"/>
+            <a:r>
+              <a:rPr lang="en-US" dirty="0"/>
+              <a:t>Windows: your terminal screen. Can think of like a browser tab. Windows can be split into…</a:t>
+            </a:r>
+          </a:p>
+          <a:p>
+            <a:pPr lvl="1"/>
+            <a:r>
+              <a:rPr lang="en-US" dirty="0"/>
+              <a:t>Panes: a rectangular subarea of a window. Each pane within a window has its own command line</a:t>
+            </a:r>
+          </a:p>
+          <a:p>
+            <a:pPr lvl="1"/>
+            <a:r>
+              <a:rPr lang="en-US" dirty="0"/>
+              <a:t>Session: your whole workspace. It can hold multiple windows (with panes). Using multiplexers, sessions can be</a:t>
+            </a:r>
+          </a:p>
+          <a:p>
+            <a:pPr lvl="2"/>
+            <a:r>
+              <a:rPr lang="en-US" dirty="0"/>
+              <a:t>Detached: “closing” the terminal, but without terminating the processes running in that session, and can…</a:t>
+            </a:r>
+          </a:p>
+          <a:p>
+            <a:pPr lvl="2"/>
+            <a:r>
+              <a:rPr lang="en-US" dirty="0"/>
+              <a:t>Reattached: can reconnect to that session without interruption</a:t>
+            </a:r>
+          </a:p>
+        </p:txBody>
+      </p:sp>
+    </p:spTree>
+    <p:extLst>
+      <p:ext uri="{BB962C8B-B14F-4D97-AF65-F5344CB8AC3E}">
+        <p14:creationId xmlns:p14="http://schemas.microsoft.com/office/powerpoint/2010/main" val="1853251870"/>
+      </p:ext>
+    </p:extLst>
+  </p:cSld>
+  <p:clrMapOvr>
+    <a:masterClrMapping/>
+  </p:clrMapOvr>
+</p:sld>
+</file>
+
+<file path=ppt/slides/slide23.xml><?xml version="1.0" encoding="utf-8"?>
+<p:sld xmlns:a="http://schemas.openxmlformats.org/drawingml/2006/main" xmlns:r="http://schemas.openxmlformats.org/officeDocument/2006/relationships" xmlns:p="http://schemas.openxmlformats.org/presentationml/2006/main">
+  <p:cSld>
+    <p:spTree>
+      <p:nvGrpSpPr>
+        <p:cNvPr id="1" name="">
+          <a:extLst>
+            <a:ext uri="{FF2B5EF4-FFF2-40B4-BE49-F238E27FC236}">
+              <a16:creationId xmlns:a16="http://schemas.microsoft.com/office/drawing/2014/main" id="{B9B5DF07-760D-2480-D421-064F06DB3A87}"/>
+            </a:ext>
+          </a:extLst>
+        </p:cNvPr>
+        <p:cNvGrpSpPr/>
+        <p:nvPr/>
+      </p:nvGrpSpPr>
+      <p:grpSpPr>
+        <a:xfrm>
+          <a:off x="0" y="0"/>
+          <a:ext cx="0" cy="0"/>
+          <a:chOff x="0" y="0"/>
+          <a:chExt cx="0" cy="0"/>
+        </a:xfrm>
+      </p:grpSpPr>
+      <p:sp>
+        <p:nvSpPr>
+          <p:cNvPr id="2" name="Title 1">
+            <a:extLst>
+              <a:ext uri="{FF2B5EF4-FFF2-40B4-BE49-F238E27FC236}">
+                <a16:creationId xmlns:a16="http://schemas.microsoft.com/office/drawing/2014/main" id="{B731E46B-DF31-62A6-3D5B-5FFB2203AF1D}"/>
+              </a:ext>
+            </a:extLst>
+          </p:cNvPr>
+          <p:cNvSpPr>
+            <a:spLocks noGrp="1"/>
+          </p:cNvSpPr>
+          <p:nvPr>
+            <p:ph type="title"/>
+          </p:nvPr>
+        </p:nvSpPr>
+        <p:spPr/>
+        <p:txBody>
+          <a:bodyPr/>
+          <a:lstStyle/>
+          <a:p>
+            <a:r>
+              <a:rPr lang="en-US" dirty="0"/>
+              <a:t>Terminal multiplexers</a:t>
+            </a:r>
+          </a:p>
+        </p:txBody>
+      </p:sp>
+      <p:sp>
+        <p:nvSpPr>
+          <p:cNvPr id="3" name="Content Placeholder 2">
+            <a:extLst>
+              <a:ext uri="{FF2B5EF4-FFF2-40B4-BE49-F238E27FC236}">
+                <a16:creationId xmlns:a16="http://schemas.microsoft.com/office/drawing/2014/main" id="{5CF19239-F772-60DC-515D-969584B2B67B}"/>
+              </a:ext>
+            </a:extLst>
+          </p:cNvPr>
+          <p:cNvSpPr>
+            <a:spLocks noGrp="1"/>
+          </p:cNvSpPr>
+          <p:nvPr>
+            <p:ph idx="1"/>
+          </p:nvPr>
+        </p:nvSpPr>
+        <p:spPr/>
+        <p:txBody>
+          <a:bodyPr/>
+          <a:lstStyle/>
+          <a:p>
+            <a:r>
+              <a:rPr lang="en-US" dirty="0"/>
+              <a:t>GNU Screen: the O.G. multiplexer</a:t>
+            </a:r>
+          </a:p>
+        </p:txBody>
+      </p:sp>
+    </p:spTree>
+    <p:extLst>
+      <p:ext uri="{BB962C8B-B14F-4D97-AF65-F5344CB8AC3E}">
+        <p14:creationId xmlns:p14="http://schemas.microsoft.com/office/powerpoint/2010/main" val="3443111476"/>
+      </p:ext>
+    </p:extLst>
+  </p:cSld>
+  <p:clrMapOvr>
+    <a:masterClrMapping/>
+  </p:clrMapOvr>
+</p:sld>
+</file>
+
+<file path=ppt/slides/slide24.xml><?xml version="1.0" encoding="utf-8"?>
+<p:sld xmlns:a="http://schemas.openxmlformats.org/drawingml/2006/main" xmlns:r="http://schemas.openxmlformats.org/officeDocument/2006/relationships" xmlns:p="http://schemas.openxmlformats.org/presentationml/2006/main">
+  <p:cSld>
+    <p:spTree>
+      <p:nvGrpSpPr>
+        <p:cNvPr id="1" name="">
+          <a:extLst>
+            <a:ext uri="{FF2B5EF4-FFF2-40B4-BE49-F238E27FC236}">
+              <a16:creationId xmlns:a16="http://schemas.microsoft.com/office/drawing/2014/main" id="{24479581-9BBA-B1D0-75FB-012A11EB8562}"/>
+            </a:ext>
+          </a:extLst>
+        </p:cNvPr>
+        <p:cNvGrpSpPr/>
+        <p:nvPr/>
+      </p:nvGrpSpPr>
+      <p:grpSpPr>
+        <a:xfrm>
+          <a:off x="0" y="0"/>
+          <a:ext cx="0" cy="0"/>
+          <a:chOff x="0" y="0"/>
+          <a:chExt cx="0" cy="0"/>
+        </a:xfrm>
+      </p:grpSpPr>
+      <p:sp>
+        <p:nvSpPr>
+          <p:cNvPr id="2" name="Title 1">
+            <a:extLst>
+              <a:ext uri="{FF2B5EF4-FFF2-40B4-BE49-F238E27FC236}">
+                <a16:creationId xmlns:a16="http://schemas.microsoft.com/office/drawing/2014/main" id="{739C545C-4943-6580-0490-891F05706C4D}"/>
+              </a:ext>
+            </a:extLst>
+          </p:cNvPr>
+          <p:cNvSpPr>
+            <a:spLocks noGrp="1"/>
+          </p:cNvSpPr>
+          <p:nvPr>
+            <p:ph type="title"/>
+          </p:nvPr>
+        </p:nvSpPr>
+        <p:spPr/>
+        <p:txBody>
+          <a:bodyPr/>
+          <a:lstStyle/>
+          <a:p>
+            <a:r>
+              <a:rPr lang="en-US" dirty="0"/>
+              <a:t>Terminal multiplexers</a:t>
+            </a:r>
+          </a:p>
+        </p:txBody>
+      </p:sp>
+      <p:sp>
+        <p:nvSpPr>
+          <p:cNvPr id="3" name="Content Placeholder 2">
+            <a:extLst>
+              <a:ext uri="{FF2B5EF4-FFF2-40B4-BE49-F238E27FC236}">
+                <a16:creationId xmlns:a16="http://schemas.microsoft.com/office/drawing/2014/main" id="{7DAD5756-F528-F764-F897-80DDB818B1A0}"/>
+              </a:ext>
+            </a:extLst>
+          </p:cNvPr>
+          <p:cNvSpPr>
+            <a:spLocks noGrp="1"/>
+          </p:cNvSpPr>
+          <p:nvPr>
+            <p:ph idx="1"/>
+          </p:nvPr>
+        </p:nvSpPr>
+        <p:spPr/>
+        <p:txBody>
+          <a:bodyPr/>
+          <a:lstStyle/>
+          <a:p>
+            <a:r>
+              <a:rPr lang="en-US" dirty="0"/>
+              <a:t>TMUX: a more modern, actively </a:t>
+            </a:r>
+            <a:r>
+              <a:rPr lang="en-US"/>
+              <a:t>developed option</a:t>
+            </a:r>
+            <a:endParaRPr lang="en-US" dirty="0"/>
+          </a:p>
+        </p:txBody>
+      </p:sp>
+    </p:spTree>
+    <p:extLst>
+      <p:ext uri="{BB962C8B-B14F-4D97-AF65-F5344CB8AC3E}">
+        <p14:creationId xmlns:p14="http://schemas.microsoft.com/office/powerpoint/2010/main" val="3596480929"/>
       </p:ext>
     </p:extLst>
   </p:cSld>

</xml_diff>

<commit_message>
small update cmdline tips
</commit_message>
<xml_diff>
--- a/cmd-line-101/cmdline_tips_draft.pptx
+++ b/cmd-line-101/cmdline_tips_draft.pptx
@@ -5,30 +5,34 @@
     <p:sldMasterId id="2147483648" r:id="rId1"/>
   </p:sldMasterIdLst>
   <p:sldIdLst>
-    <p:sldId id="256" r:id="rId2"/>
-    <p:sldId id="257" r:id="rId3"/>
-    <p:sldId id="258" r:id="rId4"/>
-    <p:sldId id="259" r:id="rId5"/>
-    <p:sldId id="260" r:id="rId6"/>
-    <p:sldId id="267" r:id="rId7"/>
-    <p:sldId id="266" r:id="rId8"/>
-    <p:sldId id="268" r:id="rId9"/>
-    <p:sldId id="261" r:id="rId10"/>
-    <p:sldId id="262" r:id="rId11"/>
-    <p:sldId id="263" r:id="rId12"/>
-    <p:sldId id="264" r:id="rId13"/>
-    <p:sldId id="265" r:id="rId14"/>
-    <p:sldId id="270" r:id="rId15"/>
-    <p:sldId id="269" r:id="rId16"/>
-    <p:sldId id="274" r:id="rId17"/>
-    <p:sldId id="271" r:id="rId18"/>
-    <p:sldId id="275" r:id="rId19"/>
-    <p:sldId id="272" r:id="rId20"/>
-    <p:sldId id="273" r:id="rId21"/>
-    <p:sldId id="276" r:id="rId22"/>
-    <p:sldId id="277" r:id="rId23"/>
-    <p:sldId id="278" r:id="rId24"/>
-    <p:sldId id="279" r:id="rId25"/>
+    <p:sldId id="280" r:id="rId2"/>
+    <p:sldId id="281" r:id="rId3"/>
+    <p:sldId id="283" r:id="rId4"/>
+    <p:sldId id="282" r:id="rId5"/>
+    <p:sldId id="284" r:id="rId6"/>
+    <p:sldId id="257" r:id="rId7"/>
+    <p:sldId id="258" r:id="rId8"/>
+    <p:sldId id="259" r:id="rId9"/>
+    <p:sldId id="260" r:id="rId10"/>
+    <p:sldId id="267" r:id="rId11"/>
+    <p:sldId id="266" r:id="rId12"/>
+    <p:sldId id="268" r:id="rId13"/>
+    <p:sldId id="261" r:id="rId14"/>
+    <p:sldId id="262" r:id="rId15"/>
+    <p:sldId id="263" r:id="rId16"/>
+    <p:sldId id="264" r:id="rId17"/>
+    <p:sldId id="265" r:id="rId18"/>
+    <p:sldId id="270" r:id="rId19"/>
+    <p:sldId id="269" r:id="rId20"/>
+    <p:sldId id="274" r:id="rId21"/>
+    <p:sldId id="271" r:id="rId22"/>
+    <p:sldId id="275" r:id="rId23"/>
+    <p:sldId id="272" r:id="rId24"/>
+    <p:sldId id="273" r:id="rId25"/>
+    <p:sldId id="276" r:id="rId26"/>
+    <p:sldId id="277" r:id="rId27"/>
+    <p:sldId id="278" r:id="rId28"/>
+    <p:sldId id="279" r:id="rId29"/>
   </p:sldIdLst>
   <p:sldSz cx="12192000" cy="6858000"/>
   <p:notesSz cx="6858000" cy="9144000"/>
@@ -3351,10 +3355,65 @@
       </p:grpSpPr>
       <p:sp>
         <p:nvSpPr>
+          <p:cNvPr id="5" name="Rectangle 4">
+            <a:extLst>
+              <a:ext uri="{FF2B5EF4-FFF2-40B4-BE49-F238E27FC236}">
+                <a16:creationId xmlns:a16="http://schemas.microsoft.com/office/drawing/2014/main" id="{358677DF-0627-BDC6-9C23-C3EBC33F697A}"/>
+              </a:ext>
+            </a:extLst>
+          </p:cNvPr>
+          <p:cNvSpPr/>
+          <p:nvPr/>
+        </p:nvSpPr>
+        <p:spPr>
+          <a:xfrm>
+            <a:off x="0" y="0"/>
+            <a:ext cx="12192000" cy="6858000"/>
+          </a:xfrm>
+          <a:prstGeom prst="rect">
+            <a:avLst/>
+          </a:prstGeom>
+          <a:solidFill>
+            <a:schemeClr val="tx1">
+              <a:lumMod val="85000"/>
+              <a:lumOff val="15000"/>
+            </a:schemeClr>
+          </a:solidFill>
+          <a:ln>
+            <a:noFill/>
+          </a:ln>
+        </p:spPr>
+        <p:style>
+          <a:lnRef idx="2">
+            <a:schemeClr val="accent1">
+              <a:shade val="15000"/>
+            </a:schemeClr>
+          </a:lnRef>
+          <a:fillRef idx="1">
+            <a:schemeClr val="accent1"/>
+          </a:fillRef>
+          <a:effectRef idx="0">
+            <a:schemeClr val="accent1"/>
+          </a:effectRef>
+          <a:fontRef idx="minor">
+            <a:schemeClr val="lt1"/>
+          </a:fontRef>
+        </p:style>
+        <p:txBody>
+          <a:bodyPr rtlCol="0" anchor="ctr"/>
+          <a:lstStyle/>
+          <a:p>
+            <a:pPr algn="ctr"/>
+            <a:endParaRPr lang="en-US"/>
+          </a:p>
+        </p:txBody>
+      </p:sp>
+      <p:sp>
+        <p:nvSpPr>
           <p:cNvPr id="2" name="Title 1">
             <a:extLst>
               <a:ext uri="{FF2B5EF4-FFF2-40B4-BE49-F238E27FC236}">
-                <a16:creationId xmlns:a16="http://schemas.microsoft.com/office/drawing/2014/main" id="{44A73EBB-C4C4-20BC-75D0-9571920E4602}"/>
+                <a16:creationId xmlns:a16="http://schemas.microsoft.com/office/drawing/2014/main" id="{E08D15E9-D3C5-4D56-EC73-260C90963F1F}"/>
               </a:ext>
             </a:extLst>
           </p:cNvPr>
@@ -3365,12 +3424,98 @@
             <p:ph type="ctrTitle"/>
           </p:nvPr>
         </p:nvSpPr>
-        <p:spPr/>
-        <p:txBody>
-          <a:bodyPr/>
-          <a:lstStyle/>
-          <a:p>
-            <a:endParaRPr lang="en-US"/>
+        <p:spPr>
+          <a:xfrm>
+            <a:off x="0" y="426314"/>
+            <a:ext cx="12192000" cy="1204913"/>
+          </a:xfrm>
+        </p:spPr>
+        <p:txBody>
+          <a:bodyPr>
+            <a:normAutofit fontScale="90000"/>
+          </a:bodyPr>
+          <a:lstStyle/>
+          <a:p>
+            <a:pPr algn="l"/>
+            <a:r>
+              <a:rPr lang="en-US" sz="4000" dirty="0">
+                <a:solidFill>
+                  <a:srgbClr val="33FF33"/>
+                </a:solidFill>
+                <a:latin typeface="Consolas" panose="020B0609020204030204" pitchFamily="49" charset="0"/>
+              </a:rPr>
+              <a:t>$</a:t>
+            </a:r>
+            <a:r>
+              <a:rPr lang="en-US" sz="2400" dirty="0">
+                <a:solidFill>
+                  <a:srgbClr val="33FF33"/>
+                </a:solidFill>
+                <a:latin typeface="Consolas" panose="020B0609020204030204" pitchFamily="49" charset="0"/>
+              </a:rPr>
+              <a:t> </a:t>
+            </a:r>
+            <a:r>
+              <a:rPr lang="en-US" sz="4000" dirty="0">
+                <a:solidFill>
+                  <a:srgbClr val="33FF33"/>
+                </a:solidFill>
+                <a:latin typeface="Consolas" panose="020B0609020204030204" pitchFamily="49" charset="0"/>
+              </a:rPr>
+              <a:t>Command line 101:</a:t>
+            </a:r>
+            <a:br>
+              <a:rPr lang="en-US" sz="4000" dirty="0">
+                <a:solidFill>
+                  <a:srgbClr val="33FF33"/>
+                </a:solidFill>
+                <a:latin typeface="Consolas" panose="020B0609020204030204" pitchFamily="49" charset="0"/>
+              </a:rPr>
+            </a:br>
+            <a:r>
+              <a:rPr lang="en-US" sz="4000" dirty="0">
+                <a:solidFill>
+                  <a:srgbClr val="33FF33"/>
+                </a:solidFill>
+                <a:latin typeface="Consolas" panose="020B0609020204030204" pitchFamily="49" charset="0"/>
+              </a:rPr>
+              <a:t>$</a:t>
+            </a:r>
+            <a:r>
+              <a:rPr lang="en-US" sz="2400" dirty="0">
+                <a:solidFill>
+                  <a:srgbClr val="33FF33"/>
+                </a:solidFill>
+                <a:latin typeface="Consolas" panose="020B0609020204030204" pitchFamily="49" charset="0"/>
+              </a:rPr>
+              <a:t> </a:t>
+            </a:r>
+            <a:r>
+              <a:rPr lang="en-US" sz="4000" dirty="0">
+                <a:solidFill>
+                  <a:srgbClr val="33FF33"/>
+                </a:solidFill>
+                <a:latin typeface="Consolas" panose="020B0609020204030204" pitchFamily="49" charset="0"/>
+              </a:rPr>
+              <a:t>Tips &amp; tricks for aspiring power users</a:t>
+            </a:r>
+            <a:br>
+              <a:rPr lang="en-US" sz="4000" dirty="0">
+                <a:solidFill>
+                  <a:srgbClr val="33FF33"/>
+                </a:solidFill>
+                <a:latin typeface="Consolas" panose="020B0609020204030204" pitchFamily="49" charset="0"/>
+              </a:rPr>
+            </a:br>
+            <a:r>
+              <a:rPr lang="en-US" sz="4000" dirty="0">
+                <a:solidFill>
+                  <a:srgbClr val="33FF33"/>
+                </a:solidFill>
+                <a:latin typeface="Consolas" panose="020B0609020204030204" pitchFamily="49" charset="0"/>
+              </a:rPr>
+              <a:t>$ Work smarter not harder &amp; type less</a:t>
+            </a:r>
           </a:p>
         </p:txBody>
       </p:sp>
@@ -3379,7 +3524,7 @@
           <p:cNvPr id="3" name="Subtitle 2">
             <a:extLst>
               <a:ext uri="{FF2B5EF4-FFF2-40B4-BE49-F238E27FC236}">
-                <a16:creationId xmlns:a16="http://schemas.microsoft.com/office/drawing/2014/main" id="{5988B069-E3AB-A69F-02FF-4B5AA21C5D99}"/>
+                <a16:creationId xmlns:a16="http://schemas.microsoft.com/office/drawing/2014/main" id="{40F930FF-0D52-8019-4787-F80035CFA7FE}"/>
               </a:ext>
             </a:extLst>
           </p:cNvPr>
@@ -3390,19 +3535,124 @@
             <p:ph type="subTitle" idx="1"/>
           </p:nvPr>
         </p:nvSpPr>
-        <p:spPr/>
-        <p:txBody>
-          <a:bodyPr/>
-          <a:lstStyle/>
-          <a:p>
-            <a:endParaRPr lang="en-US"/>
-          </a:p>
-        </p:txBody>
-      </p:sp>
+        <p:spPr>
+          <a:xfrm>
+            <a:off x="0" y="1631226"/>
+            <a:ext cx="10668000" cy="2573337"/>
+          </a:xfrm>
+        </p:spPr>
+        <p:txBody>
+          <a:bodyPr>
+            <a:normAutofit/>
+          </a:bodyPr>
+          <a:lstStyle/>
+          <a:p>
+            <a:pPr algn="l"/>
+            <a:r>
+              <a:rPr lang="en-US" sz="4000" dirty="0">
+                <a:solidFill>
+                  <a:srgbClr val="33FF33"/>
+                </a:solidFill>
+                <a:latin typeface="Consolas" panose="020B0609020204030204" pitchFamily="49" charset="0"/>
+              </a:rPr>
+              <a:t>$</a:t>
+            </a:r>
+            <a:r>
+              <a:rPr lang="en-US" dirty="0">
+                <a:solidFill>
+                  <a:srgbClr val="33FF33"/>
+                </a:solidFill>
+                <a:latin typeface="Consolas" panose="020B0609020204030204" pitchFamily="49" charset="0"/>
+              </a:rPr>
+              <a:t> Harvard FAS Informatics virtual training</a:t>
+            </a:r>
+          </a:p>
+          <a:p>
+            <a:pPr algn="l"/>
+            <a:r>
+              <a:rPr lang="en-US" sz="4000" dirty="0">
+                <a:solidFill>
+                  <a:srgbClr val="33FF33"/>
+                </a:solidFill>
+                <a:latin typeface="Consolas" panose="020B0609020204030204" pitchFamily="49" charset="0"/>
+              </a:rPr>
+              <a:t>$</a:t>
+            </a:r>
+            <a:r>
+              <a:rPr lang="en-US" dirty="0">
+                <a:solidFill>
+                  <a:srgbClr val="33FF33"/>
+                </a:solidFill>
+                <a:latin typeface="Consolas" panose="020B0609020204030204" pitchFamily="49" charset="0"/>
+              </a:rPr>
+              <a:t> Thursday, February 12, 2026</a:t>
+            </a:r>
+          </a:p>
+          <a:p>
+            <a:pPr algn="l"/>
+            <a:r>
+              <a:rPr lang="en-US" sz="4000" dirty="0">
+                <a:solidFill>
+                  <a:srgbClr val="33FF33"/>
+                </a:solidFill>
+                <a:latin typeface="Consolas" panose="020B0609020204030204" pitchFamily="49" charset="0"/>
+              </a:rPr>
+              <a:t>$ </a:t>
+            </a:r>
+          </a:p>
+        </p:txBody>
+      </p:sp>
+      <p:pic>
+        <p:nvPicPr>
+          <p:cNvPr id="1026" name="Picture 2">
+            <a:extLst>
+              <a:ext uri="{FF2B5EF4-FFF2-40B4-BE49-F238E27FC236}">
+                <a16:creationId xmlns:a16="http://schemas.microsoft.com/office/drawing/2014/main" id="{CF140393-AEA2-A958-0E1D-DBF9A848BC1F}"/>
+              </a:ext>
+            </a:extLst>
+          </p:cNvPr>
+          <p:cNvPicPr>
+            <a:picLocks noChangeAspect="1" noChangeArrowheads="1"/>
+          </p:cNvPicPr>
+          <p:nvPr/>
+        </p:nvPicPr>
+        <p:blipFill>
+          <a:blip r:embed="rId2">
+            <a:extLst>
+              <a:ext uri="{28A0092B-C50C-407E-A947-70E740481C1C}">
+                <a14:useLocalDpi xmlns:a14="http://schemas.microsoft.com/office/drawing/2010/main" val="0"/>
+              </a:ext>
+            </a:extLst>
+          </a:blip>
+          <a:srcRect/>
+          <a:stretch>
+            <a:fillRect/>
+          </a:stretch>
+        </p:blipFill>
+        <p:spPr bwMode="auto">
+          <a:xfrm>
+            <a:off x="527050" y="2998064"/>
+            <a:ext cx="584200" cy="584200"/>
+          </a:xfrm>
+          <a:prstGeom prst="rect">
+            <a:avLst/>
+          </a:prstGeom>
+          <a:noFill/>
+          <a:extLst>
+            <a:ext uri="{909E8E84-426E-40DD-AFC4-6F175D3DCCD1}">
+              <a14:hiddenFill xmlns:a14="http://schemas.microsoft.com/office/drawing/2010/main">
+                <a:solidFill>
+                  <a:srgbClr val="FFFFFF"/>
+                </a:solidFill>
+              </a14:hiddenFill>
+            </a:ext>
+          </a:extLst>
+        </p:spPr>
+      </p:pic>
     </p:spTree>
     <p:extLst>
       <p:ext uri="{BB962C8B-B14F-4D97-AF65-F5344CB8AC3E}">
-        <p14:creationId xmlns:p14="http://schemas.microsoft.com/office/powerpoint/2010/main" val="3221334056"/>
+        <p14:creationId xmlns:p14="http://schemas.microsoft.com/office/powerpoint/2010/main" val="4178609998"/>
       </p:ext>
     </p:extLst>
   </p:cSld>
@@ -3413,6 +3663,602 @@
 </file>
 
 <file path=ppt/slides/slide10.xml><?xml version="1.0" encoding="utf-8"?>
+<p:sld xmlns:a="http://schemas.openxmlformats.org/drawingml/2006/main" xmlns:r="http://schemas.openxmlformats.org/officeDocument/2006/relationships" xmlns:p="http://schemas.openxmlformats.org/presentationml/2006/main">
+  <p:cSld>
+    <p:spTree>
+      <p:nvGrpSpPr>
+        <p:cNvPr id="1" name="">
+          <a:extLst>
+            <a:ext uri="{FF2B5EF4-FFF2-40B4-BE49-F238E27FC236}">
+              <a16:creationId xmlns:a16="http://schemas.microsoft.com/office/drawing/2014/main" id="{518B08D6-F3C7-06FA-42A2-00E0F32F8F0B}"/>
+            </a:ext>
+          </a:extLst>
+        </p:cNvPr>
+        <p:cNvGrpSpPr/>
+        <p:nvPr/>
+      </p:nvGrpSpPr>
+      <p:grpSpPr>
+        <a:xfrm>
+          <a:off x="0" y="0"/>
+          <a:ext cx="0" cy="0"/>
+          <a:chOff x="0" y="0"/>
+          <a:chExt cx="0" cy="0"/>
+        </a:xfrm>
+      </p:grpSpPr>
+      <p:sp>
+        <p:nvSpPr>
+          <p:cNvPr id="2" name="Title 1">
+            <a:extLst>
+              <a:ext uri="{FF2B5EF4-FFF2-40B4-BE49-F238E27FC236}">
+                <a16:creationId xmlns:a16="http://schemas.microsoft.com/office/drawing/2014/main" id="{AF4104D0-701A-08BE-D0DC-1B8C1BBAD3A7}"/>
+              </a:ext>
+            </a:extLst>
+          </p:cNvPr>
+          <p:cNvSpPr>
+            <a:spLocks noGrp="1"/>
+          </p:cNvSpPr>
+          <p:nvPr>
+            <p:ph type="title"/>
+          </p:nvPr>
+        </p:nvSpPr>
+        <p:spPr/>
+        <p:txBody>
+          <a:bodyPr/>
+          <a:lstStyle/>
+          <a:p>
+            <a:r>
+              <a:rPr lang="en-US" dirty="0"/>
+              <a:t>Environmental variables</a:t>
+            </a:r>
+          </a:p>
+        </p:txBody>
+      </p:sp>
+      <p:sp>
+        <p:nvSpPr>
+          <p:cNvPr id="3" name="Content Placeholder 2">
+            <a:extLst>
+              <a:ext uri="{FF2B5EF4-FFF2-40B4-BE49-F238E27FC236}">
+                <a16:creationId xmlns:a16="http://schemas.microsoft.com/office/drawing/2014/main" id="{3D5DF8E9-0CB8-9BBB-791A-45A20C615DFD}"/>
+              </a:ext>
+            </a:extLst>
+          </p:cNvPr>
+          <p:cNvSpPr>
+            <a:spLocks noGrp="1"/>
+          </p:cNvSpPr>
+          <p:nvPr>
+            <p:ph idx="1"/>
+          </p:nvPr>
+        </p:nvSpPr>
+        <p:spPr>
+          <a:xfrm>
+            <a:off x="838200" y="1825624"/>
+            <a:ext cx="10515600" cy="4751445"/>
+          </a:xfrm>
+        </p:spPr>
+        <p:txBody>
+          <a:bodyPr/>
+          <a:lstStyle/>
+          <a:p>
+            <a:r>
+              <a:rPr lang="en-US" dirty="0"/>
+              <a:t>We can also add new variables to the shell:</a:t>
+            </a:r>
+          </a:p>
+          <a:p>
+            <a:pPr lvl="1"/>
+            <a:r>
+              <a:rPr lang="en-US" dirty="0"/>
+              <a:t>By convention, bash variables are named in uppercase</a:t>
+            </a:r>
+          </a:p>
+          <a:p>
+            <a:pPr lvl="1"/>
+            <a:r>
+              <a:rPr lang="en-US" dirty="0"/>
+              <a:t>`TEST=“hello there”`</a:t>
+            </a:r>
+          </a:p>
+          <a:p>
+            <a:pPr lvl="1"/>
+            <a:r>
+              <a:rPr lang="en-US" dirty="0"/>
+              <a:t>`echo $TEST`</a:t>
+            </a:r>
+          </a:p>
+          <a:p>
+            <a:r>
+              <a:rPr lang="en-US" dirty="0"/>
+              <a:t>IMPORTANT: what we did here was make a </a:t>
+            </a:r>
+            <a:r>
+              <a:rPr lang="en-US" i="1" dirty="0"/>
+              <a:t>shell variable</a:t>
+            </a:r>
+            <a:r>
+              <a:rPr lang="en-US" dirty="0"/>
+              <a:t>, not an environmental variable</a:t>
+            </a:r>
+          </a:p>
+          <a:p>
+            <a:r>
+              <a:rPr lang="en-US" dirty="0"/>
+              <a:t>What’s the difference??</a:t>
+            </a:r>
+          </a:p>
+        </p:txBody>
+      </p:sp>
+    </p:spTree>
+    <p:extLst>
+      <p:ext uri="{BB962C8B-B14F-4D97-AF65-F5344CB8AC3E}">
+        <p14:creationId xmlns:p14="http://schemas.microsoft.com/office/powerpoint/2010/main" val="3495916498"/>
+      </p:ext>
+    </p:extLst>
+  </p:cSld>
+  <p:clrMapOvr>
+    <a:masterClrMapping/>
+  </p:clrMapOvr>
+</p:sld>
+</file>
+
+<file path=ppt/slides/slide11.xml><?xml version="1.0" encoding="utf-8"?>
+<p:sld xmlns:a="http://schemas.openxmlformats.org/drawingml/2006/main" xmlns:r="http://schemas.openxmlformats.org/officeDocument/2006/relationships" xmlns:p="http://schemas.openxmlformats.org/presentationml/2006/main">
+  <p:cSld>
+    <p:spTree>
+      <p:nvGrpSpPr>
+        <p:cNvPr id="1" name="">
+          <a:extLst>
+            <a:ext uri="{FF2B5EF4-FFF2-40B4-BE49-F238E27FC236}">
+              <a16:creationId xmlns:a16="http://schemas.microsoft.com/office/drawing/2014/main" id="{9E2F3DED-A691-9BD8-F866-C62DC8FD4C02}"/>
+            </a:ext>
+          </a:extLst>
+        </p:cNvPr>
+        <p:cNvGrpSpPr/>
+        <p:nvPr/>
+      </p:nvGrpSpPr>
+      <p:grpSpPr>
+        <a:xfrm>
+          <a:off x="0" y="0"/>
+          <a:ext cx="0" cy="0"/>
+          <a:chOff x="0" y="0"/>
+          <a:chExt cx="0" cy="0"/>
+        </a:xfrm>
+      </p:grpSpPr>
+      <p:sp>
+        <p:nvSpPr>
+          <p:cNvPr id="2" name="Title 1">
+            <a:extLst>
+              <a:ext uri="{FF2B5EF4-FFF2-40B4-BE49-F238E27FC236}">
+                <a16:creationId xmlns:a16="http://schemas.microsoft.com/office/drawing/2014/main" id="{BEE41E7A-C141-5FC9-78AE-43E2B813EAB3}"/>
+              </a:ext>
+            </a:extLst>
+          </p:cNvPr>
+          <p:cNvSpPr>
+            <a:spLocks noGrp="1"/>
+          </p:cNvSpPr>
+          <p:nvPr>
+            <p:ph type="title"/>
+          </p:nvPr>
+        </p:nvSpPr>
+        <p:spPr/>
+        <p:txBody>
+          <a:bodyPr/>
+          <a:lstStyle/>
+          <a:p>
+            <a:r>
+              <a:rPr lang="en-US" dirty="0"/>
+              <a:t>Environmental variables</a:t>
+            </a:r>
+          </a:p>
+        </p:txBody>
+      </p:sp>
+      <p:sp>
+        <p:nvSpPr>
+          <p:cNvPr id="3" name="Content Placeholder 2">
+            <a:extLst>
+              <a:ext uri="{FF2B5EF4-FFF2-40B4-BE49-F238E27FC236}">
+                <a16:creationId xmlns:a16="http://schemas.microsoft.com/office/drawing/2014/main" id="{554551B4-0B44-C75B-0F64-E09B63DD2B58}"/>
+              </a:ext>
+            </a:extLst>
+          </p:cNvPr>
+          <p:cNvSpPr>
+            <a:spLocks noGrp="1"/>
+          </p:cNvSpPr>
+          <p:nvPr>
+            <p:ph idx="1"/>
+          </p:nvPr>
+        </p:nvSpPr>
+        <p:spPr>
+          <a:xfrm>
+            <a:off x="838200" y="1825624"/>
+            <a:ext cx="10515600" cy="4751445"/>
+          </a:xfrm>
+        </p:spPr>
+        <p:txBody>
+          <a:bodyPr/>
+          <a:lstStyle/>
+          <a:p>
+            <a:r>
+              <a:rPr lang="en-US" dirty="0"/>
+              <a:t>Environmental variables vs shell variables:</a:t>
+            </a:r>
+          </a:p>
+          <a:p>
+            <a:pPr lvl="1"/>
+            <a:r>
+              <a:rPr lang="en-US" dirty="0"/>
+              <a:t>Env variables are shared across all processes or programs created from the shell</a:t>
+            </a:r>
+          </a:p>
+          <a:p>
+            <a:pPr lvl="2"/>
+            <a:r>
+              <a:rPr lang="en-US" dirty="0"/>
+              <a:t>Can be “seen” by other programs</a:t>
+            </a:r>
+          </a:p>
+          <a:p>
+            <a:pPr lvl="1"/>
+            <a:r>
+              <a:rPr lang="en-US" dirty="0"/>
+              <a:t>Shell variables are local to only the shell; they aren’t “seen” by child processes</a:t>
+            </a:r>
+          </a:p>
+          <a:p>
+            <a:pPr lvl="2"/>
+            <a:r>
+              <a:rPr lang="en-US" dirty="0"/>
+              <a:t>E.g. if you ran a script that referenced a shell variable, it would not find it!</a:t>
+            </a:r>
+          </a:p>
+        </p:txBody>
+      </p:sp>
+    </p:spTree>
+    <p:extLst>
+      <p:ext uri="{BB962C8B-B14F-4D97-AF65-F5344CB8AC3E}">
+        <p14:creationId xmlns:p14="http://schemas.microsoft.com/office/powerpoint/2010/main" val="2920021287"/>
+      </p:ext>
+    </p:extLst>
+  </p:cSld>
+  <p:clrMapOvr>
+    <a:masterClrMapping/>
+  </p:clrMapOvr>
+</p:sld>
+</file>
+
+<file path=ppt/slides/slide12.xml><?xml version="1.0" encoding="utf-8"?>
+<p:sld xmlns:a="http://schemas.openxmlformats.org/drawingml/2006/main" xmlns:r="http://schemas.openxmlformats.org/officeDocument/2006/relationships" xmlns:p="http://schemas.openxmlformats.org/presentationml/2006/main">
+  <p:cSld>
+    <p:spTree>
+      <p:nvGrpSpPr>
+        <p:cNvPr id="1" name="">
+          <a:extLst>
+            <a:ext uri="{FF2B5EF4-FFF2-40B4-BE49-F238E27FC236}">
+              <a16:creationId xmlns:a16="http://schemas.microsoft.com/office/drawing/2014/main" id="{579C4F92-0A56-5631-4FF8-A0BAFB1B05F3}"/>
+            </a:ext>
+          </a:extLst>
+        </p:cNvPr>
+        <p:cNvGrpSpPr/>
+        <p:nvPr/>
+      </p:nvGrpSpPr>
+      <p:grpSpPr>
+        <a:xfrm>
+          <a:off x="0" y="0"/>
+          <a:ext cx="0" cy="0"/>
+          <a:chOff x="0" y="0"/>
+          <a:chExt cx="0" cy="0"/>
+        </a:xfrm>
+      </p:grpSpPr>
+      <p:sp>
+        <p:nvSpPr>
+          <p:cNvPr id="2" name="Title 1">
+            <a:extLst>
+              <a:ext uri="{FF2B5EF4-FFF2-40B4-BE49-F238E27FC236}">
+                <a16:creationId xmlns:a16="http://schemas.microsoft.com/office/drawing/2014/main" id="{4602EC34-AA03-A74A-1F25-873AB2339698}"/>
+              </a:ext>
+            </a:extLst>
+          </p:cNvPr>
+          <p:cNvSpPr>
+            <a:spLocks noGrp="1"/>
+          </p:cNvSpPr>
+          <p:nvPr>
+            <p:ph type="title"/>
+          </p:nvPr>
+        </p:nvSpPr>
+        <p:spPr/>
+        <p:txBody>
+          <a:bodyPr/>
+          <a:lstStyle/>
+          <a:p>
+            <a:r>
+              <a:rPr lang="en-US" dirty="0"/>
+              <a:t>Environmental variables</a:t>
+            </a:r>
+          </a:p>
+        </p:txBody>
+      </p:sp>
+      <p:sp>
+        <p:nvSpPr>
+          <p:cNvPr id="3" name="Content Placeholder 2">
+            <a:extLst>
+              <a:ext uri="{FF2B5EF4-FFF2-40B4-BE49-F238E27FC236}">
+                <a16:creationId xmlns:a16="http://schemas.microsoft.com/office/drawing/2014/main" id="{EAEF7D08-ADC1-12F9-6179-E29BDBF4820C}"/>
+              </a:ext>
+            </a:extLst>
+          </p:cNvPr>
+          <p:cNvSpPr>
+            <a:spLocks noGrp="1"/>
+          </p:cNvSpPr>
+          <p:nvPr>
+            <p:ph idx="1"/>
+          </p:nvPr>
+        </p:nvSpPr>
+        <p:spPr>
+          <a:xfrm>
+            <a:off x="838200" y="1825624"/>
+            <a:ext cx="10515600" cy="4751445"/>
+          </a:xfrm>
+        </p:spPr>
+        <p:txBody>
+          <a:bodyPr/>
+          <a:lstStyle/>
+          <a:p>
+            <a:r>
+              <a:rPr lang="en-US" dirty="0"/>
+              <a:t>`TEST=“</a:t>
+            </a:r>
+            <a:r>
+              <a:rPr lang="en-US" dirty="0" err="1"/>
+              <a:t>bingus</a:t>
+            </a:r>
+            <a:r>
+              <a:rPr lang="en-US" dirty="0"/>
+              <a:t>”`</a:t>
+            </a:r>
+          </a:p>
+          <a:p>
+            <a:r>
+              <a:rPr lang="en-US" dirty="0"/>
+              <a:t>`cat </a:t>
+            </a:r>
+            <a:r>
+              <a:rPr lang="en-US" dirty="0" err="1"/>
+              <a:t>print_test.sh</a:t>
+            </a:r>
+            <a:r>
+              <a:rPr lang="en-US" dirty="0"/>
+              <a:t>`</a:t>
+            </a:r>
+          </a:p>
+          <a:p>
+            <a:pPr lvl="1"/>
+            <a:r>
+              <a:rPr lang="en-US" dirty="0"/>
+              <a:t>`echo $TEST`</a:t>
+            </a:r>
+          </a:p>
+          <a:p>
+            <a:r>
+              <a:rPr lang="en-US" dirty="0"/>
+              <a:t>`</a:t>
+            </a:r>
+            <a:r>
+              <a:rPr lang="en-US" dirty="0" err="1"/>
+              <a:t>sh</a:t>
+            </a:r>
+            <a:r>
+              <a:rPr lang="en-US" dirty="0"/>
+              <a:t> </a:t>
+            </a:r>
+            <a:r>
+              <a:rPr lang="en-US" dirty="0" err="1"/>
+              <a:t>print_test.sh</a:t>
+            </a:r>
+            <a:r>
+              <a:rPr lang="en-US" dirty="0"/>
+              <a:t>` -&gt; no output!</a:t>
+            </a:r>
+          </a:p>
+          <a:p>
+            <a:r>
+              <a:rPr lang="en-US" dirty="0"/>
+              <a:t>This is because the `$TEST` variable only exists in the </a:t>
+            </a:r>
+            <a:r>
+              <a:rPr lang="en-US" b="1" dirty="0"/>
+              <a:t>shell</a:t>
+            </a:r>
+            <a:r>
+              <a:rPr lang="en-US" dirty="0"/>
+              <a:t>…any subprocesses (e.g. our `</a:t>
+            </a:r>
+            <a:r>
+              <a:rPr lang="en-US" dirty="0" err="1"/>
+              <a:t>print_test</a:t>
+            </a:r>
+            <a:r>
+              <a:rPr lang="en-US" dirty="0"/>
+              <a:t>` script) will not inherit it</a:t>
+            </a:r>
+          </a:p>
+          <a:p>
+            <a:r>
+              <a:rPr lang="en-US" dirty="0"/>
+              <a:t>We can convert shell variables to environmental variables!</a:t>
+            </a:r>
+          </a:p>
+          <a:p>
+            <a:pPr lvl="1"/>
+            <a:r>
+              <a:rPr lang="en-US" dirty="0"/>
+              <a:t>`export TEST`(note the lack of “$”!)</a:t>
+            </a:r>
+          </a:p>
+          <a:p>
+            <a:pPr lvl="1"/>
+            <a:r>
+              <a:rPr lang="en-US" dirty="0"/>
+              <a:t>Now we can run the script successfully</a:t>
+            </a:r>
+          </a:p>
+          <a:p>
+            <a:endParaRPr lang="en-US" dirty="0"/>
+          </a:p>
+        </p:txBody>
+      </p:sp>
+    </p:spTree>
+    <p:extLst>
+      <p:ext uri="{BB962C8B-B14F-4D97-AF65-F5344CB8AC3E}">
+        <p14:creationId xmlns:p14="http://schemas.microsoft.com/office/powerpoint/2010/main" val="285498298"/>
+      </p:ext>
+    </p:extLst>
+  </p:cSld>
+  <p:clrMapOvr>
+    <a:masterClrMapping/>
+  </p:clrMapOvr>
+</p:sld>
+</file>
+
+<file path=ppt/slides/slide13.xml><?xml version="1.0" encoding="utf-8"?>
+<p:sld xmlns:a="http://schemas.openxmlformats.org/drawingml/2006/main" xmlns:r="http://schemas.openxmlformats.org/officeDocument/2006/relationships" xmlns:p="http://schemas.openxmlformats.org/presentationml/2006/main">
+  <p:cSld>
+    <p:spTree>
+      <p:nvGrpSpPr>
+        <p:cNvPr id="1" name="">
+          <a:extLst>
+            <a:ext uri="{FF2B5EF4-FFF2-40B4-BE49-F238E27FC236}">
+              <a16:creationId xmlns:a16="http://schemas.microsoft.com/office/drawing/2014/main" id="{59C21B01-8498-55BA-4863-549119AED9FF}"/>
+            </a:ext>
+          </a:extLst>
+        </p:cNvPr>
+        <p:cNvGrpSpPr/>
+        <p:nvPr/>
+      </p:nvGrpSpPr>
+      <p:grpSpPr>
+        <a:xfrm>
+          <a:off x="0" y="0"/>
+          <a:ext cx="0" cy="0"/>
+          <a:chOff x="0" y="0"/>
+          <a:chExt cx="0" cy="0"/>
+        </a:xfrm>
+      </p:grpSpPr>
+      <p:sp>
+        <p:nvSpPr>
+          <p:cNvPr id="2" name="Title 1">
+            <a:extLst>
+              <a:ext uri="{FF2B5EF4-FFF2-40B4-BE49-F238E27FC236}">
+                <a16:creationId xmlns:a16="http://schemas.microsoft.com/office/drawing/2014/main" id="{83EC49CB-3EFF-1BEE-062E-85818E61D737}"/>
+              </a:ext>
+            </a:extLst>
+          </p:cNvPr>
+          <p:cNvSpPr>
+            <a:spLocks noGrp="1"/>
+          </p:cNvSpPr>
+          <p:nvPr>
+            <p:ph type="title"/>
+          </p:nvPr>
+        </p:nvSpPr>
+        <p:spPr/>
+        <p:txBody>
+          <a:bodyPr/>
+          <a:lstStyle/>
+          <a:p>
+            <a:r>
+              <a:rPr lang="en-US" dirty="0"/>
+              <a:t>Environmental variables</a:t>
+            </a:r>
+          </a:p>
+        </p:txBody>
+      </p:sp>
+      <p:sp>
+        <p:nvSpPr>
+          <p:cNvPr id="3" name="Content Placeholder 2">
+            <a:extLst>
+              <a:ext uri="{FF2B5EF4-FFF2-40B4-BE49-F238E27FC236}">
+                <a16:creationId xmlns:a16="http://schemas.microsoft.com/office/drawing/2014/main" id="{1CC9F031-8A9C-44AB-18A3-D0C83B59DAB0}"/>
+              </a:ext>
+            </a:extLst>
+          </p:cNvPr>
+          <p:cNvSpPr>
+            <a:spLocks noGrp="1"/>
+          </p:cNvSpPr>
+          <p:nvPr>
+            <p:ph idx="1"/>
+          </p:nvPr>
+        </p:nvSpPr>
+        <p:spPr>
+          <a:xfrm>
+            <a:off x="838200" y="1825624"/>
+            <a:ext cx="10515600" cy="4751445"/>
+          </a:xfrm>
+        </p:spPr>
+        <p:txBody>
+          <a:bodyPr/>
+          <a:lstStyle/>
+          <a:p>
+            <a:r>
+              <a:rPr lang="en-US" dirty="0"/>
+              <a:t>Another important consideration with env/shell variables…</a:t>
+            </a:r>
+          </a:p>
+          <a:p>
+            <a:r>
+              <a:rPr lang="en-US" dirty="0"/>
+              <a:t>Try making a variable: `TEST=“</a:t>
+            </a:r>
+            <a:r>
+              <a:rPr lang="en-US" dirty="0" err="1"/>
+              <a:t>bingus</a:t>
+            </a:r>
+            <a:r>
+              <a:rPr lang="en-US" dirty="0"/>
+              <a:t>”`</a:t>
+            </a:r>
+          </a:p>
+          <a:p>
+            <a:pPr lvl="1"/>
+            <a:r>
+              <a:rPr lang="en-US" dirty="0"/>
+              <a:t>`echo $TEST`</a:t>
+            </a:r>
+          </a:p>
+          <a:p>
+            <a:r>
+              <a:rPr lang="en-US" dirty="0"/>
+              <a:t>Now open a new terminal window…</a:t>
+            </a:r>
+          </a:p>
+          <a:p>
+            <a:pPr lvl="1"/>
+            <a:r>
+              <a:rPr lang="en-US" dirty="0"/>
+              <a:t>`echo $TEST`</a:t>
+            </a:r>
+          </a:p>
+          <a:p>
+            <a:r>
+              <a:rPr lang="en-US" dirty="0"/>
+              <a:t>Nothing happens! What’s going on…</a:t>
+            </a:r>
+          </a:p>
+          <a:p>
+            <a:endParaRPr lang="en-US" dirty="0"/>
+          </a:p>
+        </p:txBody>
+      </p:sp>
+    </p:spTree>
+    <p:extLst>
+      <p:ext uri="{BB962C8B-B14F-4D97-AF65-F5344CB8AC3E}">
+        <p14:creationId xmlns:p14="http://schemas.microsoft.com/office/powerpoint/2010/main" val="2057056715"/>
+      </p:ext>
+    </p:extLst>
+  </p:cSld>
+  <p:clrMapOvr>
+    <a:masterClrMapping/>
+  </p:clrMapOvr>
+</p:sld>
+</file>
+
+<file path=ppt/slides/slide14.xml><?xml version="1.0" encoding="utf-8"?>
 <p:sld xmlns:a="http://schemas.openxmlformats.org/drawingml/2006/main" xmlns:r="http://schemas.openxmlformats.org/officeDocument/2006/relationships" xmlns:p="http://schemas.openxmlformats.org/presentationml/2006/main">
   <p:cSld>
     <p:spTree>
@@ -3526,7 +4372,7 @@
 </p:sld>
 </file>
 
-<file path=ppt/slides/slide11.xml><?xml version="1.0" encoding="utf-8"?>
+<file path=ppt/slides/slide15.xml><?xml version="1.0" encoding="utf-8"?>
 <p:sld xmlns:a="http://schemas.openxmlformats.org/drawingml/2006/main" xmlns:r="http://schemas.openxmlformats.org/officeDocument/2006/relationships" xmlns:p="http://schemas.openxmlformats.org/presentationml/2006/main">
   <p:cSld>
     <p:spTree>
@@ -3662,7 +4508,7 @@
 </p:sld>
 </file>
 
-<file path=ppt/slides/slide12.xml><?xml version="1.0" encoding="utf-8"?>
+<file path=ppt/slides/slide16.xml><?xml version="1.0" encoding="utf-8"?>
 <p:sld xmlns:a="http://schemas.openxmlformats.org/drawingml/2006/main" xmlns:r="http://schemas.openxmlformats.org/officeDocument/2006/relationships" xmlns:p="http://schemas.openxmlformats.org/presentationml/2006/main">
   <p:cSld>
     <p:spTree>
@@ -3774,7 +4620,7 @@
 </p:sld>
 </file>
 
-<file path=ppt/slides/slide13.xml><?xml version="1.0" encoding="utf-8"?>
+<file path=ppt/slides/slide17.xml><?xml version="1.0" encoding="utf-8"?>
 <p:sld xmlns:a="http://schemas.openxmlformats.org/drawingml/2006/main" xmlns:r="http://schemas.openxmlformats.org/officeDocument/2006/relationships" xmlns:p="http://schemas.openxmlformats.org/presentationml/2006/main">
   <p:cSld>
     <p:spTree>
@@ -3961,7 +4807,7 @@
 </p:sld>
 </file>
 
-<file path=ppt/slides/slide14.xml><?xml version="1.0" encoding="utf-8"?>
+<file path=ppt/slides/slide18.xml><?xml version="1.0" encoding="utf-8"?>
 <p:sld xmlns:a="http://schemas.openxmlformats.org/drawingml/2006/main" xmlns:r="http://schemas.openxmlformats.org/officeDocument/2006/relationships" xmlns:p="http://schemas.openxmlformats.org/presentationml/2006/main">
   <p:cSld>
     <p:spTree>
@@ -4195,7 +5041,7 @@
 </p:sld>
 </file>
 
-<file path=ppt/slides/slide15.xml><?xml version="1.0" encoding="utf-8"?>
+<file path=ppt/slides/slide19.xml><?xml version="1.0" encoding="utf-8"?>
 <p:sld xmlns:a="http://schemas.openxmlformats.org/drawingml/2006/main" xmlns:r="http://schemas.openxmlformats.org/officeDocument/2006/relationships" xmlns:p="http://schemas.openxmlformats.org/presentationml/2006/main">
   <p:cSld>
     <p:spTree>
@@ -4420,7 +5266,603 @@
 </p:sld>
 </file>
 
-<file path=ppt/slides/slide16.xml><?xml version="1.0" encoding="utf-8"?>
+<file path=ppt/slides/slide2.xml><?xml version="1.0" encoding="utf-8"?>
+<p:sld xmlns:a="http://schemas.openxmlformats.org/drawingml/2006/main" xmlns:r="http://schemas.openxmlformats.org/officeDocument/2006/relationships" xmlns:p="http://schemas.openxmlformats.org/presentationml/2006/main">
+  <p:cSld>
+    <p:spTree>
+      <p:nvGrpSpPr>
+        <p:cNvPr id="1" name=""/>
+        <p:cNvGrpSpPr/>
+        <p:nvPr/>
+      </p:nvGrpSpPr>
+      <p:grpSpPr>
+        <a:xfrm>
+          <a:off x="0" y="0"/>
+          <a:ext cx="0" cy="0"/>
+          <a:chOff x="0" y="0"/>
+          <a:chExt cx="0" cy="0"/>
+        </a:xfrm>
+      </p:grpSpPr>
+      <p:sp>
+        <p:nvSpPr>
+          <p:cNvPr id="2" name="Title 1">
+            <a:extLst>
+              <a:ext uri="{FF2B5EF4-FFF2-40B4-BE49-F238E27FC236}">
+                <a16:creationId xmlns:a16="http://schemas.microsoft.com/office/drawing/2014/main" id="{D71FF6B6-0411-67F4-A748-26DAF2B92F75}"/>
+              </a:ext>
+            </a:extLst>
+          </p:cNvPr>
+          <p:cNvSpPr>
+            <a:spLocks noGrp="1"/>
+          </p:cNvSpPr>
+          <p:nvPr>
+            <p:ph type="title"/>
+          </p:nvPr>
+        </p:nvSpPr>
+        <p:spPr/>
+        <p:txBody>
+          <a:bodyPr/>
+          <a:lstStyle/>
+          <a:p>
+            <a:r>
+              <a:rPr lang="en-US"/>
+              <a:t>How do commands work?</a:t>
+            </a:r>
+          </a:p>
+        </p:txBody>
+      </p:sp>
+      <p:pic>
+        <p:nvPicPr>
+          <p:cNvPr id="5" name="Content Placeholder 4" descr="A drawing of a computer with a speech bubble&#10;&#10;AI-generated content may be incorrect.">
+            <a:extLst>
+              <a:ext uri="{FF2B5EF4-FFF2-40B4-BE49-F238E27FC236}">
+                <a16:creationId xmlns:a16="http://schemas.microsoft.com/office/drawing/2014/main" id="{AADC04BE-69E2-AD54-91EC-A752CB86EE64}"/>
+              </a:ext>
+            </a:extLst>
+          </p:cNvPr>
+          <p:cNvPicPr>
+            <a:picLocks noGrp="1" noChangeAspect="1"/>
+          </p:cNvPicPr>
+          <p:nvPr>
+            <p:ph idx="1"/>
+          </p:nvPr>
+        </p:nvPicPr>
+        <p:blipFill>
+          <a:blip r:embed="rId2"/>
+          <a:stretch>
+            <a:fillRect/>
+          </a:stretch>
+        </p:blipFill>
+        <p:spPr>
+          <a:xfrm>
+            <a:off x="174812" y="2141537"/>
+            <a:ext cx="4351338" cy="4351338"/>
+          </a:xfrm>
+        </p:spPr>
+      </p:pic>
+      <p:sp>
+        <p:nvSpPr>
+          <p:cNvPr id="6" name="TextBox 5">
+            <a:extLst>
+              <a:ext uri="{FF2B5EF4-FFF2-40B4-BE49-F238E27FC236}">
+                <a16:creationId xmlns:a16="http://schemas.microsoft.com/office/drawing/2014/main" id="{BE4A999C-4858-B9CD-2E28-E1637D38125A}"/>
+              </a:ext>
+            </a:extLst>
+          </p:cNvPr>
+          <p:cNvSpPr txBox="1"/>
+          <p:nvPr/>
+        </p:nvSpPr>
+        <p:spPr>
+          <a:xfrm>
+            <a:off x="699247" y="3288414"/>
+            <a:ext cx="1877437" cy="400110"/>
+          </a:xfrm>
+          <a:prstGeom prst="rect">
+            <a:avLst/>
+          </a:prstGeom>
+          <a:noFill/>
+        </p:spPr>
+        <p:txBody>
+          <a:bodyPr wrap="none" rtlCol="0">
+            <a:spAutoFit/>
+          </a:bodyPr>
+          <a:lstStyle/>
+          <a:p>
+            <a:r>
+              <a:rPr lang="en-US" sz="2000">
+                <a:latin typeface="Menlo" panose="020B0609030804020204" pitchFamily="49" charset="0"/>
+                <a:ea typeface="Menlo" panose="020B0609030804020204" pitchFamily="49" charset="0"/>
+                <a:cs typeface="Menlo" panose="020B0609030804020204" pitchFamily="49" charset="0"/>
+              </a:rPr>
+              <a:t>[gregg]$ ls</a:t>
+            </a:r>
+          </a:p>
+        </p:txBody>
+      </p:sp>
+      <p:pic>
+        <p:nvPicPr>
+          <p:cNvPr id="8" name="Graphic 7" descr="Folder Search with solid fill">
+            <a:extLst>
+              <a:ext uri="{FF2B5EF4-FFF2-40B4-BE49-F238E27FC236}">
+                <a16:creationId xmlns:a16="http://schemas.microsoft.com/office/drawing/2014/main" id="{67A97C42-CB60-9C61-FA18-B0BA1AAEF159}"/>
+              </a:ext>
+            </a:extLst>
+          </p:cNvPr>
+          <p:cNvPicPr>
+            <a:picLocks noChangeAspect="1"/>
+          </p:cNvPicPr>
+          <p:nvPr/>
+        </p:nvPicPr>
+        <p:blipFill>
+          <a:blip r:embed="rId3">
+            <a:extLst>
+              <a:ext uri="{96DAC541-7B7A-43D3-8B79-37D633B846F1}">
+                <asvg:svgBlip xmlns:asvg="http://schemas.microsoft.com/office/drawing/2016/SVG/main" r:embed="rId4"/>
+              </a:ext>
+            </a:extLst>
+          </a:blip>
+          <a:stretch>
+            <a:fillRect/>
+          </a:stretch>
+        </p:blipFill>
+        <p:spPr>
+          <a:xfrm>
+            <a:off x="5638800" y="2114643"/>
+            <a:ext cx="914400" cy="914400"/>
+          </a:xfrm>
+          <a:prstGeom prst="rect">
+            <a:avLst/>
+          </a:prstGeom>
+        </p:spPr>
+      </p:pic>
+      <p:cxnSp>
+        <p:nvCxnSpPr>
+          <p:cNvPr id="12" name="Elbow Connector 11">
+            <a:extLst>
+              <a:ext uri="{FF2B5EF4-FFF2-40B4-BE49-F238E27FC236}">
+                <a16:creationId xmlns:a16="http://schemas.microsoft.com/office/drawing/2014/main" id="{284C611A-EFD3-70A6-6A01-D70800651962}"/>
+              </a:ext>
+            </a:extLst>
+          </p:cNvPr>
+          <p:cNvCxnSpPr>
+            <a:stCxn id="5" idx="3"/>
+            <a:endCxn id="8" idx="1"/>
+          </p:cNvCxnSpPr>
+          <p:nvPr/>
+        </p:nvCxnSpPr>
+        <p:spPr>
+          <a:xfrm flipV="1">
+            <a:off x="4526150" y="2571843"/>
+            <a:ext cx="1112650" cy="1745363"/>
+          </a:xfrm>
+          <a:prstGeom prst="bentConnector3">
+            <a:avLst/>
+          </a:prstGeom>
+          <a:ln>
+            <a:tailEnd type="triangle"/>
+          </a:ln>
+        </p:spPr>
+        <p:style>
+          <a:lnRef idx="2">
+            <a:schemeClr val="accent1"/>
+          </a:lnRef>
+          <a:fillRef idx="0">
+            <a:schemeClr val="accent1"/>
+          </a:fillRef>
+          <a:effectRef idx="1">
+            <a:schemeClr val="accent1"/>
+          </a:effectRef>
+          <a:fontRef idx="minor">
+            <a:schemeClr val="tx1"/>
+          </a:fontRef>
+        </p:style>
+      </p:cxnSp>
+      <p:pic>
+        <p:nvPicPr>
+          <p:cNvPr id="13" name="Picture 4" descr="Beige Folder Icon for Mac | Customizable and High-Quality">
+            <a:extLst>
+              <a:ext uri="{FF2B5EF4-FFF2-40B4-BE49-F238E27FC236}">
+                <a16:creationId xmlns:a16="http://schemas.microsoft.com/office/drawing/2014/main" id="{6A5F274E-DDA8-C409-DDCE-298E1C0A1C06}"/>
+              </a:ext>
+            </a:extLst>
+          </p:cNvPr>
+          <p:cNvPicPr>
+            <a:picLocks noChangeAspect="1" noChangeArrowheads="1"/>
+          </p:cNvPicPr>
+          <p:nvPr/>
+        </p:nvPicPr>
+        <p:blipFill>
+          <a:blip r:embed="rId5">
+            <a:extLst>
+              <a:ext uri="{28A0092B-C50C-407E-A947-70E740481C1C}">
+                <a14:useLocalDpi xmlns:a14="http://schemas.microsoft.com/office/drawing/2010/main" val="0"/>
+              </a:ext>
+            </a:extLst>
+          </a:blip>
+          <a:srcRect/>
+          <a:stretch>
+            <a:fillRect/>
+          </a:stretch>
+        </p:blipFill>
+        <p:spPr bwMode="auto">
+          <a:xfrm>
+            <a:off x="9332553" y="2144618"/>
+            <a:ext cx="793750" cy="793750"/>
+          </a:xfrm>
+          <a:prstGeom prst="rect">
+            <a:avLst/>
+          </a:prstGeom>
+          <a:noFill/>
+          <a:extLst>
+            <a:ext uri="{909E8E84-426E-40DD-AFC4-6F175D3DCCD1}">
+              <a14:hiddenFill xmlns:a14="http://schemas.microsoft.com/office/drawing/2010/main">
+                <a:solidFill>
+                  <a:srgbClr val="FFFFFF"/>
+                </a:solidFill>
+              </a14:hiddenFill>
+            </a:ext>
+          </a:extLst>
+        </p:spPr>
+      </p:pic>
+      <p:sp>
+        <p:nvSpPr>
+          <p:cNvPr id="14" name="TextBox 13">
+            <a:extLst>
+              <a:ext uri="{FF2B5EF4-FFF2-40B4-BE49-F238E27FC236}">
+                <a16:creationId xmlns:a16="http://schemas.microsoft.com/office/drawing/2014/main" id="{0311A7F4-342A-3D27-A6CC-891560B4D6EA}"/>
+              </a:ext>
+            </a:extLst>
+          </p:cNvPr>
+          <p:cNvSpPr txBox="1"/>
+          <p:nvPr/>
+        </p:nvSpPr>
+        <p:spPr>
+          <a:xfrm>
+            <a:off x="9253178" y="2387177"/>
+            <a:ext cx="952500" cy="369332"/>
+          </a:xfrm>
+          <a:prstGeom prst="rect">
+            <a:avLst/>
+          </a:prstGeom>
+          <a:noFill/>
+        </p:spPr>
+        <p:txBody>
+          <a:bodyPr wrap="square" rtlCol="0">
+            <a:spAutoFit/>
+          </a:bodyPr>
+          <a:lstStyle/>
+          <a:p>
+            <a:pPr algn="ctr"/>
+            <a:r>
+              <a:rPr lang="en-US" dirty="0">
+                <a:latin typeface="Source Sans Pro" panose="020B0503030403020204" pitchFamily="34" charset="0"/>
+                <a:ea typeface="Source Sans Pro" panose="020B0503030403020204" pitchFamily="34" charset="0"/>
+              </a:rPr>
+              <a:t>/bin/</a:t>
+            </a:r>
+            <a:endParaRPr lang="en-US" sz="3600" dirty="0">
+              <a:latin typeface="Source Sans Pro" panose="020B0503030403020204" pitchFamily="34" charset="0"/>
+              <a:ea typeface="Source Sans Pro" panose="020B0503030403020204" pitchFamily="34" charset="0"/>
+            </a:endParaRPr>
+          </a:p>
+        </p:txBody>
+      </p:sp>
+      <p:cxnSp>
+        <p:nvCxnSpPr>
+          <p:cNvPr id="18" name="Straight Arrow Connector 17">
+            <a:extLst>
+              <a:ext uri="{FF2B5EF4-FFF2-40B4-BE49-F238E27FC236}">
+                <a16:creationId xmlns:a16="http://schemas.microsoft.com/office/drawing/2014/main" id="{D4B325C8-9BA6-DC0C-809B-819595E847FF}"/>
+              </a:ext>
+            </a:extLst>
+          </p:cNvPr>
+          <p:cNvCxnSpPr>
+            <a:cxnSpLocks/>
+            <a:endCxn id="14" idx="1"/>
+          </p:cNvCxnSpPr>
+          <p:nvPr/>
+        </p:nvCxnSpPr>
+        <p:spPr>
+          <a:xfrm>
+            <a:off x="6553200" y="2571843"/>
+            <a:ext cx="2699978" cy="0"/>
+          </a:xfrm>
+          <a:prstGeom prst="straightConnector1">
+            <a:avLst/>
+          </a:prstGeom>
+          <a:ln>
+            <a:tailEnd type="triangle"/>
+          </a:ln>
+        </p:spPr>
+        <p:style>
+          <a:lnRef idx="2">
+            <a:schemeClr val="accent1"/>
+          </a:lnRef>
+          <a:fillRef idx="0">
+            <a:schemeClr val="accent1"/>
+          </a:fillRef>
+          <a:effectRef idx="1">
+            <a:schemeClr val="accent1"/>
+          </a:effectRef>
+          <a:fontRef idx="minor">
+            <a:schemeClr val="tx1"/>
+          </a:fontRef>
+        </p:style>
+      </p:cxnSp>
+      <p:grpSp>
+        <p:nvGrpSpPr>
+          <p:cNvPr id="20" name="Group 19">
+            <a:extLst>
+              <a:ext uri="{FF2B5EF4-FFF2-40B4-BE49-F238E27FC236}">
+                <a16:creationId xmlns:a16="http://schemas.microsoft.com/office/drawing/2014/main" id="{1EC0E139-053F-3DDC-3CA5-9BE717884C9D}"/>
+              </a:ext>
+            </a:extLst>
+          </p:cNvPr>
+          <p:cNvGrpSpPr/>
+          <p:nvPr/>
+        </p:nvGrpSpPr>
+        <p:grpSpPr>
+          <a:xfrm>
+            <a:off x="9448341" y="3421781"/>
+            <a:ext cx="562174" cy="793750"/>
+            <a:chOff x="7387881" y="3180927"/>
+            <a:chExt cx="793750" cy="1096011"/>
+          </a:xfrm>
+        </p:grpSpPr>
+        <p:pic>
+          <p:nvPicPr>
+            <p:cNvPr id="16" name="Picture 15">
+              <a:extLst>
+                <a:ext uri="{FF2B5EF4-FFF2-40B4-BE49-F238E27FC236}">
+                  <a16:creationId xmlns:a16="http://schemas.microsoft.com/office/drawing/2014/main" id="{A24ED2B7-70F4-20E1-9C3F-D07EB9CA9A6B}"/>
+                </a:ext>
+              </a:extLst>
+            </p:cNvPr>
+            <p:cNvPicPr>
+              <a:picLocks noChangeAspect="1"/>
+            </p:cNvPicPr>
+            <p:nvPr/>
+          </p:nvPicPr>
+          <p:blipFill>
+            <a:blip r:embed="rId6"/>
+            <a:srcRect l="3700" t="52231" r="80037" b="2857"/>
+            <a:stretch>
+              <a:fillRect/>
+            </a:stretch>
+          </p:blipFill>
+          <p:spPr>
+            <a:xfrm>
+              <a:off x="7387881" y="3180927"/>
+              <a:ext cx="793750" cy="1096011"/>
+            </a:xfrm>
+            <a:prstGeom prst="rect">
+              <a:avLst/>
+            </a:prstGeom>
+          </p:spPr>
+        </p:pic>
+        <p:sp>
+          <p:nvSpPr>
+            <p:cNvPr id="19" name="TextBox 18">
+              <a:extLst>
+                <a:ext uri="{FF2B5EF4-FFF2-40B4-BE49-F238E27FC236}">
+                  <a16:creationId xmlns:a16="http://schemas.microsoft.com/office/drawing/2014/main" id="{3C290E23-F06E-B658-130D-A687FD9094F1}"/>
+                </a:ext>
+              </a:extLst>
+            </p:cNvPr>
+            <p:cNvSpPr txBox="1"/>
+            <p:nvPr/>
+          </p:nvSpPr>
+          <p:spPr>
+            <a:xfrm>
+              <a:off x="7459706" y="4000526"/>
+              <a:ext cx="603019" cy="215444"/>
+            </a:xfrm>
+            <a:prstGeom prst="rect">
+              <a:avLst/>
+            </a:prstGeom>
+            <a:solidFill>
+              <a:srgbClr val="EE1C23"/>
+            </a:solidFill>
+          </p:spPr>
+          <p:txBody>
+            <a:bodyPr wrap="square" lIns="0" tIns="0" rIns="0" bIns="0" rtlCol="0">
+              <a:spAutoFit/>
+            </a:bodyPr>
+            <a:lstStyle/>
+            <a:p>
+              <a:pPr algn="ctr"/>
+              <a:r>
+                <a:rPr lang="en-US" sz="1400" b="1">
+                  <a:solidFill>
+                    <a:schemeClr val="bg1"/>
+                  </a:solidFill>
+                  <a:latin typeface="Menlo" panose="020B0609030804020204" pitchFamily="49" charset="0"/>
+                  <a:ea typeface="Menlo" panose="020B0609030804020204" pitchFamily="49" charset="0"/>
+                  <a:cs typeface="Menlo" panose="020B0609030804020204" pitchFamily="49" charset="0"/>
+                </a:rPr>
+                <a:t>ls</a:t>
+              </a:r>
+            </a:p>
+          </p:txBody>
+        </p:sp>
+      </p:grpSp>
+      <p:cxnSp>
+        <p:nvCxnSpPr>
+          <p:cNvPr id="21" name="Straight Arrow Connector 20">
+            <a:extLst>
+              <a:ext uri="{FF2B5EF4-FFF2-40B4-BE49-F238E27FC236}">
+                <a16:creationId xmlns:a16="http://schemas.microsoft.com/office/drawing/2014/main" id="{F09CDE50-642A-624A-6DB8-CAF3D105B722}"/>
+              </a:ext>
+            </a:extLst>
+          </p:cNvPr>
+          <p:cNvCxnSpPr>
+            <a:cxnSpLocks/>
+            <a:stCxn id="13" idx="2"/>
+            <a:endCxn id="16" idx="0"/>
+          </p:cNvCxnSpPr>
+          <p:nvPr/>
+        </p:nvCxnSpPr>
+        <p:spPr>
+          <a:xfrm>
+            <a:off x="9729428" y="2938368"/>
+            <a:ext cx="0" cy="483413"/>
+          </a:xfrm>
+          <a:prstGeom prst="straightConnector1">
+            <a:avLst/>
+          </a:prstGeom>
+          <a:ln>
+            <a:tailEnd type="triangle"/>
+          </a:ln>
+        </p:spPr>
+        <p:style>
+          <a:lnRef idx="2">
+            <a:schemeClr val="accent1"/>
+          </a:lnRef>
+          <a:fillRef idx="0">
+            <a:schemeClr val="accent1"/>
+          </a:fillRef>
+          <a:effectRef idx="1">
+            <a:schemeClr val="accent1"/>
+          </a:effectRef>
+          <a:fontRef idx="minor">
+            <a:schemeClr val="tx1"/>
+          </a:fontRef>
+        </p:style>
+      </p:cxnSp>
+      <p:sp>
+        <p:nvSpPr>
+          <p:cNvPr id="32" name="TextBox 31">
+            <a:extLst>
+              <a:ext uri="{FF2B5EF4-FFF2-40B4-BE49-F238E27FC236}">
+                <a16:creationId xmlns:a16="http://schemas.microsoft.com/office/drawing/2014/main" id="{974D3501-407D-D084-5A5B-512AE1DBC3A8}"/>
+              </a:ext>
+            </a:extLst>
+          </p:cNvPr>
+          <p:cNvSpPr txBox="1"/>
+          <p:nvPr/>
+        </p:nvSpPr>
+        <p:spPr>
+          <a:xfrm>
+            <a:off x="6553200" y="4720281"/>
+            <a:ext cx="1874103" cy="369332"/>
+          </a:xfrm>
+          <a:prstGeom prst="rect">
+            <a:avLst/>
+          </a:prstGeom>
+          <a:noFill/>
+        </p:spPr>
+        <p:txBody>
+          <a:bodyPr wrap="none" rtlCol="0">
+            <a:spAutoFit/>
+          </a:bodyPr>
+          <a:lstStyle/>
+          <a:p>
+            <a:r>
+              <a:rPr lang="en-US"/>
+              <a:t>Run this program</a:t>
+            </a:r>
+          </a:p>
+        </p:txBody>
+      </p:sp>
+      <p:cxnSp>
+        <p:nvCxnSpPr>
+          <p:cNvPr id="34" name="Elbow Connector 33">
+            <a:extLst>
+              <a:ext uri="{FF2B5EF4-FFF2-40B4-BE49-F238E27FC236}">
+                <a16:creationId xmlns:a16="http://schemas.microsoft.com/office/drawing/2014/main" id="{E80BB726-4EB9-5919-732B-8053097B7F47}"/>
+              </a:ext>
+            </a:extLst>
+          </p:cNvPr>
+          <p:cNvCxnSpPr>
+            <a:cxnSpLocks/>
+            <a:stCxn id="32" idx="2"/>
+          </p:cNvCxnSpPr>
+          <p:nvPr/>
+        </p:nvCxnSpPr>
+        <p:spPr>
+          <a:xfrm rot="5400000">
+            <a:off x="5667098" y="3700315"/>
+            <a:ext cx="433856" cy="3212453"/>
+          </a:xfrm>
+          <a:prstGeom prst="bentConnector2">
+            <a:avLst/>
+          </a:prstGeom>
+          <a:ln>
+            <a:tailEnd type="triangle"/>
+          </a:ln>
+        </p:spPr>
+        <p:style>
+          <a:lnRef idx="2">
+            <a:schemeClr val="accent1"/>
+          </a:lnRef>
+          <a:fillRef idx="0">
+            <a:schemeClr val="accent1"/>
+          </a:fillRef>
+          <a:effectRef idx="1">
+            <a:schemeClr val="accent1"/>
+          </a:effectRef>
+          <a:fontRef idx="minor">
+            <a:schemeClr val="tx1"/>
+          </a:fontRef>
+        </p:style>
+      </p:cxnSp>
+      <p:cxnSp>
+        <p:nvCxnSpPr>
+          <p:cNvPr id="37" name="Elbow Connector 36">
+            <a:extLst>
+              <a:ext uri="{FF2B5EF4-FFF2-40B4-BE49-F238E27FC236}">
+                <a16:creationId xmlns:a16="http://schemas.microsoft.com/office/drawing/2014/main" id="{DBCA8E09-4C00-C38D-98C5-38836A1FEA57}"/>
+              </a:ext>
+            </a:extLst>
+          </p:cNvPr>
+          <p:cNvCxnSpPr>
+            <a:cxnSpLocks/>
+            <a:stCxn id="16" idx="2"/>
+            <a:endCxn id="32" idx="3"/>
+          </p:cNvCxnSpPr>
+          <p:nvPr/>
+        </p:nvCxnSpPr>
+        <p:spPr>
+          <a:xfrm rot="5400000">
+            <a:off x="8733658" y="3909177"/>
+            <a:ext cx="689416" cy="1302125"/>
+          </a:xfrm>
+          <a:prstGeom prst="bentConnector2">
+            <a:avLst/>
+          </a:prstGeom>
+          <a:ln>
+            <a:tailEnd type="triangle"/>
+          </a:ln>
+        </p:spPr>
+        <p:style>
+          <a:lnRef idx="2">
+            <a:schemeClr val="accent1"/>
+          </a:lnRef>
+          <a:fillRef idx="0">
+            <a:schemeClr val="accent1"/>
+          </a:fillRef>
+          <a:effectRef idx="1">
+            <a:schemeClr val="accent1"/>
+          </a:effectRef>
+          <a:fontRef idx="minor">
+            <a:schemeClr val="tx1"/>
+          </a:fontRef>
+        </p:style>
+      </p:cxnSp>
+    </p:spTree>
+    <p:extLst>
+      <p:ext uri="{BB962C8B-B14F-4D97-AF65-F5344CB8AC3E}">
+        <p14:creationId xmlns:p14="http://schemas.microsoft.com/office/powerpoint/2010/main" val="1164345524"/>
+      </p:ext>
+    </p:extLst>
+  </p:cSld>
+  <p:clrMapOvr>
+    <a:masterClrMapping/>
+  </p:clrMapOvr>
+</p:sld>
+</file>
+
+<file path=ppt/slides/slide20.xml><?xml version="1.0" encoding="utf-8"?>
 <p:sld xmlns:a="http://schemas.openxmlformats.org/drawingml/2006/main" xmlns:r="http://schemas.openxmlformats.org/officeDocument/2006/relationships" xmlns:p="http://schemas.openxmlformats.org/presentationml/2006/main">
   <p:cSld>
     <p:spTree>
@@ -4615,7 +6057,7 @@
 </p:sld>
 </file>
 
-<file path=ppt/slides/slide17.xml><?xml version="1.0" encoding="utf-8"?>
+<file path=ppt/slides/slide21.xml><?xml version="1.0" encoding="utf-8"?>
 <p:sld xmlns:a="http://schemas.openxmlformats.org/drawingml/2006/main" xmlns:r="http://schemas.openxmlformats.org/officeDocument/2006/relationships" xmlns:p="http://schemas.openxmlformats.org/presentationml/2006/main">
   <p:cSld>
     <p:spTree>
@@ -4879,7 +6321,7 @@
 </p:sld>
 </file>
 
-<file path=ppt/slides/slide18.xml><?xml version="1.0" encoding="utf-8"?>
+<file path=ppt/slides/slide22.xml><?xml version="1.0" encoding="utf-8"?>
 <p:sld xmlns:a="http://schemas.openxmlformats.org/drawingml/2006/main" xmlns:r="http://schemas.openxmlformats.org/officeDocument/2006/relationships" xmlns:p="http://schemas.openxmlformats.org/presentationml/2006/main">
   <p:cSld>
     <p:spTree>
@@ -5071,7 +6513,7 @@
 </p:sld>
 </file>
 
-<file path=ppt/slides/slide19.xml><?xml version="1.0" encoding="utf-8"?>
+<file path=ppt/slides/slide23.xml><?xml version="1.0" encoding="utf-8"?>
 <p:sld xmlns:a="http://schemas.openxmlformats.org/drawingml/2006/main" xmlns:r="http://schemas.openxmlformats.org/officeDocument/2006/relationships" xmlns:p="http://schemas.openxmlformats.org/presentationml/2006/main">
   <p:cSld>
     <p:spTree>
@@ -5274,146 +6716,7 @@
 </p:sld>
 </file>
 
-<file path=ppt/slides/slide2.xml><?xml version="1.0" encoding="utf-8"?>
-<p:sld xmlns:a="http://schemas.openxmlformats.org/drawingml/2006/main" xmlns:r="http://schemas.openxmlformats.org/officeDocument/2006/relationships" xmlns:p="http://schemas.openxmlformats.org/presentationml/2006/main">
-  <p:cSld>
-    <p:spTree>
-      <p:nvGrpSpPr>
-        <p:cNvPr id="1" name=""/>
-        <p:cNvGrpSpPr/>
-        <p:nvPr/>
-      </p:nvGrpSpPr>
-      <p:grpSpPr>
-        <a:xfrm>
-          <a:off x="0" y="0"/>
-          <a:ext cx="0" cy="0"/>
-          <a:chOff x="0" y="0"/>
-          <a:chExt cx="0" cy="0"/>
-        </a:xfrm>
-      </p:grpSpPr>
-      <p:sp>
-        <p:nvSpPr>
-          <p:cNvPr id="2" name="Title 1">
-            <a:extLst>
-              <a:ext uri="{FF2B5EF4-FFF2-40B4-BE49-F238E27FC236}">
-                <a16:creationId xmlns:a16="http://schemas.microsoft.com/office/drawing/2014/main" id="{0EE03133-4B55-6D63-00E8-2FADDAC347B6}"/>
-              </a:ext>
-            </a:extLst>
-          </p:cNvPr>
-          <p:cNvSpPr>
-            <a:spLocks noGrp="1"/>
-          </p:cNvSpPr>
-          <p:nvPr>
-            <p:ph type="title"/>
-          </p:nvPr>
-        </p:nvSpPr>
-        <p:spPr/>
-        <p:txBody>
-          <a:bodyPr/>
-          <a:lstStyle/>
-          <a:p>
-            <a:r>
-              <a:rPr lang="en-US" dirty="0"/>
-              <a:t>Environmental variables</a:t>
-            </a:r>
-          </a:p>
-        </p:txBody>
-      </p:sp>
-      <p:sp>
-        <p:nvSpPr>
-          <p:cNvPr id="3" name="Content Placeholder 2">
-            <a:extLst>
-              <a:ext uri="{FF2B5EF4-FFF2-40B4-BE49-F238E27FC236}">
-                <a16:creationId xmlns:a16="http://schemas.microsoft.com/office/drawing/2014/main" id="{633E4DD6-2D20-CB12-42C1-BE793AD1BCE9}"/>
-              </a:ext>
-            </a:extLst>
-          </p:cNvPr>
-          <p:cNvSpPr>
-            <a:spLocks noGrp="1"/>
-          </p:cNvSpPr>
-          <p:nvPr>
-            <p:ph idx="1"/>
-          </p:nvPr>
-        </p:nvSpPr>
-        <p:spPr/>
-        <p:txBody>
-          <a:bodyPr/>
-          <a:lstStyle/>
-          <a:p>
-            <a:r>
-              <a:rPr lang="en-US" dirty="0"/>
-              <a:t>When you type a command at the terminal and it executes, what is actually happening?</a:t>
-            </a:r>
-          </a:p>
-          <a:p>
-            <a:pPr lvl="1"/>
-            <a:r>
-              <a:rPr lang="en-US" dirty="0"/>
-              <a:t>E.g. `</a:t>
-            </a:r>
-            <a:r>
-              <a:rPr lang="en-US" dirty="0" err="1"/>
-              <a:t>ls`</a:t>
-            </a:r>
-            <a:endParaRPr lang="en-US" dirty="0"/>
-          </a:p>
-          <a:p>
-            <a:r>
-              <a:rPr lang="en-US" dirty="0"/>
-              <a:t>Or, when you type a command and you get a “command not found” error even </a:t>
-            </a:r>
-            <a:r>
-              <a:rPr lang="en-US" dirty="0" err="1"/>
-              <a:t>tho</a:t>
-            </a:r>
-            <a:r>
-              <a:rPr lang="en-US" dirty="0"/>
-              <a:t> you’ve installed it, why is that?</a:t>
-            </a:r>
-          </a:p>
-          <a:p>
-            <a:r>
-              <a:rPr lang="en-US" dirty="0"/>
-              <a:t>“Behind the scenes” the shell sets variables that contain important configuration data (paths to executables, </a:t>
-            </a:r>
-            <a:r>
-              <a:rPr lang="en-US" dirty="0" err="1"/>
-              <a:t>etc</a:t>
-            </a:r>
-            <a:r>
-              <a:rPr lang="en-US" dirty="0"/>
-              <a:t>)</a:t>
-            </a:r>
-          </a:p>
-          <a:p>
-            <a:r>
-              <a:rPr lang="en-US" b="1" i="1" dirty="0"/>
-              <a:t>Environmental variables </a:t>
-            </a:r>
-          </a:p>
-          <a:p>
-            <a:pPr lvl="1"/>
-            <a:r>
-              <a:rPr lang="en-US" dirty="0"/>
-              <a:t>Inherited by all child processes upon shell startup</a:t>
-            </a:r>
-          </a:p>
-        </p:txBody>
-      </p:sp>
-    </p:spTree>
-    <p:extLst>
-      <p:ext uri="{BB962C8B-B14F-4D97-AF65-F5344CB8AC3E}">
-        <p14:creationId xmlns:p14="http://schemas.microsoft.com/office/powerpoint/2010/main" val="258523420"/>
-      </p:ext>
-    </p:extLst>
-  </p:cSld>
-  <p:clrMapOvr>
-    <a:masterClrMapping/>
-  </p:clrMapOvr>
-</p:sld>
-</file>
-
-<file path=ppt/slides/slide20.xml><?xml version="1.0" encoding="utf-8"?>
+<file path=ppt/slides/slide24.xml><?xml version="1.0" encoding="utf-8"?>
 <p:sld xmlns:a="http://schemas.openxmlformats.org/drawingml/2006/main" xmlns:r="http://schemas.openxmlformats.org/officeDocument/2006/relationships" xmlns:p="http://schemas.openxmlformats.org/presentationml/2006/main">
   <p:cSld>
     <p:spTree>
@@ -5657,7 +6960,7 @@
 </p:sld>
 </file>
 
-<file path=ppt/slides/slide21.xml><?xml version="1.0" encoding="utf-8"?>
+<file path=ppt/slides/slide25.xml><?xml version="1.0" encoding="utf-8"?>
 <p:sld xmlns:a="http://schemas.openxmlformats.org/drawingml/2006/main" xmlns:r="http://schemas.openxmlformats.org/officeDocument/2006/relationships" xmlns:p="http://schemas.openxmlformats.org/presentationml/2006/main">
   <p:cSld>
     <p:spTree>
@@ -5777,7 +7080,7 @@
 </p:sld>
 </file>
 
-<file path=ppt/slides/slide22.xml><?xml version="1.0" encoding="utf-8"?>
+<file path=ppt/slides/slide26.xml><?xml version="1.0" encoding="utf-8"?>
 <p:sld xmlns:a="http://schemas.openxmlformats.org/drawingml/2006/main" xmlns:r="http://schemas.openxmlformats.org/officeDocument/2006/relationships" xmlns:p="http://schemas.openxmlformats.org/presentationml/2006/main">
   <p:cSld>
     <p:spTree>
@@ -5904,7 +7207,7 @@
 </p:sld>
 </file>
 
-<file path=ppt/slides/slide23.xml><?xml version="1.0" encoding="utf-8"?>
+<file path=ppt/slides/slide27.xml><?xml version="1.0" encoding="utf-8"?>
 <p:sld xmlns:a="http://schemas.openxmlformats.org/drawingml/2006/main" xmlns:r="http://schemas.openxmlformats.org/officeDocument/2006/relationships" xmlns:p="http://schemas.openxmlformats.org/presentationml/2006/main">
   <p:cSld>
     <p:spTree>
@@ -5996,7 +7299,7 @@
 </p:sld>
 </file>
 
-<file path=ppt/slides/slide24.xml><?xml version="1.0" encoding="utf-8"?>
+<file path=ppt/slides/slide28.xml><?xml version="1.0" encoding="utf-8"?>
 <p:sld xmlns:a="http://schemas.openxmlformats.org/drawingml/2006/main" xmlns:r="http://schemas.openxmlformats.org/officeDocument/2006/relationships" xmlns:p="http://schemas.openxmlformats.org/presentationml/2006/main">
   <p:cSld>
     <p:spTree>
@@ -6098,6 +7401,1406 @@
   <p:cSld>
     <p:spTree>
       <p:nvGrpSpPr>
+        <p:cNvPr id="1" name="">
+          <a:extLst>
+            <a:ext uri="{FF2B5EF4-FFF2-40B4-BE49-F238E27FC236}">
+              <a16:creationId xmlns:a16="http://schemas.microsoft.com/office/drawing/2014/main" id="{C5C4B9C2-C621-AE15-06D9-A47037A493B4}"/>
+            </a:ext>
+          </a:extLst>
+        </p:cNvPr>
+        <p:cNvGrpSpPr/>
+        <p:nvPr/>
+      </p:nvGrpSpPr>
+      <p:grpSpPr>
+        <a:xfrm>
+          <a:off x="0" y="0"/>
+          <a:ext cx="0" cy="0"/>
+          <a:chOff x="0" y="0"/>
+          <a:chExt cx="0" cy="0"/>
+        </a:xfrm>
+      </p:grpSpPr>
+      <p:sp>
+        <p:nvSpPr>
+          <p:cNvPr id="2" name="Title 1">
+            <a:extLst>
+              <a:ext uri="{FF2B5EF4-FFF2-40B4-BE49-F238E27FC236}">
+                <a16:creationId xmlns:a16="http://schemas.microsoft.com/office/drawing/2014/main" id="{4BC00AA1-FB47-5B67-FD98-A9B66902967B}"/>
+              </a:ext>
+            </a:extLst>
+          </p:cNvPr>
+          <p:cNvSpPr>
+            <a:spLocks noGrp="1"/>
+          </p:cNvSpPr>
+          <p:nvPr>
+            <p:ph type="title"/>
+          </p:nvPr>
+        </p:nvSpPr>
+        <p:spPr/>
+        <p:txBody>
+          <a:bodyPr/>
+          <a:lstStyle/>
+          <a:p>
+            <a:r>
+              <a:rPr lang="en-US"/>
+              <a:t>All progams live somewhere in your computer</a:t>
+            </a:r>
+          </a:p>
+        </p:txBody>
+      </p:sp>
+      <p:pic>
+        <p:nvPicPr>
+          <p:cNvPr id="5" name="Content Placeholder 4" descr="A drawing of a computer with a speech bubble&#10;&#10;AI-generated content may be incorrect.">
+            <a:extLst>
+              <a:ext uri="{FF2B5EF4-FFF2-40B4-BE49-F238E27FC236}">
+                <a16:creationId xmlns:a16="http://schemas.microsoft.com/office/drawing/2014/main" id="{E337F20B-3F99-669F-62EC-4B9232153736}"/>
+              </a:ext>
+            </a:extLst>
+          </p:cNvPr>
+          <p:cNvPicPr>
+            <a:picLocks noGrp="1" noChangeAspect="1"/>
+          </p:cNvPicPr>
+          <p:nvPr>
+            <p:ph idx="1"/>
+          </p:nvPr>
+        </p:nvPicPr>
+        <p:blipFill>
+          <a:blip r:embed="rId2"/>
+          <a:stretch>
+            <a:fillRect/>
+          </a:stretch>
+        </p:blipFill>
+        <p:spPr>
+          <a:xfrm>
+            <a:off x="174812" y="2141537"/>
+            <a:ext cx="4351338" cy="4351338"/>
+          </a:xfrm>
+        </p:spPr>
+      </p:pic>
+      <p:sp>
+        <p:nvSpPr>
+          <p:cNvPr id="6" name="TextBox 5">
+            <a:extLst>
+              <a:ext uri="{FF2B5EF4-FFF2-40B4-BE49-F238E27FC236}">
+                <a16:creationId xmlns:a16="http://schemas.microsoft.com/office/drawing/2014/main" id="{E1DE6893-722F-BF68-DD48-5DD62B4C08DB}"/>
+              </a:ext>
+            </a:extLst>
+          </p:cNvPr>
+          <p:cNvSpPr txBox="1"/>
+          <p:nvPr/>
+        </p:nvSpPr>
+        <p:spPr>
+          <a:xfrm>
+            <a:off x="699247" y="3288414"/>
+            <a:ext cx="1877437" cy="400110"/>
+          </a:xfrm>
+          <a:prstGeom prst="rect">
+            <a:avLst/>
+          </a:prstGeom>
+          <a:noFill/>
+        </p:spPr>
+        <p:txBody>
+          <a:bodyPr wrap="none" rtlCol="0">
+            <a:spAutoFit/>
+          </a:bodyPr>
+          <a:lstStyle/>
+          <a:p>
+            <a:r>
+              <a:rPr lang="en-US" sz="2000">
+                <a:latin typeface="Menlo" panose="020B0609030804020204" pitchFamily="49" charset="0"/>
+                <a:ea typeface="Menlo" panose="020B0609030804020204" pitchFamily="49" charset="0"/>
+                <a:cs typeface="Menlo" panose="020B0609030804020204" pitchFamily="49" charset="0"/>
+              </a:rPr>
+              <a:t>[gregg]$ ls</a:t>
+            </a:r>
+          </a:p>
+        </p:txBody>
+      </p:sp>
+      <p:pic>
+        <p:nvPicPr>
+          <p:cNvPr id="8" name="Graphic 7" descr="Folder Search with solid fill">
+            <a:extLst>
+              <a:ext uri="{FF2B5EF4-FFF2-40B4-BE49-F238E27FC236}">
+                <a16:creationId xmlns:a16="http://schemas.microsoft.com/office/drawing/2014/main" id="{F5368EBA-1C1B-949F-7BA0-45B23330ADDB}"/>
+              </a:ext>
+            </a:extLst>
+          </p:cNvPr>
+          <p:cNvPicPr>
+            <a:picLocks noChangeAspect="1"/>
+          </p:cNvPicPr>
+          <p:nvPr/>
+        </p:nvPicPr>
+        <p:blipFill>
+          <a:blip r:embed="rId3">
+            <a:extLst>
+              <a:ext uri="{96DAC541-7B7A-43D3-8B79-37D633B846F1}">
+                <asvg:svgBlip xmlns:asvg="http://schemas.microsoft.com/office/drawing/2016/SVG/main" r:embed="rId4"/>
+              </a:ext>
+            </a:extLst>
+          </a:blip>
+          <a:stretch>
+            <a:fillRect/>
+          </a:stretch>
+        </p:blipFill>
+        <p:spPr>
+          <a:xfrm>
+            <a:off x="5638800" y="2114643"/>
+            <a:ext cx="914400" cy="914400"/>
+          </a:xfrm>
+          <a:prstGeom prst="rect">
+            <a:avLst/>
+          </a:prstGeom>
+        </p:spPr>
+      </p:pic>
+      <p:cxnSp>
+        <p:nvCxnSpPr>
+          <p:cNvPr id="12" name="Elbow Connector 11">
+            <a:extLst>
+              <a:ext uri="{FF2B5EF4-FFF2-40B4-BE49-F238E27FC236}">
+                <a16:creationId xmlns:a16="http://schemas.microsoft.com/office/drawing/2014/main" id="{E1C7597E-7189-7F2D-9D7E-DCFC18B092B2}"/>
+              </a:ext>
+            </a:extLst>
+          </p:cNvPr>
+          <p:cNvCxnSpPr>
+            <a:stCxn id="5" idx="3"/>
+            <a:endCxn id="8" idx="1"/>
+          </p:cNvCxnSpPr>
+          <p:nvPr/>
+        </p:nvCxnSpPr>
+        <p:spPr>
+          <a:xfrm flipV="1">
+            <a:off x="4526150" y="2571843"/>
+            <a:ext cx="1112650" cy="1745363"/>
+          </a:xfrm>
+          <a:prstGeom prst="bentConnector3">
+            <a:avLst/>
+          </a:prstGeom>
+          <a:ln>
+            <a:tailEnd type="triangle"/>
+          </a:ln>
+        </p:spPr>
+        <p:style>
+          <a:lnRef idx="2">
+            <a:schemeClr val="accent1"/>
+          </a:lnRef>
+          <a:fillRef idx="0">
+            <a:schemeClr val="accent1"/>
+          </a:fillRef>
+          <a:effectRef idx="1">
+            <a:schemeClr val="accent1"/>
+          </a:effectRef>
+          <a:fontRef idx="minor">
+            <a:schemeClr val="tx1"/>
+          </a:fontRef>
+        </p:style>
+      </p:cxnSp>
+      <p:pic>
+        <p:nvPicPr>
+          <p:cNvPr id="13" name="Picture 4" descr="Beige Folder Icon for Mac | Customizable and High-Quality">
+            <a:extLst>
+              <a:ext uri="{FF2B5EF4-FFF2-40B4-BE49-F238E27FC236}">
+                <a16:creationId xmlns:a16="http://schemas.microsoft.com/office/drawing/2014/main" id="{2EDB3F06-CE4D-7AC4-DB07-BFD4599E75A7}"/>
+              </a:ext>
+            </a:extLst>
+          </p:cNvPr>
+          <p:cNvPicPr>
+            <a:picLocks noChangeAspect="1" noChangeArrowheads="1"/>
+          </p:cNvPicPr>
+          <p:nvPr/>
+        </p:nvPicPr>
+        <p:blipFill>
+          <a:blip r:embed="rId5">
+            <a:extLst>
+              <a:ext uri="{28A0092B-C50C-407E-A947-70E740481C1C}">
+                <a14:useLocalDpi xmlns:a14="http://schemas.microsoft.com/office/drawing/2010/main" val="0"/>
+              </a:ext>
+            </a:extLst>
+          </a:blip>
+          <a:srcRect/>
+          <a:stretch>
+            <a:fillRect/>
+          </a:stretch>
+        </p:blipFill>
+        <p:spPr bwMode="auto">
+          <a:xfrm>
+            <a:off x="9332553" y="2144618"/>
+            <a:ext cx="793750" cy="793750"/>
+          </a:xfrm>
+          <a:prstGeom prst="rect">
+            <a:avLst/>
+          </a:prstGeom>
+          <a:noFill/>
+          <a:extLst>
+            <a:ext uri="{909E8E84-426E-40DD-AFC4-6F175D3DCCD1}">
+              <a14:hiddenFill xmlns:a14="http://schemas.microsoft.com/office/drawing/2010/main">
+                <a:solidFill>
+                  <a:srgbClr val="FFFFFF"/>
+                </a:solidFill>
+              </a14:hiddenFill>
+            </a:ext>
+          </a:extLst>
+        </p:spPr>
+      </p:pic>
+      <p:sp>
+        <p:nvSpPr>
+          <p:cNvPr id="14" name="TextBox 13">
+            <a:extLst>
+              <a:ext uri="{FF2B5EF4-FFF2-40B4-BE49-F238E27FC236}">
+                <a16:creationId xmlns:a16="http://schemas.microsoft.com/office/drawing/2014/main" id="{603F5B8B-BE13-5E69-BFB3-8C6AFC407B56}"/>
+              </a:ext>
+            </a:extLst>
+          </p:cNvPr>
+          <p:cNvSpPr txBox="1"/>
+          <p:nvPr/>
+        </p:nvSpPr>
+        <p:spPr>
+          <a:xfrm>
+            <a:off x="9253178" y="2387177"/>
+            <a:ext cx="952500" cy="369332"/>
+          </a:xfrm>
+          <a:prstGeom prst="rect">
+            <a:avLst/>
+          </a:prstGeom>
+          <a:noFill/>
+        </p:spPr>
+        <p:txBody>
+          <a:bodyPr wrap="square" rtlCol="0">
+            <a:spAutoFit/>
+          </a:bodyPr>
+          <a:lstStyle/>
+          <a:p>
+            <a:pPr algn="ctr"/>
+            <a:r>
+              <a:rPr lang="en-US" dirty="0">
+                <a:latin typeface="Source Sans Pro" panose="020B0503030403020204" pitchFamily="34" charset="0"/>
+                <a:ea typeface="Source Sans Pro" panose="020B0503030403020204" pitchFamily="34" charset="0"/>
+              </a:rPr>
+              <a:t>/bin/</a:t>
+            </a:r>
+            <a:endParaRPr lang="en-US" sz="3600" dirty="0">
+              <a:latin typeface="Source Sans Pro" panose="020B0503030403020204" pitchFamily="34" charset="0"/>
+              <a:ea typeface="Source Sans Pro" panose="020B0503030403020204" pitchFamily="34" charset="0"/>
+            </a:endParaRPr>
+          </a:p>
+        </p:txBody>
+      </p:sp>
+      <p:cxnSp>
+        <p:nvCxnSpPr>
+          <p:cNvPr id="18" name="Straight Arrow Connector 17">
+            <a:extLst>
+              <a:ext uri="{FF2B5EF4-FFF2-40B4-BE49-F238E27FC236}">
+                <a16:creationId xmlns:a16="http://schemas.microsoft.com/office/drawing/2014/main" id="{7DA5DC7C-B020-9AB4-737F-E4EABD4AC2A4}"/>
+              </a:ext>
+            </a:extLst>
+          </p:cNvPr>
+          <p:cNvCxnSpPr>
+            <a:cxnSpLocks/>
+            <a:endCxn id="14" idx="1"/>
+          </p:cNvCxnSpPr>
+          <p:nvPr/>
+        </p:nvCxnSpPr>
+        <p:spPr>
+          <a:xfrm>
+            <a:off x="6553200" y="2571843"/>
+            <a:ext cx="2699978" cy="0"/>
+          </a:xfrm>
+          <a:prstGeom prst="straightConnector1">
+            <a:avLst/>
+          </a:prstGeom>
+          <a:ln>
+            <a:tailEnd type="triangle"/>
+          </a:ln>
+        </p:spPr>
+        <p:style>
+          <a:lnRef idx="2">
+            <a:schemeClr val="accent1"/>
+          </a:lnRef>
+          <a:fillRef idx="0">
+            <a:schemeClr val="accent1"/>
+          </a:fillRef>
+          <a:effectRef idx="1">
+            <a:schemeClr val="accent1"/>
+          </a:effectRef>
+          <a:fontRef idx="minor">
+            <a:schemeClr val="tx1"/>
+          </a:fontRef>
+        </p:style>
+      </p:cxnSp>
+      <p:grpSp>
+        <p:nvGrpSpPr>
+          <p:cNvPr id="20" name="Group 19">
+            <a:extLst>
+              <a:ext uri="{FF2B5EF4-FFF2-40B4-BE49-F238E27FC236}">
+                <a16:creationId xmlns:a16="http://schemas.microsoft.com/office/drawing/2014/main" id="{B532C612-FDF5-AAA6-4E85-9AB95E93E485}"/>
+              </a:ext>
+            </a:extLst>
+          </p:cNvPr>
+          <p:cNvGrpSpPr/>
+          <p:nvPr/>
+        </p:nvGrpSpPr>
+        <p:grpSpPr>
+          <a:xfrm>
+            <a:off x="9448341" y="3421781"/>
+            <a:ext cx="562174" cy="793750"/>
+            <a:chOff x="7387881" y="3180927"/>
+            <a:chExt cx="793750" cy="1096011"/>
+          </a:xfrm>
+        </p:grpSpPr>
+        <p:pic>
+          <p:nvPicPr>
+            <p:cNvPr id="16" name="Picture 15">
+              <a:extLst>
+                <a:ext uri="{FF2B5EF4-FFF2-40B4-BE49-F238E27FC236}">
+                  <a16:creationId xmlns:a16="http://schemas.microsoft.com/office/drawing/2014/main" id="{0215CCD6-B695-B77D-865E-D56EB0468819}"/>
+                </a:ext>
+              </a:extLst>
+            </p:cNvPr>
+            <p:cNvPicPr>
+              <a:picLocks noChangeAspect="1"/>
+            </p:cNvPicPr>
+            <p:nvPr/>
+          </p:nvPicPr>
+          <p:blipFill>
+            <a:blip r:embed="rId6"/>
+            <a:srcRect l="3700" t="52231" r="80037" b="2857"/>
+            <a:stretch>
+              <a:fillRect/>
+            </a:stretch>
+          </p:blipFill>
+          <p:spPr>
+            <a:xfrm>
+              <a:off x="7387881" y="3180927"/>
+              <a:ext cx="793750" cy="1096011"/>
+            </a:xfrm>
+            <a:prstGeom prst="rect">
+              <a:avLst/>
+            </a:prstGeom>
+          </p:spPr>
+        </p:pic>
+        <p:sp>
+          <p:nvSpPr>
+            <p:cNvPr id="19" name="TextBox 18">
+              <a:extLst>
+                <a:ext uri="{FF2B5EF4-FFF2-40B4-BE49-F238E27FC236}">
+                  <a16:creationId xmlns:a16="http://schemas.microsoft.com/office/drawing/2014/main" id="{9912915E-CEE8-4459-CB7B-34685C03B214}"/>
+                </a:ext>
+              </a:extLst>
+            </p:cNvPr>
+            <p:cNvSpPr txBox="1"/>
+            <p:nvPr/>
+          </p:nvSpPr>
+          <p:spPr>
+            <a:xfrm>
+              <a:off x="7459706" y="4000526"/>
+              <a:ext cx="603019" cy="215444"/>
+            </a:xfrm>
+            <a:prstGeom prst="rect">
+              <a:avLst/>
+            </a:prstGeom>
+            <a:solidFill>
+              <a:srgbClr val="EE1C23"/>
+            </a:solidFill>
+          </p:spPr>
+          <p:txBody>
+            <a:bodyPr wrap="square" lIns="0" tIns="0" rIns="0" bIns="0" rtlCol="0">
+              <a:spAutoFit/>
+            </a:bodyPr>
+            <a:lstStyle/>
+            <a:p>
+              <a:pPr algn="ctr"/>
+              <a:r>
+                <a:rPr lang="en-US" sz="1400" b="1">
+                  <a:solidFill>
+                    <a:schemeClr val="bg1"/>
+                  </a:solidFill>
+                  <a:latin typeface="Menlo" panose="020B0609030804020204" pitchFamily="49" charset="0"/>
+                  <a:ea typeface="Menlo" panose="020B0609030804020204" pitchFamily="49" charset="0"/>
+                  <a:cs typeface="Menlo" panose="020B0609030804020204" pitchFamily="49" charset="0"/>
+                </a:rPr>
+                <a:t>ls</a:t>
+              </a:r>
+            </a:p>
+          </p:txBody>
+        </p:sp>
+      </p:grpSp>
+      <p:cxnSp>
+        <p:nvCxnSpPr>
+          <p:cNvPr id="21" name="Straight Arrow Connector 20">
+            <a:extLst>
+              <a:ext uri="{FF2B5EF4-FFF2-40B4-BE49-F238E27FC236}">
+                <a16:creationId xmlns:a16="http://schemas.microsoft.com/office/drawing/2014/main" id="{C30B1371-E8B2-653D-A293-0A5316726239}"/>
+              </a:ext>
+            </a:extLst>
+          </p:cNvPr>
+          <p:cNvCxnSpPr>
+            <a:cxnSpLocks/>
+            <a:stCxn id="13" idx="2"/>
+            <a:endCxn id="16" idx="0"/>
+          </p:cNvCxnSpPr>
+          <p:nvPr/>
+        </p:nvCxnSpPr>
+        <p:spPr>
+          <a:xfrm>
+            <a:off x="9729428" y="2938368"/>
+            <a:ext cx="0" cy="483413"/>
+          </a:xfrm>
+          <a:prstGeom prst="straightConnector1">
+            <a:avLst/>
+          </a:prstGeom>
+          <a:ln>
+            <a:tailEnd type="triangle"/>
+          </a:ln>
+        </p:spPr>
+        <p:style>
+          <a:lnRef idx="2">
+            <a:schemeClr val="accent1"/>
+          </a:lnRef>
+          <a:fillRef idx="0">
+            <a:schemeClr val="accent1"/>
+          </a:fillRef>
+          <a:effectRef idx="1">
+            <a:schemeClr val="accent1"/>
+          </a:effectRef>
+          <a:fontRef idx="minor">
+            <a:schemeClr val="tx1"/>
+          </a:fontRef>
+        </p:style>
+      </p:cxnSp>
+      <p:pic>
+        <p:nvPicPr>
+          <p:cNvPr id="4" name="Picture 3" descr="A close-up of a black and white text&#10;&#10;AI-generated content may be incorrect.">
+            <a:extLst>
+              <a:ext uri="{FF2B5EF4-FFF2-40B4-BE49-F238E27FC236}">
+                <a16:creationId xmlns:a16="http://schemas.microsoft.com/office/drawing/2014/main" id="{C3EF7F38-1469-89FF-5642-E41D00ADED6A}"/>
+              </a:ext>
+            </a:extLst>
+          </p:cNvPr>
+          <p:cNvPicPr>
+            <a:picLocks noChangeAspect="1"/>
+          </p:cNvPicPr>
+          <p:nvPr/>
+        </p:nvPicPr>
+        <p:blipFill>
+          <a:blip r:embed="rId7"/>
+          <a:stretch>
+            <a:fillRect/>
+          </a:stretch>
+        </p:blipFill>
+        <p:spPr>
+          <a:xfrm>
+            <a:off x="5638800" y="3724662"/>
+            <a:ext cx="3149600" cy="800100"/>
+          </a:xfrm>
+          <a:prstGeom prst="rect">
+            <a:avLst/>
+          </a:prstGeom>
+        </p:spPr>
+      </p:pic>
+    </p:spTree>
+    <p:extLst>
+      <p:ext uri="{BB962C8B-B14F-4D97-AF65-F5344CB8AC3E}">
+        <p14:creationId xmlns:p14="http://schemas.microsoft.com/office/powerpoint/2010/main" val="4271037738"/>
+      </p:ext>
+    </p:extLst>
+  </p:cSld>
+  <p:clrMapOvr>
+    <a:masterClrMapping/>
+  </p:clrMapOvr>
+</p:sld>
+</file>
+
+<file path=ppt/slides/slide4.xml><?xml version="1.0" encoding="utf-8"?>
+<p:sld xmlns:a="http://schemas.openxmlformats.org/drawingml/2006/main" xmlns:r="http://schemas.openxmlformats.org/officeDocument/2006/relationships" xmlns:p="http://schemas.openxmlformats.org/presentationml/2006/main">
+  <p:cSld>
+    <p:spTree>
+      <p:nvGrpSpPr>
+        <p:cNvPr id="1" name="">
+          <a:extLst>
+            <a:ext uri="{FF2B5EF4-FFF2-40B4-BE49-F238E27FC236}">
+              <a16:creationId xmlns:a16="http://schemas.microsoft.com/office/drawing/2014/main" id="{2324654C-6D6C-A53C-BB82-DBF282105AB2}"/>
+            </a:ext>
+          </a:extLst>
+        </p:cNvPr>
+        <p:cNvGrpSpPr/>
+        <p:nvPr/>
+      </p:nvGrpSpPr>
+      <p:grpSpPr>
+        <a:xfrm>
+          <a:off x="0" y="0"/>
+          <a:ext cx="0" cy="0"/>
+          <a:chOff x="0" y="0"/>
+          <a:chExt cx="0" cy="0"/>
+        </a:xfrm>
+      </p:grpSpPr>
+      <p:sp>
+        <p:nvSpPr>
+          <p:cNvPr id="2" name="Title 1">
+            <a:extLst>
+              <a:ext uri="{FF2B5EF4-FFF2-40B4-BE49-F238E27FC236}">
+                <a16:creationId xmlns:a16="http://schemas.microsoft.com/office/drawing/2014/main" id="{F864CF5D-235A-2DAA-A1C0-367845D3BB76}"/>
+              </a:ext>
+            </a:extLst>
+          </p:cNvPr>
+          <p:cNvSpPr>
+            <a:spLocks noGrp="1"/>
+          </p:cNvSpPr>
+          <p:nvPr>
+            <p:ph type="title"/>
+          </p:nvPr>
+        </p:nvSpPr>
+        <p:spPr/>
+        <p:txBody>
+          <a:bodyPr/>
+          <a:lstStyle/>
+          <a:p>
+            <a:r>
+              <a:rPr lang="en-US"/>
+              <a:t>$PATH is list of directories to search</a:t>
+            </a:r>
+          </a:p>
+        </p:txBody>
+      </p:sp>
+      <p:pic>
+        <p:nvPicPr>
+          <p:cNvPr id="5" name="Content Placeholder 4" descr="A drawing of a computer with a speech bubble&#10;&#10;AI-generated content may be incorrect.">
+            <a:extLst>
+              <a:ext uri="{FF2B5EF4-FFF2-40B4-BE49-F238E27FC236}">
+                <a16:creationId xmlns:a16="http://schemas.microsoft.com/office/drawing/2014/main" id="{735F6FF6-CCC5-6106-ED7F-86062E5175DE}"/>
+              </a:ext>
+            </a:extLst>
+          </p:cNvPr>
+          <p:cNvPicPr>
+            <a:picLocks noGrp="1" noChangeAspect="1"/>
+          </p:cNvPicPr>
+          <p:nvPr>
+            <p:ph idx="1"/>
+          </p:nvPr>
+        </p:nvPicPr>
+        <p:blipFill>
+          <a:blip r:embed="rId2"/>
+          <a:stretch>
+            <a:fillRect/>
+          </a:stretch>
+        </p:blipFill>
+        <p:spPr>
+          <a:xfrm>
+            <a:off x="174812" y="2141537"/>
+            <a:ext cx="4351338" cy="4351338"/>
+          </a:xfrm>
+        </p:spPr>
+      </p:pic>
+      <p:sp>
+        <p:nvSpPr>
+          <p:cNvPr id="6" name="TextBox 5">
+            <a:extLst>
+              <a:ext uri="{FF2B5EF4-FFF2-40B4-BE49-F238E27FC236}">
+                <a16:creationId xmlns:a16="http://schemas.microsoft.com/office/drawing/2014/main" id="{CD608A8E-E428-331A-0920-2A3AAC93A925}"/>
+              </a:ext>
+            </a:extLst>
+          </p:cNvPr>
+          <p:cNvSpPr txBox="1"/>
+          <p:nvPr/>
+        </p:nvSpPr>
+        <p:spPr>
+          <a:xfrm>
+            <a:off x="699247" y="3288414"/>
+            <a:ext cx="1877437" cy="400110"/>
+          </a:xfrm>
+          <a:prstGeom prst="rect">
+            <a:avLst/>
+          </a:prstGeom>
+          <a:noFill/>
+        </p:spPr>
+        <p:txBody>
+          <a:bodyPr wrap="none" rtlCol="0">
+            <a:spAutoFit/>
+          </a:bodyPr>
+          <a:lstStyle/>
+          <a:p>
+            <a:r>
+              <a:rPr lang="en-US" sz="2000">
+                <a:latin typeface="Menlo" panose="020B0609030804020204" pitchFamily="49" charset="0"/>
+                <a:ea typeface="Menlo" panose="020B0609030804020204" pitchFamily="49" charset="0"/>
+                <a:cs typeface="Menlo" panose="020B0609030804020204" pitchFamily="49" charset="0"/>
+              </a:rPr>
+              <a:t>[gregg]$ ls</a:t>
+            </a:r>
+          </a:p>
+        </p:txBody>
+      </p:sp>
+      <p:pic>
+        <p:nvPicPr>
+          <p:cNvPr id="8" name="Graphic 7" descr="Folder Search with solid fill">
+            <a:extLst>
+              <a:ext uri="{FF2B5EF4-FFF2-40B4-BE49-F238E27FC236}">
+                <a16:creationId xmlns:a16="http://schemas.microsoft.com/office/drawing/2014/main" id="{E10395E1-EB12-07CB-FB0B-37F06044AA3B}"/>
+              </a:ext>
+            </a:extLst>
+          </p:cNvPr>
+          <p:cNvPicPr>
+            <a:picLocks noChangeAspect="1"/>
+          </p:cNvPicPr>
+          <p:nvPr/>
+        </p:nvPicPr>
+        <p:blipFill>
+          <a:blip r:embed="rId3">
+            <a:extLst>
+              <a:ext uri="{96DAC541-7B7A-43D3-8B79-37D633B846F1}">
+                <asvg:svgBlip xmlns:asvg="http://schemas.microsoft.com/office/drawing/2016/SVG/main" r:embed="rId4"/>
+              </a:ext>
+            </a:extLst>
+          </a:blip>
+          <a:stretch>
+            <a:fillRect/>
+          </a:stretch>
+        </p:blipFill>
+        <p:spPr>
+          <a:xfrm>
+            <a:off x="5638800" y="2114643"/>
+            <a:ext cx="914400" cy="914400"/>
+          </a:xfrm>
+          <a:prstGeom prst="rect">
+            <a:avLst/>
+          </a:prstGeom>
+        </p:spPr>
+      </p:pic>
+      <p:cxnSp>
+        <p:nvCxnSpPr>
+          <p:cNvPr id="12" name="Elbow Connector 11">
+            <a:extLst>
+              <a:ext uri="{FF2B5EF4-FFF2-40B4-BE49-F238E27FC236}">
+                <a16:creationId xmlns:a16="http://schemas.microsoft.com/office/drawing/2014/main" id="{29A6BEF4-3856-AA4D-A107-C2F69FA28C0A}"/>
+              </a:ext>
+            </a:extLst>
+          </p:cNvPr>
+          <p:cNvCxnSpPr>
+            <a:stCxn id="5" idx="3"/>
+            <a:endCxn id="8" idx="1"/>
+          </p:cNvCxnSpPr>
+          <p:nvPr/>
+        </p:nvCxnSpPr>
+        <p:spPr>
+          <a:xfrm flipV="1">
+            <a:off x="4526150" y="2571843"/>
+            <a:ext cx="1112650" cy="1745363"/>
+          </a:xfrm>
+          <a:prstGeom prst="bentConnector3">
+            <a:avLst/>
+          </a:prstGeom>
+          <a:ln>
+            <a:tailEnd type="triangle"/>
+          </a:ln>
+        </p:spPr>
+        <p:style>
+          <a:lnRef idx="2">
+            <a:schemeClr val="accent1"/>
+          </a:lnRef>
+          <a:fillRef idx="0">
+            <a:schemeClr val="accent1"/>
+          </a:fillRef>
+          <a:effectRef idx="1">
+            <a:schemeClr val="accent1"/>
+          </a:effectRef>
+          <a:fontRef idx="minor">
+            <a:schemeClr val="tx1"/>
+          </a:fontRef>
+        </p:style>
+      </p:cxnSp>
+      <p:pic>
+        <p:nvPicPr>
+          <p:cNvPr id="13" name="Picture 4" descr="Beige Folder Icon for Mac | Customizable and High-Quality">
+            <a:extLst>
+              <a:ext uri="{FF2B5EF4-FFF2-40B4-BE49-F238E27FC236}">
+                <a16:creationId xmlns:a16="http://schemas.microsoft.com/office/drawing/2014/main" id="{77F35104-FED9-21E2-12C4-A13C4D7C2ABE}"/>
+              </a:ext>
+            </a:extLst>
+          </p:cNvPr>
+          <p:cNvPicPr>
+            <a:picLocks noChangeAspect="1" noChangeArrowheads="1"/>
+          </p:cNvPicPr>
+          <p:nvPr/>
+        </p:nvPicPr>
+        <p:blipFill>
+          <a:blip r:embed="rId5">
+            <a:extLst>
+              <a:ext uri="{28A0092B-C50C-407E-A947-70E740481C1C}">
+                <a14:useLocalDpi xmlns:a14="http://schemas.microsoft.com/office/drawing/2010/main" val="0"/>
+              </a:ext>
+            </a:extLst>
+          </a:blip>
+          <a:srcRect/>
+          <a:stretch>
+            <a:fillRect/>
+          </a:stretch>
+        </p:blipFill>
+        <p:spPr bwMode="auto">
+          <a:xfrm>
+            <a:off x="9332553" y="2144618"/>
+            <a:ext cx="793750" cy="793750"/>
+          </a:xfrm>
+          <a:prstGeom prst="rect">
+            <a:avLst/>
+          </a:prstGeom>
+          <a:noFill/>
+          <a:extLst>
+            <a:ext uri="{909E8E84-426E-40DD-AFC4-6F175D3DCCD1}">
+              <a14:hiddenFill xmlns:a14="http://schemas.microsoft.com/office/drawing/2010/main">
+                <a:solidFill>
+                  <a:srgbClr val="FFFFFF"/>
+                </a:solidFill>
+              </a14:hiddenFill>
+            </a:ext>
+          </a:extLst>
+        </p:spPr>
+      </p:pic>
+      <p:sp>
+        <p:nvSpPr>
+          <p:cNvPr id="14" name="TextBox 13">
+            <a:extLst>
+              <a:ext uri="{FF2B5EF4-FFF2-40B4-BE49-F238E27FC236}">
+                <a16:creationId xmlns:a16="http://schemas.microsoft.com/office/drawing/2014/main" id="{68022EEE-DFEF-4BB6-4275-E63727A0DBD9}"/>
+              </a:ext>
+            </a:extLst>
+          </p:cNvPr>
+          <p:cNvSpPr txBox="1"/>
+          <p:nvPr/>
+        </p:nvSpPr>
+        <p:spPr>
+          <a:xfrm>
+            <a:off x="9253178" y="2387177"/>
+            <a:ext cx="952500" cy="369332"/>
+          </a:xfrm>
+          <a:prstGeom prst="rect">
+            <a:avLst/>
+          </a:prstGeom>
+          <a:noFill/>
+        </p:spPr>
+        <p:txBody>
+          <a:bodyPr wrap="square" rtlCol="0">
+            <a:spAutoFit/>
+          </a:bodyPr>
+          <a:lstStyle/>
+          <a:p>
+            <a:pPr algn="ctr"/>
+            <a:r>
+              <a:rPr lang="en-US" dirty="0">
+                <a:latin typeface="Source Sans Pro" panose="020B0503030403020204" pitchFamily="34" charset="0"/>
+                <a:ea typeface="Source Sans Pro" panose="020B0503030403020204" pitchFamily="34" charset="0"/>
+              </a:rPr>
+              <a:t>/bin/</a:t>
+            </a:r>
+            <a:endParaRPr lang="en-US" sz="3600" dirty="0">
+              <a:latin typeface="Source Sans Pro" panose="020B0503030403020204" pitchFamily="34" charset="0"/>
+              <a:ea typeface="Source Sans Pro" panose="020B0503030403020204" pitchFamily="34" charset="0"/>
+            </a:endParaRPr>
+          </a:p>
+        </p:txBody>
+      </p:sp>
+      <p:cxnSp>
+        <p:nvCxnSpPr>
+          <p:cNvPr id="18" name="Straight Arrow Connector 17">
+            <a:extLst>
+              <a:ext uri="{FF2B5EF4-FFF2-40B4-BE49-F238E27FC236}">
+                <a16:creationId xmlns:a16="http://schemas.microsoft.com/office/drawing/2014/main" id="{B5B7DEA8-89C1-FA35-1092-FE71851D4091}"/>
+              </a:ext>
+            </a:extLst>
+          </p:cNvPr>
+          <p:cNvCxnSpPr>
+            <a:cxnSpLocks/>
+            <a:endCxn id="14" idx="1"/>
+          </p:cNvCxnSpPr>
+          <p:nvPr/>
+        </p:nvCxnSpPr>
+        <p:spPr>
+          <a:xfrm>
+            <a:off x="6553200" y="2571843"/>
+            <a:ext cx="2699978" cy="0"/>
+          </a:xfrm>
+          <a:prstGeom prst="straightConnector1">
+            <a:avLst/>
+          </a:prstGeom>
+          <a:ln>
+            <a:tailEnd type="triangle"/>
+          </a:ln>
+        </p:spPr>
+        <p:style>
+          <a:lnRef idx="2">
+            <a:schemeClr val="accent1"/>
+          </a:lnRef>
+          <a:fillRef idx="0">
+            <a:schemeClr val="accent1"/>
+          </a:fillRef>
+          <a:effectRef idx="1">
+            <a:schemeClr val="accent1"/>
+          </a:effectRef>
+          <a:fontRef idx="minor">
+            <a:schemeClr val="tx1"/>
+          </a:fontRef>
+        </p:style>
+      </p:cxnSp>
+      <p:pic>
+        <p:nvPicPr>
+          <p:cNvPr id="4" name="Picture 3" descr="A screen shot of a computer screen&#10;&#10;AI-generated content may be incorrect.">
+            <a:extLst>
+              <a:ext uri="{FF2B5EF4-FFF2-40B4-BE49-F238E27FC236}">
+                <a16:creationId xmlns:a16="http://schemas.microsoft.com/office/drawing/2014/main" id="{A0AAED4F-64B9-FE6D-88A7-8E43E270B014}"/>
+              </a:ext>
+            </a:extLst>
+          </p:cNvPr>
+          <p:cNvPicPr>
+            <a:picLocks noChangeAspect="1"/>
+          </p:cNvPicPr>
+          <p:nvPr/>
+        </p:nvPicPr>
+        <p:blipFill>
+          <a:blip r:embed="rId6"/>
+          <a:stretch>
+            <a:fillRect/>
+          </a:stretch>
+        </p:blipFill>
+        <p:spPr>
+          <a:xfrm>
+            <a:off x="5331582" y="3029043"/>
+            <a:ext cx="5143213" cy="3398656"/>
+          </a:xfrm>
+          <a:prstGeom prst="rect">
+            <a:avLst/>
+          </a:prstGeom>
+        </p:spPr>
+      </p:pic>
+    </p:spTree>
+    <p:extLst>
+      <p:ext uri="{BB962C8B-B14F-4D97-AF65-F5344CB8AC3E}">
+        <p14:creationId xmlns:p14="http://schemas.microsoft.com/office/powerpoint/2010/main" val="2805477809"/>
+      </p:ext>
+    </p:extLst>
+  </p:cSld>
+  <p:clrMapOvr>
+    <a:masterClrMapping/>
+  </p:clrMapOvr>
+</p:sld>
+</file>
+
+<file path=ppt/slides/slide5.xml><?xml version="1.0" encoding="utf-8"?>
+<p:sld xmlns:a="http://schemas.openxmlformats.org/drawingml/2006/main" xmlns:r="http://schemas.openxmlformats.org/officeDocument/2006/relationships" xmlns:p="http://schemas.openxmlformats.org/presentationml/2006/main">
+  <p:cSld>
+    <p:spTree>
+      <p:nvGrpSpPr>
+        <p:cNvPr id="1" name=""/>
+        <p:cNvGrpSpPr/>
+        <p:nvPr/>
+      </p:nvGrpSpPr>
+      <p:grpSpPr>
+        <a:xfrm>
+          <a:off x="0" y="0"/>
+          <a:ext cx="0" cy="0"/>
+          <a:chOff x="0" y="0"/>
+          <a:chExt cx="0" cy="0"/>
+        </a:xfrm>
+      </p:grpSpPr>
+      <p:sp>
+        <p:nvSpPr>
+          <p:cNvPr id="2" name="Title 1">
+            <a:extLst>
+              <a:ext uri="{FF2B5EF4-FFF2-40B4-BE49-F238E27FC236}">
+                <a16:creationId xmlns:a16="http://schemas.microsoft.com/office/drawing/2014/main" id="{5CFC00AD-C4C7-D25B-7B11-406D194488CE}"/>
+              </a:ext>
+            </a:extLst>
+          </p:cNvPr>
+          <p:cNvSpPr>
+            <a:spLocks noGrp="1"/>
+          </p:cNvSpPr>
+          <p:nvPr>
+            <p:ph type="title"/>
+          </p:nvPr>
+        </p:nvSpPr>
+        <p:spPr/>
+        <p:txBody>
+          <a:bodyPr/>
+          <a:lstStyle/>
+          <a:p>
+            <a:r>
+              <a:rPr lang="en-US"/>
+              <a:t>Environmental variables</a:t>
+            </a:r>
+          </a:p>
+        </p:txBody>
+      </p:sp>
+      <p:sp>
+        <p:nvSpPr>
+          <p:cNvPr id="3" name="Content Placeholder 2">
+            <a:extLst>
+              <a:ext uri="{FF2B5EF4-FFF2-40B4-BE49-F238E27FC236}">
+                <a16:creationId xmlns:a16="http://schemas.microsoft.com/office/drawing/2014/main" id="{6C4FADDB-581D-EF4A-B959-D3FB63301201}"/>
+              </a:ext>
+            </a:extLst>
+          </p:cNvPr>
+          <p:cNvSpPr>
+            <a:spLocks noGrp="1"/>
+          </p:cNvSpPr>
+          <p:nvPr>
+            <p:ph idx="1"/>
+          </p:nvPr>
+        </p:nvSpPr>
+        <p:spPr>
+          <a:xfrm>
+            <a:off x="838200" y="1825625"/>
+            <a:ext cx="10515600" cy="621013"/>
+          </a:xfrm>
+        </p:spPr>
+        <p:txBody>
+          <a:bodyPr/>
+          <a:lstStyle/>
+          <a:p>
+            <a:pPr marL="0" indent="0">
+              <a:buNone/>
+            </a:pPr>
+            <a:r>
+              <a:rPr lang="en-US"/>
+              <a:t>Shortcuts/keywords that are assign on startup</a:t>
+            </a:r>
+          </a:p>
+          <a:p>
+            <a:endParaRPr lang="en-US"/>
+          </a:p>
+        </p:txBody>
+      </p:sp>
+      <p:graphicFrame>
+        <p:nvGraphicFramePr>
+          <p:cNvPr id="7" name="Table 6">
+            <a:extLst>
+              <a:ext uri="{FF2B5EF4-FFF2-40B4-BE49-F238E27FC236}">
+                <a16:creationId xmlns:a16="http://schemas.microsoft.com/office/drawing/2014/main" id="{50A8B417-A532-83EF-81F1-4FCA9D6ECA6E}"/>
+              </a:ext>
+            </a:extLst>
+          </p:cNvPr>
+          <p:cNvGraphicFramePr>
+            <a:graphicFrameLocks noGrp="1"/>
+          </p:cNvGraphicFramePr>
+          <p:nvPr>
+            <p:extLst>
+              <p:ext uri="{D42A27DB-BD31-4B8C-83A1-F6EECF244321}">
+                <p14:modId xmlns:p14="http://schemas.microsoft.com/office/powerpoint/2010/main" val="247032086"/>
+              </p:ext>
+            </p:extLst>
+          </p:nvPr>
+        </p:nvGraphicFramePr>
+        <p:xfrm>
+          <a:off x="1" y="3015482"/>
+          <a:ext cx="12191999" cy="2366512"/>
+        </p:xfrm>
+        <a:graphic>
+          <a:graphicData uri="http://schemas.openxmlformats.org/drawingml/2006/table">
+            <a:tbl>
+              <a:tblPr firstRow="1" bandRow="1">
+                <a:tableStyleId>{616DA210-FB5B-4158-B5E0-FEB733F419BA}</a:tableStyleId>
+              </a:tblPr>
+              <a:tblGrid>
+                <a:gridCol w="3855492">
+                  <a:extLst>
+                    <a:ext uri="{9D8B030D-6E8A-4147-A177-3AD203B41FA5}">
+                      <a16:colId xmlns:a16="http://schemas.microsoft.com/office/drawing/2014/main" val="3298165829"/>
+                    </a:ext>
+                  </a:extLst>
+                </a:gridCol>
+                <a:gridCol w="8336507">
+                  <a:extLst>
+                    <a:ext uri="{9D8B030D-6E8A-4147-A177-3AD203B41FA5}">
+                      <a16:colId xmlns:a16="http://schemas.microsoft.com/office/drawing/2014/main" val="677998999"/>
+                    </a:ext>
+                  </a:extLst>
+                </a:gridCol>
+              </a:tblGrid>
+              <a:tr h="530907">
+                <a:tc>
+                  <a:txBody>
+                    <a:bodyPr/>
+                    <a:lstStyle/>
+                    <a:p>
+                      <a:r>
+                        <a:rPr lang="en-US" sz="1600" b="0" dirty="0">
+                          <a:latin typeface="Consolas" panose="020B0609020204030204" pitchFamily="49" charset="0"/>
+                        </a:rPr>
+                        <a:t>$PATH</a:t>
+                      </a:r>
+                    </a:p>
+                  </a:txBody>
+                  <a:tcPr>
+                    <a:lnB w="12700" cap="flat" cmpd="sng" algn="ctr">
+                      <a:solidFill>
+                        <a:schemeClr val="tx1"/>
+                      </a:solidFill>
+                      <a:prstDash val="solid"/>
+                      <a:round/>
+                      <a:headEnd type="none" w="med" len="med"/>
+                      <a:tailEnd type="none" w="med" len="med"/>
+                    </a:lnB>
+                  </a:tcPr>
+                </a:tc>
+                <a:tc>
+                  <a:txBody>
+                    <a:bodyPr/>
+                    <a:lstStyle/>
+                    <a:p>
+                      <a:r>
+                        <a:rPr lang="en-US" sz="1600" b="1" dirty="0">
+                          <a:latin typeface="Consolas" panose="020B0609020204030204" pitchFamily="49" charset="0"/>
+                          <a:cs typeface="Consolas" panose="020B0609020204030204" pitchFamily="49" charset="0"/>
+                        </a:rPr>
+                        <a:t>A colon-separated list of directories that contain software</a:t>
+                      </a:r>
+                    </a:p>
+                  </a:txBody>
+                  <a:tcPr>
+                    <a:lnB w="12700" cap="flat" cmpd="sng" algn="ctr">
+                      <a:solidFill>
+                        <a:schemeClr val="tx1"/>
+                      </a:solidFill>
+                      <a:prstDash val="solid"/>
+                      <a:round/>
+                      <a:headEnd type="none" w="med" len="med"/>
+                      <a:tailEnd type="none" w="med" len="med"/>
+                    </a:lnB>
+                  </a:tcPr>
+                </a:tc>
+                <a:extLst>
+                  <a:ext uri="{0D108BD9-81ED-4DB2-BD59-A6C34878D82A}">
+                    <a16:rowId xmlns:a16="http://schemas.microsoft.com/office/drawing/2014/main" val="2477674686"/>
+                  </a:ext>
+                </a:extLst>
+              </a:tr>
+              <a:tr h="457200">
+                <a:tc>
+                  <a:txBody>
+                    <a:bodyPr/>
+                    <a:lstStyle/>
+                    <a:p>
+                      <a:r>
+                        <a:rPr lang="en-US" sz="1600" b="0" dirty="0">
+                          <a:latin typeface="Consolas" panose="020B0609020204030204" pitchFamily="49" charset="0"/>
+                        </a:rPr>
+                        <a:t>$HOME</a:t>
+                      </a:r>
+                    </a:p>
+                  </a:txBody>
+                  <a:tcPr>
+                    <a:lnT w="12700" cap="flat" cmpd="sng" algn="ctr">
+                      <a:solidFill>
+                        <a:schemeClr val="tx1"/>
+                      </a:solidFill>
+                      <a:prstDash val="solid"/>
+                      <a:round/>
+                      <a:headEnd type="none" w="med" len="med"/>
+                      <a:tailEnd type="none" w="med" len="med"/>
+                    </a:lnT>
+                  </a:tcPr>
+                </a:tc>
+                <a:tc>
+                  <a:txBody>
+                    <a:bodyPr/>
+                    <a:lstStyle/>
+                    <a:p>
+                      <a:r>
+                        <a:rPr lang="en-US" sz="1600" b="1" dirty="0">
+                          <a:latin typeface="Consolas" panose="020B0609020204030204" pitchFamily="49" charset="0"/>
+                          <a:ea typeface="Source Sans Pro" panose="020B0503030403020204" pitchFamily="34" charset="0"/>
+                          <a:cs typeface="Consolas" panose="020B0609020204030204" pitchFamily="49" charset="0"/>
+                        </a:rPr>
+                        <a:t>points to the home directory</a:t>
+                      </a:r>
+                    </a:p>
+                  </a:txBody>
+                  <a:tcPr>
+                    <a:lnT w="12700" cap="flat" cmpd="sng" algn="ctr">
+                      <a:solidFill>
+                        <a:schemeClr val="tx1"/>
+                      </a:solidFill>
+                      <a:prstDash val="solid"/>
+                      <a:round/>
+                      <a:headEnd type="none" w="med" len="med"/>
+                      <a:tailEnd type="none" w="med" len="med"/>
+                    </a:lnT>
+                  </a:tcPr>
+                </a:tc>
+                <a:extLst>
+                  <a:ext uri="{0D108BD9-81ED-4DB2-BD59-A6C34878D82A}">
+                    <a16:rowId xmlns:a16="http://schemas.microsoft.com/office/drawing/2014/main" val="1456704255"/>
+                  </a:ext>
+                </a:extLst>
+              </a:tr>
+              <a:tr h="475109">
+                <a:tc>
+                  <a:txBody>
+                    <a:bodyPr/>
+                    <a:lstStyle/>
+                    <a:p>
+                      <a:r>
+                        <a:rPr lang="en-US" sz="1600" b="0" dirty="0">
+                          <a:latin typeface="Consolas" panose="020B0609020204030204" pitchFamily="49" charset="0"/>
+                        </a:rPr>
+                        <a:t>$PWD</a:t>
+                      </a:r>
+                    </a:p>
+                  </a:txBody>
+                  <a:tcPr/>
+                </a:tc>
+                <a:tc>
+                  <a:txBody>
+                    <a:bodyPr/>
+                    <a:lstStyle/>
+                    <a:p>
+                      <a:r>
+                        <a:rPr lang="en-US" sz="1600" b="1" dirty="0">
+                          <a:latin typeface="Consolas" panose="020B0609020204030204" pitchFamily="49" charset="0"/>
+                        </a:rPr>
+                        <a:t>the current working directory (print working directory)</a:t>
+                      </a:r>
+                    </a:p>
+                  </a:txBody>
+                  <a:tcPr/>
+                </a:tc>
+                <a:extLst>
+                  <a:ext uri="{0D108BD9-81ED-4DB2-BD59-A6C34878D82A}">
+                    <a16:rowId xmlns:a16="http://schemas.microsoft.com/office/drawing/2014/main" val="236212215"/>
+                  </a:ext>
+                </a:extLst>
+              </a:tr>
+              <a:tr h="451648">
+                <a:tc>
+                  <a:txBody>
+                    <a:bodyPr/>
+                    <a:lstStyle/>
+                    <a:p>
+                      <a:r>
+                        <a:rPr lang="en-US" sz="1600" b="0" dirty="0">
+                          <a:latin typeface="Consolas" panose="020B0609020204030204" pitchFamily="49" charset="0"/>
+                        </a:rPr>
+                        <a:t>$SCRATCH</a:t>
+                      </a:r>
+                    </a:p>
+                  </a:txBody>
+                  <a:tcPr/>
+                </a:tc>
+                <a:tc>
+                  <a:txBody>
+                    <a:bodyPr/>
+                    <a:lstStyle/>
+                    <a:p>
+                      <a:r>
+                        <a:rPr lang="en-US" sz="1600" b="1" dirty="0">
+                          <a:latin typeface="Consolas" panose="020B0609020204030204" pitchFamily="49" charset="0"/>
+                          <a:ea typeface="Source Sans Pro" panose="020B0503030403020204" pitchFamily="34" charset="0"/>
+                        </a:rPr>
+                        <a:t>(on Cannon) points to the scratch directory</a:t>
+                      </a:r>
+                    </a:p>
+                  </a:txBody>
+                  <a:tcPr/>
+                </a:tc>
+                <a:extLst>
+                  <a:ext uri="{0D108BD9-81ED-4DB2-BD59-A6C34878D82A}">
+                    <a16:rowId xmlns:a16="http://schemas.microsoft.com/office/drawing/2014/main" val="2852715579"/>
+                  </a:ext>
+                </a:extLst>
+              </a:tr>
+              <a:tr h="451648">
+                <a:tc>
+                  <a:txBody>
+                    <a:bodyPr/>
+                    <a:lstStyle/>
+                    <a:p>
+                      <a:r>
+                        <a:rPr lang="en-US" sz="1600" b="0" dirty="0">
+                          <a:latin typeface="Consolas" panose="020B0609020204030204" pitchFamily="49" charset="0"/>
+                        </a:rPr>
+                        <a:t>$USER</a:t>
+                      </a:r>
+                    </a:p>
+                  </a:txBody>
+                  <a:tcPr/>
+                </a:tc>
+                <a:tc>
+                  <a:txBody>
+                    <a:bodyPr/>
+                    <a:lstStyle/>
+                    <a:p>
+                      <a:r>
+                        <a:rPr lang="en-US" sz="1600" b="1" dirty="0">
+                          <a:latin typeface="Consolas" panose="020B0609020204030204" pitchFamily="49" charset="0"/>
+                          <a:ea typeface="Source Sans Pro" panose="020B0503030403020204" pitchFamily="34" charset="0"/>
+                        </a:rPr>
+                        <a:t>prints the current user of the terminal</a:t>
+                      </a:r>
+                    </a:p>
+                  </a:txBody>
+                  <a:tcPr/>
+                </a:tc>
+                <a:extLst>
+                  <a:ext uri="{0D108BD9-81ED-4DB2-BD59-A6C34878D82A}">
+                    <a16:rowId xmlns:a16="http://schemas.microsoft.com/office/drawing/2014/main" val="496299667"/>
+                  </a:ext>
+                </a:extLst>
+              </a:tr>
+            </a:tbl>
+          </a:graphicData>
+        </a:graphic>
+      </p:graphicFrame>
+    </p:spTree>
+    <p:extLst>
+      <p:ext uri="{BB962C8B-B14F-4D97-AF65-F5344CB8AC3E}">
+        <p14:creationId xmlns:p14="http://schemas.microsoft.com/office/powerpoint/2010/main" val="234473224"/>
+      </p:ext>
+    </p:extLst>
+  </p:cSld>
+  <p:clrMapOvr>
+    <a:masterClrMapping/>
+  </p:clrMapOvr>
+</p:sld>
+</file>
+
+<file path=ppt/slides/slide6.xml><?xml version="1.0" encoding="utf-8"?>
+<p:sld xmlns:a="http://schemas.openxmlformats.org/drawingml/2006/main" xmlns:r="http://schemas.openxmlformats.org/officeDocument/2006/relationships" xmlns:p="http://schemas.openxmlformats.org/presentationml/2006/main">
+  <p:cSld>
+    <p:spTree>
+      <p:nvGrpSpPr>
+        <p:cNvPr id="1" name=""/>
+        <p:cNvGrpSpPr/>
+        <p:nvPr/>
+      </p:nvGrpSpPr>
+      <p:grpSpPr>
+        <a:xfrm>
+          <a:off x="0" y="0"/>
+          <a:ext cx="0" cy="0"/>
+          <a:chOff x="0" y="0"/>
+          <a:chExt cx="0" cy="0"/>
+        </a:xfrm>
+      </p:grpSpPr>
+      <p:sp>
+        <p:nvSpPr>
+          <p:cNvPr id="2" name="Title 1">
+            <a:extLst>
+              <a:ext uri="{FF2B5EF4-FFF2-40B4-BE49-F238E27FC236}">
+                <a16:creationId xmlns:a16="http://schemas.microsoft.com/office/drawing/2014/main" id="{0EE03133-4B55-6D63-00E8-2FADDAC347B6}"/>
+              </a:ext>
+            </a:extLst>
+          </p:cNvPr>
+          <p:cNvSpPr>
+            <a:spLocks noGrp="1"/>
+          </p:cNvSpPr>
+          <p:nvPr>
+            <p:ph type="title"/>
+          </p:nvPr>
+        </p:nvSpPr>
+        <p:spPr/>
+        <p:txBody>
+          <a:bodyPr/>
+          <a:lstStyle/>
+          <a:p>
+            <a:r>
+              <a:rPr lang="en-US" dirty="0"/>
+              <a:t>Environmental variables</a:t>
+            </a:r>
+          </a:p>
+        </p:txBody>
+      </p:sp>
+      <p:sp>
+        <p:nvSpPr>
+          <p:cNvPr id="3" name="Content Placeholder 2">
+            <a:extLst>
+              <a:ext uri="{FF2B5EF4-FFF2-40B4-BE49-F238E27FC236}">
+                <a16:creationId xmlns:a16="http://schemas.microsoft.com/office/drawing/2014/main" id="{633E4DD6-2D20-CB12-42C1-BE793AD1BCE9}"/>
+              </a:ext>
+            </a:extLst>
+          </p:cNvPr>
+          <p:cNvSpPr>
+            <a:spLocks noGrp="1"/>
+          </p:cNvSpPr>
+          <p:nvPr>
+            <p:ph idx="1"/>
+          </p:nvPr>
+        </p:nvSpPr>
+        <p:spPr/>
+        <p:txBody>
+          <a:bodyPr/>
+          <a:lstStyle/>
+          <a:p>
+            <a:r>
+              <a:rPr lang="en-US" dirty="0"/>
+              <a:t>When you type a command at the terminal and it executes, what is actually happening?</a:t>
+            </a:r>
+          </a:p>
+          <a:p>
+            <a:pPr lvl="1"/>
+            <a:r>
+              <a:rPr lang="en-US" dirty="0"/>
+              <a:t>E.g. `</a:t>
+            </a:r>
+            <a:r>
+              <a:rPr lang="en-US" dirty="0" err="1"/>
+              <a:t>ls`</a:t>
+            </a:r>
+            <a:endParaRPr lang="en-US" dirty="0"/>
+          </a:p>
+          <a:p>
+            <a:r>
+              <a:rPr lang="en-US" dirty="0"/>
+              <a:t>Or, when you type a command and you get a “command not found” error even </a:t>
+            </a:r>
+            <a:r>
+              <a:rPr lang="en-US" dirty="0" err="1"/>
+              <a:t>tho</a:t>
+            </a:r>
+            <a:r>
+              <a:rPr lang="en-US" dirty="0"/>
+              <a:t> you’ve installed it, why is that?</a:t>
+            </a:r>
+          </a:p>
+          <a:p>
+            <a:r>
+              <a:rPr lang="en-US" dirty="0"/>
+              <a:t>“Behind the scenes” the shell sets variables that contain important configuration data (paths to executables, </a:t>
+            </a:r>
+            <a:r>
+              <a:rPr lang="en-US" dirty="0" err="1"/>
+              <a:t>etc</a:t>
+            </a:r>
+            <a:r>
+              <a:rPr lang="en-US" dirty="0"/>
+              <a:t>)</a:t>
+            </a:r>
+          </a:p>
+          <a:p>
+            <a:r>
+              <a:rPr lang="en-US" b="1" i="1" dirty="0"/>
+              <a:t>Environmental variables </a:t>
+            </a:r>
+          </a:p>
+          <a:p>
+            <a:pPr lvl="1"/>
+            <a:r>
+              <a:rPr lang="en-US" dirty="0"/>
+              <a:t>Inherited by all child processes upon shell startup</a:t>
+            </a:r>
+          </a:p>
+        </p:txBody>
+      </p:sp>
+    </p:spTree>
+    <p:extLst>
+      <p:ext uri="{BB962C8B-B14F-4D97-AF65-F5344CB8AC3E}">
+        <p14:creationId xmlns:p14="http://schemas.microsoft.com/office/powerpoint/2010/main" val="258523420"/>
+      </p:ext>
+    </p:extLst>
+  </p:cSld>
+  <p:clrMapOvr>
+    <a:masterClrMapping/>
+  </p:clrMapOvr>
+</p:sld>
+</file>
+
+<file path=ppt/slides/slide7.xml><?xml version="1.0" encoding="utf-8"?>
+<p:sld xmlns:a="http://schemas.openxmlformats.org/drawingml/2006/main" xmlns:r="http://schemas.openxmlformats.org/officeDocument/2006/relationships" xmlns:p="http://schemas.openxmlformats.org/presentationml/2006/main">
+  <p:cSld>
+    <p:spTree>
+      <p:nvGrpSpPr>
         <p:cNvPr id="1" name=""/>
         <p:cNvGrpSpPr/>
         <p:nvPr/>
@@ -6252,7 +8955,7 @@
 </p:sld>
 </file>
 
-<file path=ppt/slides/slide4.xml><?xml version="1.0" encoding="utf-8"?>
+<file path=ppt/slides/slide8.xml><?xml version="1.0" encoding="utf-8"?>
 <p:sld xmlns:a="http://schemas.openxmlformats.org/drawingml/2006/main" xmlns:r="http://schemas.openxmlformats.org/officeDocument/2006/relationships" xmlns:p="http://schemas.openxmlformats.org/presentationml/2006/main">
   <p:cSld>
     <p:spTree>
@@ -6410,7 +9113,7 @@
 </p:sld>
 </file>
 
-<file path=ppt/slides/slide5.xml><?xml version="1.0" encoding="utf-8"?>
+<file path=ppt/slides/slide9.xml><?xml version="1.0" encoding="utf-8"?>
 <p:sld xmlns:a="http://schemas.openxmlformats.org/drawingml/2006/main" xmlns:r="http://schemas.openxmlformats.org/officeDocument/2006/relationships" xmlns:p="http://schemas.openxmlformats.org/presentationml/2006/main">
   <p:cSld>
     <p:spTree>
@@ -6553,602 +9256,6 @@
     <p:extLst>
       <p:ext uri="{BB962C8B-B14F-4D97-AF65-F5344CB8AC3E}">
         <p14:creationId xmlns:p14="http://schemas.microsoft.com/office/powerpoint/2010/main" val="1038812180"/>
-      </p:ext>
-    </p:extLst>
-  </p:cSld>
-  <p:clrMapOvr>
-    <a:masterClrMapping/>
-  </p:clrMapOvr>
-</p:sld>
-</file>
-
-<file path=ppt/slides/slide6.xml><?xml version="1.0" encoding="utf-8"?>
-<p:sld xmlns:a="http://schemas.openxmlformats.org/drawingml/2006/main" xmlns:r="http://schemas.openxmlformats.org/officeDocument/2006/relationships" xmlns:p="http://schemas.openxmlformats.org/presentationml/2006/main">
-  <p:cSld>
-    <p:spTree>
-      <p:nvGrpSpPr>
-        <p:cNvPr id="1" name="">
-          <a:extLst>
-            <a:ext uri="{FF2B5EF4-FFF2-40B4-BE49-F238E27FC236}">
-              <a16:creationId xmlns:a16="http://schemas.microsoft.com/office/drawing/2014/main" id="{518B08D6-F3C7-06FA-42A2-00E0F32F8F0B}"/>
-            </a:ext>
-          </a:extLst>
-        </p:cNvPr>
-        <p:cNvGrpSpPr/>
-        <p:nvPr/>
-      </p:nvGrpSpPr>
-      <p:grpSpPr>
-        <a:xfrm>
-          <a:off x="0" y="0"/>
-          <a:ext cx="0" cy="0"/>
-          <a:chOff x="0" y="0"/>
-          <a:chExt cx="0" cy="0"/>
-        </a:xfrm>
-      </p:grpSpPr>
-      <p:sp>
-        <p:nvSpPr>
-          <p:cNvPr id="2" name="Title 1">
-            <a:extLst>
-              <a:ext uri="{FF2B5EF4-FFF2-40B4-BE49-F238E27FC236}">
-                <a16:creationId xmlns:a16="http://schemas.microsoft.com/office/drawing/2014/main" id="{AF4104D0-701A-08BE-D0DC-1B8C1BBAD3A7}"/>
-              </a:ext>
-            </a:extLst>
-          </p:cNvPr>
-          <p:cNvSpPr>
-            <a:spLocks noGrp="1"/>
-          </p:cNvSpPr>
-          <p:nvPr>
-            <p:ph type="title"/>
-          </p:nvPr>
-        </p:nvSpPr>
-        <p:spPr/>
-        <p:txBody>
-          <a:bodyPr/>
-          <a:lstStyle/>
-          <a:p>
-            <a:r>
-              <a:rPr lang="en-US" dirty="0"/>
-              <a:t>Environmental variables</a:t>
-            </a:r>
-          </a:p>
-        </p:txBody>
-      </p:sp>
-      <p:sp>
-        <p:nvSpPr>
-          <p:cNvPr id="3" name="Content Placeholder 2">
-            <a:extLst>
-              <a:ext uri="{FF2B5EF4-FFF2-40B4-BE49-F238E27FC236}">
-                <a16:creationId xmlns:a16="http://schemas.microsoft.com/office/drawing/2014/main" id="{3D5DF8E9-0CB8-9BBB-791A-45A20C615DFD}"/>
-              </a:ext>
-            </a:extLst>
-          </p:cNvPr>
-          <p:cNvSpPr>
-            <a:spLocks noGrp="1"/>
-          </p:cNvSpPr>
-          <p:nvPr>
-            <p:ph idx="1"/>
-          </p:nvPr>
-        </p:nvSpPr>
-        <p:spPr>
-          <a:xfrm>
-            <a:off x="838200" y="1825624"/>
-            <a:ext cx="10515600" cy="4751445"/>
-          </a:xfrm>
-        </p:spPr>
-        <p:txBody>
-          <a:bodyPr/>
-          <a:lstStyle/>
-          <a:p>
-            <a:r>
-              <a:rPr lang="en-US" dirty="0"/>
-              <a:t>We can also add new variables to the shell:</a:t>
-            </a:r>
-          </a:p>
-          <a:p>
-            <a:pPr lvl="1"/>
-            <a:r>
-              <a:rPr lang="en-US" dirty="0"/>
-              <a:t>By convention, bash variables are named in uppercase</a:t>
-            </a:r>
-          </a:p>
-          <a:p>
-            <a:pPr lvl="1"/>
-            <a:r>
-              <a:rPr lang="en-US" dirty="0"/>
-              <a:t>`TEST=“hello there”`</a:t>
-            </a:r>
-          </a:p>
-          <a:p>
-            <a:pPr lvl="1"/>
-            <a:r>
-              <a:rPr lang="en-US" dirty="0"/>
-              <a:t>`echo $TEST`</a:t>
-            </a:r>
-          </a:p>
-          <a:p>
-            <a:r>
-              <a:rPr lang="en-US" dirty="0"/>
-              <a:t>IMPORTANT: what we did here was make a </a:t>
-            </a:r>
-            <a:r>
-              <a:rPr lang="en-US" i="1" dirty="0"/>
-              <a:t>shell variable</a:t>
-            </a:r>
-            <a:r>
-              <a:rPr lang="en-US" dirty="0"/>
-              <a:t>, not an environmental variable</a:t>
-            </a:r>
-          </a:p>
-          <a:p>
-            <a:r>
-              <a:rPr lang="en-US" dirty="0"/>
-              <a:t>What’s the difference??</a:t>
-            </a:r>
-          </a:p>
-        </p:txBody>
-      </p:sp>
-    </p:spTree>
-    <p:extLst>
-      <p:ext uri="{BB962C8B-B14F-4D97-AF65-F5344CB8AC3E}">
-        <p14:creationId xmlns:p14="http://schemas.microsoft.com/office/powerpoint/2010/main" val="3495916498"/>
-      </p:ext>
-    </p:extLst>
-  </p:cSld>
-  <p:clrMapOvr>
-    <a:masterClrMapping/>
-  </p:clrMapOvr>
-</p:sld>
-</file>
-
-<file path=ppt/slides/slide7.xml><?xml version="1.0" encoding="utf-8"?>
-<p:sld xmlns:a="http://schemas.openxmlformats.org/drawingml/2006/main" xmlns:r="http://schemas.openxmlformats.org/officeDocument/2006/relationships" xmlns:p="http://schemas.openxmlformats.org/presentationml/2006/main">
-  <p:cSld>
-    <p:spTree>
-      <p:nvGrpSpPr>
-        <p:cNvPr id="1" name="">
-          <a:extLst>
-            <a:ext uri="{FF2B5EF4-FFF2-40B4-BE49-F238E27FC236}">
-              <a16:creationId xmlns:a16="http://schemas.microsoft.com/office/drawing/2014/main" id="{9E2F3DED-A691-9BD8-F866-C62DC8FD4C02}"/>
-            </a:ext>
-          </a:extLst>
-        </p:cNvPr>
-        <p:cNvGrpSpPr/>
-        <p:nvPr/>
-      </p:nvGrpSpPr>
-      <p:grpSpPr>
-        <a:xfrm>
-          <a:off x="0" y="0"/>
-          <a:ext cx="0" cy="0"/>
-          <a:chOff x="0" y="0"/>
-          <a:chExt cx="0" cy="0"/>
-        </a:xfrm>
-      </p:grpSpPr>
-      <p:sp>
-        <p:nvSpPr>
-          <p:cNvPr id="2" name="Title 1">
-            <a:extLst>
-              <a:ext uri="{FF2B5EF4-FFF2-40B4-BE49-F238E27FC236}">
-                <a16:creationId xmlns:a16="http://schemas.microsoft.com/office/drawing/2014/main" id="{BEE41E7A-C141-5FC9-78AE-43E2B813EAB3}"/>
-              </a:ext>
-            </a:extLst>
-          </p:cNvPr>
-          <p:cNvSpPr>
-            <a:spLocks noGrp="1"/>
-          </p:cNvSpPr>
-          <p:nvPr>
-            <p:ph type="title"/>
-          </p:nvPr>
-        </p:nvSpPr>
-        <p:spPr/>
-        <p:txBody>
-          <a:bodyPr/>
-          <a:lstStyle/>
-          <a:p>
-            <a:r>
-              <a:rPr lang="en-US" dirty="0"/>
-              <a:t>Environmental variables</a:t>
-            </a:r>
-          </a:p>
-        </p:txBody>
-      </p:sp>
-      <p:sp>
-        <p:nvSpPr>
-          <p:cNvPr id="3" name="Content Placeholder 2">
-            <a:extLst>
-              <a:ext uri="{FF2B5EF4-FFF2-40B4-BE49-F238E27FC236}">
-                <a16:creationId xmlns:a16="http://schemas.microsoft.com/office/drawing/2014/main" id="{554551B4-0B44-C75B-0F64-E09B63DD2B58}"/>
-              </a:ext>
-            </a:extLst>
-          </p:cNvPr>
-          <p:cNvSpPr>
-            <a:spLocks noGrp="1"/>
-          </p:cNvSpPr>
-          <p:nvPr>
-            <p:ph idx="1"/>
-          </p:nvPr>
-        </p:nvSpPr>
-        <p:spPr>
-          <a:xfrm>
-            <a:off x="838200" y="1825624"/>
-            <a:ext cx="10515600" cy="4751445"/>
-          </a:xfrm>
-        </p:spPr>
-        <p:txBody>
-          <a:bodyPr/>
-          <a:lstStyle/>
-          <a:p>
-            <a:r>
-              <a:rPr lang="en-US" dirty="0"/>
-              <a:t>Environmental variables vs shell variables:</a:t>
-            </a:r>
-          </a:p>
-          <a:p>
-            <a:pPr lvl="1"/>
-            <a:r>
-              <a:rPr lang="en-US" dirty="0"/>
-              <a:t>Env variables are shared across all processes or programs created from the shell</a:t>
-            </a:r>
-          </a:p>
-          <a:p>
-            <a:pPr lvl="2"/>
-            <a:r>
-              <a:rPr lang="en-US" dirty="0"/>
-              <a:t>Can be “seen” by other programs</a:t>
-            </a:r>
-          </a:p>
-          <a:p>
-            <a:pPr lvl="1"/>
-            <a:r>
-              <a:rPr lang="en-US" dirty="0"/>
-              <a:t>Shell variables are local to only the shell; they aren’t “seen” by child processes</a:t>
-            </a:r>
-          </a:p>
-          <a:p>
-            <a:pPr lvl="2"/>
-            <a:r>
-              <a:rPr lang="en-US" dirty="0"/>
-              <a:t>E.g. if you ran a script that referenced a shell variable, it would not find it!</a:t>
-            </a:r>
-          </a:p>
-        </p:txBody>
-      </p:sp>
-    </p:spTree>
-    <p:extLst>
-      <p:ext uri="{BB962C8B-B14F-4D97-AF65-F5344CB8AC3E}">
-        <p14:creationId xmlns:p14="http://schemas.microsoft.com/office/powerpoint/2010/main" val="2920021287"/>
-      </p:ext>
-    </p:extLst>
-  </p:cSld>
-  <p:clrMapOvr>
-    <a:masterClrMapping/>
-  </p:clrMapOvr>
-</p:sld>
-</file>
-
-<file path=ppt/slides/slide8.xml><?xml version="1.0" encoding="utf-8"?>
-<p:sld xmlns:a="http://schemas.openxmlformats.org/drawingml/2006/main" xmlns:r="http://schemas.openxmlformats.org/officeDocument/2006/relationships" xmlns:p="http://schemas.openxmlformats.org/presentationml/2006/main">
-  <p:cSld>
-    <p:spTree>
-      <p:nvGrpSpPr>
-        <p:cNvPr id="1" name="">
-          <a:extLst>
-            <a:ext uri="{FF2B5EF4-FFF2-40B4-BE49-F238E27FC236}">
-              <a16:creationId xmlns:a16="http://schemas.microsoft.com/office/drawing/2014/main" id="{579C4F92-0A56-5631-4FF8-A0BAFB1B05F3}"/>
-            </a:ext>
-          </a:extLst>
-        </p:cNvPr>
-        <p:cNvGrpSpPr/>
-        <p:nvPr/>
-      </p:nvGrpSpPr>
-      <p:grpSpPr>
-        <a:xfrm>
-          <a:off x="0" y="0"/>
-          <a:ext cx="0" cy="0"/>
-          <a:chOff x="0" y="0"/>
-          <a:chExt cx="0" cy="0"/>
-        </a:xfrm>
-      </p:grpSpPr>
-      <p:sp>
-        <p:nvSpPr>
-          <p:cNvPr id="2" name="Title 1">
-            <a:extLst>
-              <a:ext uri="{FF2B5EF4-FFF2-40B4-BE49-F238E27FC236}">
-                <a16:creationId xmlns:a16="http://schemas.microsoft.com/office/drawing/2014/main" id="{4602EC34-AA03-A74A-1F25-873AB2339698}"/>
-              </a:ext>
-            </a:extLst>
-          </p:cNvPr>
-          <p:cNvSpPr>
-            <a:spLocks noGrp="1"/>
-          </p:cNvSpPr>
-          <p:nvPr>
-            <p:ph type="title"/>
-          </p:nvPr>
-        </p:nvSpPr>
-        <p:spPr/>
-        <p:txBody>
-          <a:bodyPr/>
-          <a:lstStyle/>
-          <a:p>
-            <a:r>
-              <a:rPr lang="en-US" dirty="0"/>
-              <a:t>Environmental variables</a:t>
-            </a:r>
-          </a:p>
-        </p:txBody>
-      </p:sp>
-      <p:sp>
-        <p:nvSpPr>
-          <p:cNvPr id="3" name="Content Placeholder 2">
-            <a:extLst>
-              <a:ext uri="{FF2B5EF4-FFF2-40B4-BE49-F238E27FC236}">
-                <a16:creationId xmlns:a16="http://schemas.microsoft.com/office/drawing/2014/main" id="{EAEF7D08-ADC1-12F9-6179-E29BDBF4820C}"/>
-              </a:ext>
-            </a:extLst>
-          </p:cNvPr>
-          <p:cNvSpPr>
-            <a:spLocks noGrp="1"/>
-          </p:cNvSpPr>
-          <p:nvPr>
-            <p:ph idx="1"/>
-          </p:nvPr>
-        </p:nvSpPr>
-        <p:spPr>
-          <a:xfrm>
-            <a:off x="838200" y="1825624"/>
-            <a:ext cx="10515600" cy="4751445"/>
-          </a:xfrm>
-        </p:spPr>
-        <p:txBody>
-          <a:bodyPr/>
-          <a:lstStyle/>
-          <a:p>
-            <a:r>
-              <a:rPr lang="en-US" dirty="0"/>
-              <a:t>`TEST=“</a:t>
-            </a:r>
-            <a:r>
-              <a:rPr lang="en-US" dirty="0" err="1"/>
-              <a:t>bingus</a:t>
-            </a:r>
-            <a:r>
-              <a:rPr lang="en-US" dirty="0"/>
-              <a:t>”`</a:t>
-            </a:r>
-          </a:p>
-          <a:p>
-            <a:r>
-              <a:rPr lang="en-US" dirty="0"/>
-              <a:t>`cat </a:t>
-            </a:r>
-            <a:r>
-              <a:rPr lang="en-US" dirty="0" err="1"/>
-              <a:t>print_test.sh</a:t>
-            </a:r>
-            <a:r>
-              <a:rPr lang="en-US" dirty="0"/>
-              <a:t>`</a:t>
-            </a:r>
-          </a:p>
-          <a:p>
-            <a:pPr lvl="1"/>
-            <a:r>
-              <a:rPr lang="en-US" dirty="0"/>
-              <a:t>`echo $TEST`</a:t>
-            </a:r>
-          </a:p>
-          <a:p>
-            <a:r>
-              <a:rPr lang="en-US" dirty="0"/>
-              <a:t>`</a:t>
-            </a:r>
-            <a:r>
-              <a:rPr lang="en-US" dirty="0" err="1"/>
-              <a:t>sh</a:t>
-            </a:r>
-            <a:r>
-              <a:rPr lang="en-US" dirty="0"/>
-              <a:t> </a:t>
-            </a:r>
-            <a:r>
-              <a:rPr lang="en-US" dirty="0" err="1"/>
-              <a:t>print_test.sh</a:t>
-            </a:r>
-            <a:r>
-              <a:rPr lang="en-US" dirty="0"/>
-              <a:t>` -&gt; no output!</a:t>
-            </a:r>
-          </a:p>
-          <a:p>
-            <a:r>
-              <a:rPr lang="en-US" dirty="0"/>
-              <a:t>This is because the `$TEST` variable only exists in the </a:t>
-            </a:r>
-            <a:r>
-              <a:rPr lang="en-US" b="1" dirty="0"/>
-              <a:t>shell</a:t>
-            </a:r>
-            <a:r>
-              <a:rPr lang="en-US" dirty="0"/>
-              <a:t>…any subprocesses (e.g. our `</a:t>
-            </a:r>
-            <a:r>
-              <a:rPr lang="en-US" dirty="0" err="1"/>
-              <a:t>print_test</a:t>
-            </a:r>
-            <a:r>
-              <a:rPr lang="en-US" dirty="0"/>
-              <a:t>` script) will not inherit it</a:t>
-            </a:r>
-          </a:p>
-          <a:p>
-            <a:r>
-              <a:rPr lang="en-US" dirty="0"/>
-              <a:t>We can convert shell variables to environmental variables!</a:t>
-            </a:r>
-          </a:p>
-          <a:p>
-            <a:pPr lvl="1"/>
-            <a:r>
-              <a:rPr lang="en-US" dirty="0"/>
-              <a:t>`export TEST`(note the lack of “$”!)</a:t>
-            </a:r>
-          </a:p>
-          <a:p>
-            <a:pPr lvl="1"/>
-            <a:r>
-              <a:rPr lang="en-US" dirty="0"/>
-              <a:t>Now we can run the script successfully</a:t>
-            </a:r>
-          </a:p>
-          <a:p>
-            <a:endParaRPr lang="en-US" dirty="0"/>
-          </a:p>
-        </p:txBody>
-      </p:sp>
-    </p:spTree>
-    <p:extLst>
-      <p:ext uri="{BB962C8B-B14F-4D97-AF65-F5344CB8AC3E}">
-        <p14:creationId xmlns:p14="http://schemas.microsoft.com/office/powerpoint/2010/main" val="285498298"/>
-      </p:ext>
-    </p:extLst>
-  </p:cSld>
-  <p:clrMapOvr>
-    <a:masterClrMapping/>
-  </p:clrMapOvr>
-</p:sld>
-</file>
-
-<file path=ppt/slides/slide9.xml><?xml version="1.0" encoding="utf-8"?>
-<p:sld xmlns:a="http://schemas.openxmlformats.org/drawingml/2006/main" xmlns:r="http://schemas.openxmlformats.org/officeDocument/2006/relationships" xmlns:p="http://schemas.openxmlformats.org/presentationml/2006/main">
-  <p:cSld>
-    <p:spTree>
-      <p:nvGrpSpPr>
-        <p:cNvPr id="1" name="">
-          <a:extLst>
-            <a:ext uri="{FF2B5EF4-FFF2-40B4-BE49-F238E27FC236}">
-              <a16:creationId xmlns:a16="http://schemas.microsoft.com/office/drawing/2014/main" id="{59C21B01-8498-55BA-4863-549119AED9FF}"/>
-            </a:ext>
-          </a:extLst>
-        </p:cNvPr>
-        <p:cNvGrpSpPr/>
-        <p:nvPr/>
-      </p:nvGrpSpPr>
-      <p:grpSpPr>
-        <a:xfrm>
-          <a:off x="0" y="0"/>
-          <a:ext cx="0" cy="0"/>
-          <a:chOff x="0" y="0"/>
-          <a:chExt cx="0" cy="0"/>
-        </a:xfrm>
-      </p:grpSpPr>
-      <p:sp>
-        <p:nvSpPr>
-          <p:cNvPr id="2" name="Title 1">
-            <a:extLst>
-              <a:ext uri="{FF2B5EF4-FFF2-40B4-BE49-F238E27FC236}">
-                <a16:creationId xmlns:a16="http://schemas.microsoft.com/office/drawing/2014/main" id="{83EC49CB-3EFF-1BEE-062E-85818E61D737}"/>
-              </a:ext>
-            </a:extLst>
-          </p:cNvPr>
-          <p:cNvSpPr>
-            <a:spLocks noGrp="1"/>
-          </p:cNvSpPr>
-          <p:nvPr>
-            <p:ph type="title"/>
-          </p:nvPr>
-        </p:nvSpPr>
-        <p:spPr/>
-        <p:txBody>
-          <a:bodyPr/>
-          <a:lstStyle/>
-          <a:p>
-            <a:r>
-              <a:rPr lang="en-US" dirty="0"/>
-              <a:t>Environmental variables</a:t>
-            </a:r>
-          </a:p>
-        </p:txBody>
-      </p:sp>
-      <p:sp>
-        <p:nvSpPr>
-          <p:cNvPr id="3" name="Content Placeholder 2">
-            <a:extLst>
-              <a:ext uri="{FF2B5EF4-FFF2-40B4-BE49-F238E27FC236}">
-                <a16:creationId xmlns:a16="http://schemas.microsoft.com/office/drawing/2014/main" id="{1CC9F031-8A9C-44AB-18A3-D0C83B59DAB0}"/>
-              </a:ext>
-            </a:extLst>
-          </p:cNvPr>
-          <p:cNvSpPr>
-            <a:spLocks noGrp="1"/>
-          </p:cNvSpPr>
-          <p:nvPr>
-            <p:ph idx="1"/>
-          </p:nvPr>
-        </p:nvSpPr>
-        <p:spPr>
-          <a:xfrm>
-            <a:off x="838200" y="1825624"/>
-            <a:ext cx="10515600" cy="4751445"/>
-          </a:xfrm>
-        </p:spPr>
-        <p:txBody>
-          <a:bodyPr/>
-          <a:lstStyle/>
-          <a:p>
-            <a:r>
-              <a:rPr lang="en-US" dirty="0"/>
-              <a:t>Another important consideration with env/shell variables…</a:t>
-            </a:r>
-          </a:p>
-          <a:p>
-            <a:r>
-              <a:rPr lang="en-US" dirty="0"/>
-              <a:t>Try making a variable: `TEST=“</a:t>
-            </a:r>
-            <a:r>
-              <a:rPr lang="en-US" dirty="0" err="1"/>
-              <a:t>bingus</a:t>
-            </a:r>
-            <a:r>
-              <a:rPr lang="en-US" dirty="0"/>
-              <a:t>”`</a:t>
-            </a:r>
-          </a:p>
-          <a:p>
-            <a:pPr lvl="1"/>
-            <a:r>
-              <a:rPr lang="en-US" dirty="0"/>
-              <a:t>`echo $TEST`</a:t>
-            </a:r>
-          </a:p>
-          <a:p>
-            <a:r>
-              <a:rPr lang="en-US" dirty="0"/>
-              <a:t>Now open a new terminal window…</a:t>
-            </a:r>
-          </a:p>
-          <a:p>
-            <a:pPr lvl="1"/>
-            <a:r>
-              <a:rPr lang="en-US" dirty="0"/>
-              <a:t>`echo $TEST`</a:t>
-            </a:r>
-          </a:p>
-          <a:p>
-            <a:r>
-              <a:rPr lang="en-US" dirty="0"/>
-              <a:t>Nothing happens! What’s going on…</a:t>
-            </a:r>
-          </a:p>
-          <a:p>
-            <a:endParaRPr lang="en-US" dirty="0"/>
-          </a:p>
-        </p:txBody>
-      </p:sp>
-    </p:spTree>
-    <p:extLst>
-      <p:ext uri="{BB962C8B-B14F-4D97-AF65-F5344CB8AC3E}">
-        <p14:creationId xmlns:p14="http://schemas.microsoft.com/office/powerpoint/2010/main" val="2057056715"/>
       </p:ext>
     </p:extLst>
   </p:cSld>

</xml_diff>